<commit_message>
update demo assets and dependencies
Co-Authored-By: Claude Opus 4.7 <noreply@anthropic.com>
</commit_message>
<xml_diff>
--- a/demo_video/演示文稿1.pptx
+++ b/demo_video/演示文稿1.pptx
@@ -5,14 +5,15 @@
     <p:sldMasterId id="2147483648" r:id="rId1"/>
   </p:sldMasterIdLst>
   <p:notesMasterIdLst>
-    <p:notesMasterId r:id="rId4"/>
+    <p:notesMasterId r:id="rId5"/>
   </p:notesMasterIdLst>
   <p:handoutMasterIdLst>
     <p:handoutMasterId r:id="rId6"/>
   </p:handoutMasterIdLst>
   <p:sldIdLst>
-    <p:sldId id="257" r:id="rId3"/>
-    <p:sldId id="258" r:id="rId5"/>
+    <p:sldId id="257" r:id="rId2"/>
+    <p:sldId id="258" r:id="rId3"/>
+    <p:sldId id="259" r:id="rId4"/>
   </p:sldIdLst>
   <p:sldSz cx="12192000" cy="6858000"/>
   <p:notesSz cx="6858000" cy="9144000"/>
@@ -126,6 +127,9 @@
         </p15:guide>
       </p15:sldGuideLst>
     </p:ext>
+    <p:ext uri="{2D200454-40CA-4A62-9FC3-DE9A4176ACB9}">
+      <p15:notesGuideLst xmlns:p15="http://schemas.microsoft.com/office/powerpoint/2012/main"/>
+    </p:ext>
   </p:extLst>
 </p:presentation>
 </file>
@@ -212,6 +216,7 @@
           <a:p>
             <a:fld id="{0F9B84EA-7D68-4D60-9CB1-D50884785D1C}" type="datetimeFigureOut">
               <a:rPr lang="zh-CN" altLang="en-US" smtClean="0"/>
+              <a:t>2026/6/13</a:t>
             </a:fld>
             <a:endParaRPr lang="zh-CN" altLang="en-US"/>
           </a:p>
@@ -277,12 +282,18 @@
           <a:p>
             <a:fld id="{8D4E0FC9-F1F8-4FAE-9988-3BA365CFD46F}" type="slidenum">
               <a:rPr lang="zh-CN" altLang="en-US" smtClean="0"/>
+              <a:t>‹#›</a:t>
             </a:fld>
             <a:endParaRPr lang="zh-CN" altLang="en-US"/>
           </a:p>
         </p:txBody>
       </p:sp>
     </p:spTree>
+    <p:extLst>
+      <p:ext uri="{BB962C8B-B14F-4D97-AF65-F5344CB8AC3E}">
+        <p14:creationId xmlns:p14="http://schemas.microsoft.com/office/powerpoint/2010/main" val="1"/>
+      </p:ext>
+    </p:extLst>
   </p:cSld>
   <p:clrMap bg1="lt1" tx1="dk1" bg2="lt2" tx2="dk2" accent1="accent1" accent2="accent2" accent3="accent3" accent4="accent4" accent5="accent5" accent6="accent6" hlink="hlink" folHlink="folHlink"/>
 </p:handoutMaster>
@@ -370,6 +381,7 @@
           <a:p>
             <a:fld id="{D2A48B96-639E-45A3-A0BA-2464DFDB1FAA}" type="datetimeFigureOut">
               <a:rPr lang="zh-CN" altLang="en-US" smtClean="0"/>
+              <a:t>2026/6/13</a:t>
             </a:fld>
             <a:endParaRPr lang="zh-CN" altLang="en-US"/>
           </a:p>
@@ -433,42 +445,37 @@
           <a:p>
             <a:pPr lvl="0"/>
             <a:r>
-              <a:rPr lang="zh-CN" altLang="en-US" smtClean="0"/>
+              <a:rPr lang="zh-CN" altLang="en-US"/>
               <a:t>单击此处编辑母版文本样式</a:t>
             </a:r>
-            <a:endParaRPr lang="zh-CN" altLang="en-US" smtClean="0"/>
           </a:p>
           <a:p>
             <a:pPr lvl="1"/>
             <a:r>
-              <a:rPr lang="zh-CN" altLang="en-US" smtClean="0"/>
+              <a:rPr lang="zh-CN" altLang="en-US"/>
               <a:t>第二级</a:t>
             </a:r>
-            <a:endParaRPr lang="zh-CN" altLang="en-US" smtClean="0"/>
           </a:p>
           <a:p>
             <a:pPr lvl="2"/>
             <a:r>
-              <a:rPr lang="zh-CN" altLang="en-US" smtClean="0"/>
+              <a:rPr lang="zh-CN" altLang="en-US"/>
               <a:t>第三级</a:t>
             </a:r>
-            <a:endParaRPr lang="zh-CN" altLang="en-US" smtClean="0"/>
           </a:p>
           <a:p>
             <a:pPr lvl="3"/>
             <a:r>
-              <a:rPr lang="zh-CN" altLang="en-US" smtClean="0"/>
+              <a:rPr lang="zh-CN" altLang="en-US"/>
               <a:t>第四级</a:t>
             </a:r>
-            <a:endParaRPr lang="zh-CN" altLang="en-US" smtClean="0"/>
           </a:p>
           <a:p>
             <a:pPr lvl="4"/>
             <a:r>
-              <a:rPr lang="zh-CN" altLang="en-US" smtClean="0"/>
+              <a:rPr lang="zh-CN" altLang="en-US"/>
               <a:t>第五级</a:t>
             </a:r>
-            <a:endParaRPr lang="zh-CN" altLang="en-US"/>
           </a:p>
         </p:txBody>
       </p:sp>
@@ -532,6 +539,7 @@
           <a:p>
             <a:fld id="{A6837353-30EB-4A48-80EB-173D804AEFBD}" type="slidenum">
               <a:rPr lang="zh-CN" altLang="en-US" smtClean="0"/>
+              <a:t>‹#›</a:t>
             </a:fld>
             <a:endParaRPr lang="zh-CN" altLang="en-US"/>
           </a:p>
@@ -644,12 +652,19 @@
         <p:cNvGrpSpPr/>
         <p:nvPr/>
       </p:nvGrpSpPr>
-      <p:grpSpPr/>
+      <p:grpSpPr>
+        <a:xfrm>
+          <a:off x="0" y="0"/>
+          <a:ext cx="0" cy="0"/>
+          <a:chOff x="0" y="0"/>
+          <a:chExt cx="0" cy="0"/>
+        </a:xfrm>
+      </p:grpSpPr>
       <p:sp>
         <p:nvSpPr>
           <p:cNvPr id="2" name="幻灯片图像占位符 1"/>
           <p:cNvSpPr>
-            <a:spLocks noGrp="1"/>
+            <a:spLocks noGrp="1" noRot="1" noChangeAspect="1"/>
           </p:cNvSpPr>
           <p:nvPr>
             <p:ph type="sldImg" idx="2"/>
@@ -670,6 +685,7 @@
         <p:spPr/>
         <p:txBody>
           <a:bodyPr/>
+          <a:lstStyle/>
           <a:p>
             <a:endParaRPr lang="zh-CN" altLang="en-US"/>
           </a:p>
@@ -692,12 +708,19 @@
         <p:cNvGrpSpPr/>
         <p:nvPr/>
       </p:nvGrpSpPr>
-      <p:grpSpPr/>
+      <p:grpSpPr>
+        <a:xfrm>
+          <a:off x="0" y="0"/>
+          <a:ext cx="0" cy="0"/>
+          <a:chOff x="0" y="0"/>
+          <a:chExt cx="0" cy="0"/>
+        </a:xfrm>
+      </p:grpSpPr>
       <p:sp>
         <p:nvSpPr>
           <p:cNvPr id="2" name="幻灯片图像占位符 1"/>
           <p:cNvSpPr>
-            <a:spLocks noGrp="1"/>
+            <a:spLocks noGrp="1" noRot="1" noChangeAspect="1"/>
           </p:cNvSpPr>
           <p:nvPr>
             <p:ph type="sldImg" idx="2"/>
@@ -718,6 +741,7 @@
         <p:spPr/>
         <p:txBody>
           <a:bodyPr/>
+          <a:lstStyle/>
           <a:p>
             <a:endParaRPr lang="zh-CN" altLang="en-US"/>
           </a:p>
@@ -757,7 +781,7 @@
           <p:nvPr>
             <p:ph type="ctrTitle"/>
             <p:custDataLst>
-              <p:tags r:id="rId2"/>
+              <p:tags r:id="rId1"/>
             </p:custDataLst>
           </p:nvPr>
         </p:nvSpPr>
@@ -781,7 +805,6 @@
               <a:rPr lang="zh-CN" altLang="en-US" dirty="0"/>
               <a:t>单击此处编辑母版标题样式</a:t>
             </a:r>
-            <a:endParaRPr lang="zh-CN" altLang="en-US" dirty="0"/>
           </a:p>
         </p:txBody>
       </p:sp>
@@ -794,7 +817,7 @@
           <p:nvPr>
             <p:ph type="subTitle" idx="1"/>
             <p:custDataLst>
-              <p:tags r:id="rId3"/>
+              <p:tags r:id="rId2"/>
             </p:custDataLst>
           </p:nvPr>
         </p:nvSpPr>
@@ -854,7 +877,6 @@
               <a:rPr lang="zh-CN" altLang="en-US" dirty="0"/>
               <a:t>单击此处编辑母版副标题样式</a:t>
             </a:r>
-            <a:endParaRPr lang="zh-CN" altLang="en-US" dirty="0"/>
           </a:p>
         </p:txBody>
       </p:sp>
@@ -866,6 +888,32 @@
           </p:cNvSpPr>
           <p:nvPr>
             <p:ph type="dt" sz="half" idx="10"/>
+            <p:custDataLst>
+              <p:tags r:id="rId3"/>
+            </p:custDataLst>
+          </p:nvPr>
+        </p:nvSpPr>
+        <p:spPr/>
+        <p:txBody>
+          <a:bodyPr/>
+          <a:lstStyle/>
+          <a:p>
+            <a:fld id="{760FBDFE-C587-4B4C-A407-44438C67B59E}" type="datetimeFigureOut">
+              <a:rPr lang="zh-CN" altLang="en-US" smtClean="0"/>
+              <a:t>2026/6/13</a:t>
+            </a:fld>
+            <a:endParaRPr lang="zh-CN" altLang="en-US"/>
+          </a:p>
+        </p:txBody>
+      </p:sp>
+      <p:sp>
+        <p:nvSpPr>
+          <p:cNvPr id="17" name="页脚占位符 16"/>
+          <p:cNvSpPr>
+            <a:spLocks noGrp="1"/>
+          </p:cNvSpPr>
+          <p:nvPr>
+            <p:ph type="ftr" sz="quarter" idx="11"/>
             <p:custDataLst>
               <p:tags r:id="rId4"/>
             </p:custDataLst>
@@ -876,21 +924,18 @@
           <a:bodyPr/>
           <a:lstStyle/>
           <a:p>
-            <a:fld id="{760FBDFE-C587-4B4C-A407-44438C67B59E}" type="datetimeFigureOut">
-              <a:rPr lang="zh-CN" altLang="en-US" smtClean="0"/>
-            </a:fld>
-            <a:endParaRPr lang="zh-CN" altLang="en-US"/>
-          </a:p>
-        </p:txBody>
-      </p:sp>
-      <p:sp>
-        <p:nvSpPr>
-          <p:cNvPr id="17" name="页脚占位符 16"/>
-          <p:cNvSpPr>
-            <a:spLocks noGrp="1"/>
-          </p:cNvSpPr>
-          <p:nvPr>
-            <p:ph type="ftr" sz="quarter" idx="11"/>
+            <a:endParaRPr lang="zh-CN" altLang="en-US" dirty="0"/>
+          </a:p>
+        </p:txBody>
+      </p:sp>
+      <p:sp>
+        <p:nvSpPr>
+          <p:cNvPr id="18" name="灯片编号占位符 17"/>
+          <p:cNvSpPr>
+            <a:spLocks noGrp="1"/>
+          </p:cNvSpPr>
+          <p:nvPr>
+            <p:ph type="sldNum" sz="quarter" idx="12"/>
             <p:custDataLst>
               <p:tags r:id="rId5"/>
             </p:custDataLst>
@@ -901,30 +946,9 @@
           <a:bodyPr/>
           <a:lstStyle/>
           <a:p>
-            <a:endParaRPr lang="zh-CN" altLang="en-US" dirty="0"/>
-          </a:p>
-        </p:txBody>
-      </p:sp>
-      <p:sp>
-        <p:nvSpPr>
-          <p:cNvPr id="18" name="灯片编号占位符 17"/>
-          <p:cNvSpPr>
-            <a:spLocks noGrp="1"/>
-          </p:cNvSpPr>
-          <p:nvPr>
-            <p:ph type="sldNum" sz="quarter" idx="12"/>
-            <p:custDataLst>
-              <p:tags r:id="rId6"/>
-            </p:custDataLst>
-          </p:nvPr>
-        </p:nvSpPr>
-        <p:spPr/>
-        <p:txBody>
-          <a:bodyPr/>
-          <a:lstStyle/>
-          <a:p>
             <a:fld id="{49AE70B2-8BF9-45C0-BB95-33D1B9D3A854}" type="slidenum">
               <a:rPr lang="zh-CN" altLang="en-US" smtClean="0"/>
+              <a:t>‹#›</a:t>
             </a:fld>
             <a:endParaRPr lang="zh-CN" altLang="en-US" dirty="0"/>
           </a:p>
@@ -964,6 +988,32 @@
           <p:nvPr>
             <p:ph type="dt" sz="half" idx="10"/>
             <p:custDataLst>
+              <p:tags r:id="rId1"/>
+            </p:custDataLst>
+          </p:nvPr>
+        </p:nvSpPr>
+        <p:spPr/>
+        <p:txBody>
+          <a:bodyPr/>
+          <a:lstStyle/>
+          <a:p>
+            <a:fld id="{760FBDFE-C587-4B4C-A407-44438C67B59E}" type="datetimeFigureOut">
+              <a:rPr lang="zh-CN" altLang="en-US" smtClean="0"/>
+              <a:t>2026/6/13</a:t>
+            </a:fld>
+            <a:endParaRPr lang="zh-CN" altLang="en-US"/>
+          </a:p>
+        </p:txBody>
+      </p:sp>
+      <p:sp>
+        <p:nvSpPr>
+          <p:cNvPr id="4" name="页脚占位符 3"/>
+          <p:cNvSpPr>
+            <a:spLocks noGrp="1"/>
+          </p:cNvSpPr>
+          <p:nvPr>
+            <p:ph type="ftr" sz="quarter" idx="11"/>
+            <p:custDataLst>
               <p:tags r:id="rId2"/>
             </p:custDataLst>
           </p:nvPr>
@@ -973,21 +1023,18 @@
           <a:bodyPr/>
           <a:lstStyle/>
           <a:p>
-            <a:fld id="{760FBDFE-C587-4B4C-A407-44438C67B59E}" type="datetimeFigureOut">
-              <a:rPr lang="zh-CN" altLang="en-US" smtClean="0"/>
-            </a:fld>
             <a:endParaRPr lang="zh-CN" altLang="en-US"/>
           </a:p>
         </p:txBody>
       </p:sp>
       <p:sp>
         <p:nvSpPr>
-          <p:cNvPr id="4" name="页脚占位符 3"/>
-          <p:cNvSpPr>
-            <a:spLocks noGrp="1"/>
-          </p:cNvSpPr>
-          <p:nvPr>
-            <p:ph type="ftr" sz="quarter" idx="11"/>
+          <p:cNvPr id="5" name="灯片编号占位符 4"/>
+          <p:cNvSpPr>
+            <a:spLocks noGrp="1"/>
+          </p:cNvSpPr>
+          <p:nvPr>
+            <p:ph type="sldNum" sz="quarter" idx="12"/>
             <p:custDataLst>
               <p:tags r:id="rId3"/>
             </p:custDataLst>
@@ -998,45 +1045,24 @@
           <a:bodyPr/>
           <a:lstStyle/>
           <a:p>
+            <a:fld id="{49AE70B2-8BF9-45C0-BB95-33D1B9D3A854}" type="slidenum">
+              <a:rPr lang="zh-CN" altLang="en-US" smtClean="0"/>
+              <a:t>‹#›</a:t>
+            </a:fld>
             <a:endParaRPr lang="zh-CN" altLang="en-US"/>
           </a:p>
         </p:txBody>
       </p:sp>
       <p:sp>
         <p:nvSpPr>
-          <p:cNvPr id="5" name="灯片编号占位符 4"/>
-          <p:cNvSpPr>
-            <a:spLocks noGrp="1"/>
-          </p:cNvSpPr>
-          <p:nvPr>
-            <p:ph type="sldNum" sz="quarter" idx="12"/>
+          <p:cNvPr id="7" name="内容占位符 6"/>
+          <p:cNvSpPr>
+            <a:spLocks noGrp="1"/>
+          </p:cNvSpPr>
+          <p:nvPr>
+            <p:ph sz="quarter" idx="13"/>
             <p:custDataLst>
               <p:tags r:id="rId4"/>
-            </p:custDataLst>
-          </p:nvPr>
-        </p:nvSpPr>
-        <p:spPr/>
-        <p:txBody>
-          <a:bodyPr/>
-          <a:lstStyle/>
-          <a:p>
-            <a:fld id="{49AE70B2-8BF9-45C0-BB95-33D1B9D3A854}" type="slidenum">
-              <a:rPr lang="zh-CN" altLang="en-US" smtClean="0"/>
-            </a:fld>
-            <a:endParaRPr lang="zh-CN" altLang="en-US"/>
-          </a:p>
-        </p:txBody>
-      </p:sp>
-      <p:sp>
-        <p:nvSpPr>
-          <p:cNvPr id="7" name="内容占位符 6"/>
-          <p:cNvSpPr>
-            <a:spLocks noGrp="1"/>
-          </p:cNvSpPr>
-          <p:nvPr>
-            <p:ph sz="quarter" idx="13"/>
-            <p:custDataLst>
-              <p:tags r:id="rId5"/>
             </p:custDataLst>
           </p:nvPr>
         </p:nvSpPr>
@@ -1055,7 +1081,6 @@
               <a:rPr lang="zh-CN" altLang="en-US" dirty="0"/>
               <a:t>单击此处编辑母版文本样式</a:t>
             </a:r>
-            <a:endParaRPr lang="zh-CN" altLang="en-US" dirty="0"/>
           </a:p>
           <a:p>
             <a:pPr lvl="1"/>
@@ -1063,7 +1088,6 @@
               <a:rPr lang="zh-CN" altLang="en-US" dirty="0"/>
               <a:t>第二级</a:t>
             </a:r>
-            <a:endParaRPr lang="zh-CN" altLang="en-US" dirty="0"/>
           </a:p>
           <a:p>
             <a:pPr lvl="2"/>
@@ -1071,7 +1095,6 @@
               <a:rPr lang="zh-CN" altLang="en-US" dirty="0"/>
               <a:t>第三级</a:t>
             </a:r>
-            <a:endParaRPr lang="zh-CN" altLang="en-US" dirty="0"/>
           </a:p>
           <a:p>
             <a:pPr lvl="3"/>
@@ -1079,7 +1102,6 @@
               <a:rPr lang="zh-CN" altLang="en-US" dirty="0"/>
               <a:t>第四级</a:t>
             </a:r>
-            <a:endParaRPr lang="zh-CN" altLang="en-US" dirty="0"/>
           </a:p>
           <a:p>
             <a:pPr lvl="4"/>
@@ -1087,7 +1109,6 @@
               <a:rPr lang="zh-CN" altLang="en-US" dirty="0"/>
               <a:t>第五级</a:t>
             </a:r>
-            <a:endParaRPr lang="zh-CN" altLang="en-US" dirty="0"/>
           </a:p>
         </p:txBody>
       </p:sp>
@@ -1125,6 +1146,32 @@
           <p:nvPr>
             <p:ph type="dt" sz="half" idx="10"/>
             <p:custDataLst>
+              <p:tags r:id="rId1"/>
+            </p:custDataLst>
+          </p:nvPr>
+        </p:nvSpPr>
+        <p:spPr/>
+        <p:txBody>
+          <a:bodyPr/>
+          <a:lstStyle/>
+          <a:p>
+            <a:fld id="{760FBDFE-C587-4B4C-A407-44438C67B59E}" type="datetimeFigureOut">
+              <a:rPr lang="zh-CN" altLang="en-US" smtClean="0"/>
+              <a:t>2026/6/13</a:t>
+            </a:fld>
+            <a:endParaRPr lang="zh-CN" altLang="en-US"/>
+          </a:p>
+        </p:txBody>
+      </p:sp>
+      <p:sp>
+        <p:nvSpPr>
+          <p:cNvPr id="4" name="页脚占位符 3"/>
+          <p:cNvSpPr>
+            <a:spLocks noGrp="1"/>
+          </p:cNvSpPr>
+          <p:nvPr>
+            <p:ph type="ftr" sz="quarter" idx="11"/>
+            <p:custDataLst>
               <p:tags r:id="rId2"/>
             </p:custDataLst>
           </p:nvPr>
@@ -1134,21 +1181,18 @@
           <a:bodyPr/>
           <a:lstStyle/>
           <a:p>
-            <a:fld id="{760FBDFE-C587-4B4C-A407-44438C67B59E}" type="datetimeFigureOut">
-              <a:rPr lang="zh-CN" altLang="en-US" smtClean="0"/>
-            </a:fld>
             <a:endParaRPr lang="zh-CN" altLang="en-US"/>
           </a:p>
         </p:txBody>
       </p:sp>
       <p:sp>
         <p:nvSpPr>
-          <p:cNvPr id="4" name="页脚占位符 3"/>
-          <p:cNvSpPr>
-            <a:spLocks noGrp="1"/>
-          </p:cNvSpPr>
-          <p:nvPr>
-            <p:ph type="ftr" sz="quarter" idx="11"/>
+          <p:cNvPr id="5" name="灯片编号占位符 4"/>
+          <p:cNvSpPr>
+            <a:spLocks noGrp="1"/>
+          </p:cNvSpPr>
+          <p:nvPr>
+            <p:ph type="sldNum" sz="quarter" idx="12"/>
             <p:custDataLst>
               <p:tags r:id="rId3"/>
             </p:custDataLst>
@@ -1159,45 +1203,24 @@
           <a:bodyPr/>
           <a:lstStyle/>
           <a:p>
+            <a:fld id="{49AE70B2-8BF9-45C0-BB95-33D1B9D3A854}" type="slidenum">
+              <a:rPr lang="zh-CN" altLang="en-US" smtClean="0"/>
+              <a:t>‹#›</a:t>
+            </a:fld>
             <a:endParaRPr lang="zh-CN" altLang="en-US"/>
           </a:p>
         </p:txBody>
       </p:sp>
       <p:sp>
         <p:nvSpPr>
-          <p:cNvPr id="5" name="灯片编号占位符 4"/>
-          <p:cNvSpPr>
-            <a:spLocks noGrp="1"/>
-          </p:cNvSpPr>
-          <p:nvPr>
-            <p:ph type="sldNum" sz="quarter" idx="12"/>
+          <p:cNvPr id="2" name="标题 1"/>
+          <p:cNvSpPr>
+            <a:spLocks noGrp="1"/>
+          </p:cNvSpPr>
+          <p:nvPr>
+            <p:ph type="title" hasCustomPrompt="1"/>
             <p:custDataLst>
               <p:tags r:id="rId4"/>
-            </p:custDataLst>
-          </p:nvPr>
-        </p:nvSpPr>
-        <p:spPr/>
-        <p:txBody>
-          <a:bodyPr/>
-          <a:lstStyle/>
-          <a:p>
-            <a:fld id="{49AE70B2-8BF9-45C0-BB95-33D1B9D3A854}" type="slidenum">
-              <a:rPr lang="zh-CN" altLang="en-US" smtClean="0"/>
-            </a:fld>
-            <a:endParaRPr lang="zh-CN" altLang="en-US"/>
-          </a:p>
-        </p:txBody>
-      </p:sp>
-      <p:sp>
-        <p:nvSpPr>
-          <p:cNvPr id="2" name="标题 1"/>
-          <p:cNvSpPr>
-            <a:spLocks noGrp="1"/>
-          </p:cNvSpPr>
-          <p:nvPr>
-            <p:ph type="title" hasCustomPrompt="1"/>
-            <p:custDataLst>
-              <p:tags r:id="rId5"/>
             </p:custDataLst>
           </p:nvPr>
         </p:nvSpPr>
@@ -1219,10 +1242,9 @@
           <a:p>
             <a:pPr lvl="0"/>
             <a:r>
-              <a:rPr lang="zh-CN" altLang="en-US" smtClean="0"/>
+              <a:rPr lang="zh-CN" altLang="en-US"/>
               <a:t>单击此处编辑标题</a:t>
             </a:r>
-            <a:endParaRPr lang="zh-CN" altLang="en-US"/>
           </a:p>
         </p:txBody>
       </p:sp>
@@ -1235,7 +1257,7 @@
           <p:nvPr>
             <p:ph type="body" sz="quarter" idx="13"/>
             <p:custDataLst>
-              <p:tags r:id="rId6"/>
+              <p:tags r:id="rId5"/>
             </p:custDataLst>
           </p:nvPr>
         </p:nvSpPr>
@@ -1264,7 +1286,6 @@
               <a:rPr lang="zh-CN" altLang="en-US" dirty="0"/>
               <a:t>单击此处编辑母版文本样式</a:t>
             </a:r>
-            <a:endParaRPr lang="zh-CN" altLang="en-US" dirty="0"/>
           </a:p>
         </p:txBody>
       </p:sp>
@@ -1302,7 +1323,7 @@
           <p:nvPr>
             <p:ph type="title"/>
             <p:custDataLst>
-              <p:tags r:id="rId2"/>
+              <p:tags r:id="rId1"/>
             </p:custDataLst>
           </p:nvPr>
         </p:nvSpPr>
@@ -1320,10 +1341,9 @@
           <a:p>
             <a:pPr lvl="0"/>
             <a:r>
-              <a:rPr lang="zh-CN" altLang="en-US" smtClean="0"/>
+              <a:rPr lang="zh-CN" altLang="en-US"/>
               <a:t>单击此处编辑母版标题样式</a:t>
             </a:r>
-            <a:endParaRPr lang="zh-CN" altLang="en-US"/>
           </a:p>
         </p:txBody>
       </p:sp>
@@ -1336,7 +1356,7 @@
           <p:nvPr>
             <p:ph idx="1"/>
             <p:custDataLst>
-              <p:tags r:id="rId3"/>
+              <p:tags r:id="rId2"/>
             </p:custDataLst>
           </p:nvPr>
         </p:nvSpPr>
@@ -1354,53 +1374,74 @@
           <a:p>
             <a:pPr lvl="0"/>
             <a:r>
-              <a:rPr lang="zh-CN" altLang="en-US" smtClean="0"/>
+              <a:rPr lang="zh-CN" altLang="en-US"/>
               <a:t>单击此处编辑母版文本样式</a:t>
             </a:r>
-            <a:endParaRPr lang="zh-CN" altLang="en-US" smtClean="0"/>
           </a:p>
           <a:p>
             <a:pPr lvl="1"/>
             <a:r>
-              <a:rPr lang="zh-CN" altLang="en-US" smtClean="0"/>
+              <a:rPr lang="zh-CN" altLang="en-US"/>
               <a:t>第二级</a:t>
             </a:r>
-            <a:endParaRPr lang="zh-CN" altLang="en-US" smtClean="0"/>
           </a:p>
           <a:p>
             <a:pPr lvl="2"/>
             <a:r>
-              <a:rPr lang="zh-CN" altLang="en-US" smtClean="0"/>
+              <a:rPr lang="zh-CN" altLang="en-US"/>
               <a:t>第三级</a:t>
             </a:r>
-            <a:endParaRPr lang="zh-CN" altLang="en-US" smtClean="0"/>
           </a:p>
           <a:p>
             <a:pPr lvl="3"/>
             <a:r>
-              <a:rPr lang="zh-CN" altLang="en-US" smtClean="0"/>
+              <a:rPr lang="zh-CN" altLang="en-US"/>
               <a:t>第四级</a:t>
             </a:r>
-            <a:endParaRPr lang="zh-CN" altLang="en-US" smtClean="0"/>
           </a:p>
           <a:p>
             <a:pPr lvl="4"/>
             <a:r>
-              <a:rPr lang="zh-CN" altLang="en-US" smtClean="0"/>
+              <a:rPr lang="zh-CN" altLang="en-US"/>
               <a:t>第五级</a:t>
             </a:r>
+          </a:p>
+        </p:txBody>
+      </p:sp>
+      <p:sp>
+        <p:nvSpPr>
+          <p:cNvPr id="4" name="日期占位符 3"/>
+          <p:cNvSpPr>
+            <a:spLocks noGrp="1"/>
+          </p:cNvSpPr>
+          <p:nvPr>
+            <p:ph type="dt" sz="half" idx="10"/>
+            <p:custDataLst>
+              <p:tags r:id="rId3"/>
+            </p:custDataLst>
+          </p:nvPr>
+        </p:nvSpPr>
+        <p:spPr/>
+        <p:txBody>
+          <a:bodyPr/>
+          <a:lstStyle/>
+          <a:p>
+            <a:fld id="{760FBDFE-C587-4B4C-A407-44438C67B59E}" type="datetimeFigureOut">
+              <a:rPr lang="zh-CN" altLang="en-US" smtClean="0"/>
+              <a:t>2026/6/13</a:t>
+            </a:fld>
             <a:endParaRPr lang="zh-CN" altLang="en-US"/>
           </a:p>
         </p:txBody>
       </p:sp>
       <p:sp>
         <p:nvSpPr>
-          <p:cNvPr id="4" name="日期占位符 3"/>
-          <p:cNvSpPr>
-            <a:spLocks noGrp="1"/>
-          </p:cNvSpPr>
-          <p:nvPr>
-            <p:ph type="dt" sz="half" idx="10"/>
+          <p:cNvPr id="5" name="页脚占位符 4"/>
+          <p:cNvSpPr>
+            <a:spLocks noGrp="1"/>
+          </p:cNvSpPr>
+          <p:nvPr>
+            <p:ph type="ftr" sz="quarter" idx="11"/>
             <p:custDataLst>
               <p:tags r:id="rId4"/>
             </p:custDataLst>
@@ -1411,21 +1452,18 @@
           <a:bodyPr/>
           <a:lstStyle/>
           <a:p>
-            <a:fld id="{760FBDFE-C587-4B4C-A407-44438C67B59E}" type="datetimeFigureOut">
-              <a:rPr lang="zh-CN" altLang="en-US" smtClean="0"/>
-            </a:fld>
             <a:endParaRPr lang="zh-CN" altLang="en-US"/>
           </a:p>
         </p:txBody>
       </p:sp>
       <p:sp>
         <p:nvSpPr>
-          <p:cNvPr id="5" name="页脚占位符 4"/>
-          <p:cNvSpPr>
-            <a:spLocks noGrp="1"/>
-          </p:cNvSpPr>
-          <p:nvPr>
-            <p:ph type="ftr" sz="quarter" idx="11"/>
+          <p:cNvPr id="6" name="灯片编号占位符 5"/>
+          <p:cNvSpPr>
+            <a:spLocks noGrp="1"/>
+          </p:cNvSpPr>
+          <p:nvPr>
+            <p:ph type="sldNum" sz="quarter" idx="12"/>
             <p:custDataLst>
               <p:tags r:id="rId5"/>
             </p:custDataLst>
@@ -1436,30 +1474,9 @@
           <a:bodyPr/>
           <a:lstStyle/>
           <a:p>
-            <a:endParaRPr lang="zh-CN" altLang="en-US"/>
-          </a:p>
-        </p:txBody>
-      </p:sp>
-      <p:sp>
-        <p:nvSpPr>
-          <p:cNvPr id="6" name="灯片编号占位符 5"/>
-          <p:cNvSpPr>
-            <a:spLocks noGrp="1"/>
-          </p:cNvSpPr>
-          <p:nvPr>
-            <p:ph type="sldNum" sz="quarter" idx="12"/>
-            <p:custDataLst>
-              <p:tags r:id="rId6"/>
-            </p:custDataLst>
-          </p:nvPr>
-        </p:nvSpPr>
-        <p:spPr/>
-        <p:txBody>
-          <a:bodyPr/>
-          <a:lstStyle/>
-          <a:p>
             <a:fld id="{49AE70B2-8BF9-45C0-BB95-33D1B9D3A854}" type="slidenum">
               <a:rPr lang="zh-CN" altLang="en-US" smtClean="0"/>
+              <a:t>‹#›</a:t>
             </a:fld>
             <a:endParaRPr lang="zh-CN" altLang="en-US"/>
           </a:p>
@@ -1499,7 +1516,7 @@
           <p:nvPr>
             <p:ph type="title" hasCustomPrompt="1"/>
             <p:custDataLst>
-              <p:tags r:id="rId2"/>
+              <p:tags r:id="rId1"/>
             </p:custDataLst>
           </p:nvPr>
         </p:nvSpPr>
@@ -1523,7 +1540,6 @@
               <a:rPr lang="zh-CN" altLang="en-US" dirty="0"/>
               <a:t>单击此处编辑标题</a:t>
             </a:r>
-            <a:endParaRPr lang="zh-CN" altLang="en-US" dirty="0"/>
           </a:p>
         </p:txBody>
       </p:sp>
@@ -1536,7 +1552,7 @@
           <p:nvPr>
             <p:ph type="body" idx="1" hasCustomPrompt="1"/>
             <p:custDataLst>
-              <p:tags r:id="rId3"/>
+              <p:tags r:id="rId2"/>
             </p:custDataLst>
           </p:nvPr>
         </p:nvSpPr>
@@ -1649,7 +1665,6 @@
               <a:rPr lang="zh-CN" altLang="en-US" dirty="0"/>
               <a:t>单击此处编辑文本</a:t>
             </a:r>
-            <a:endParaRPr lang="zh-CN" altLang="en-US" dirty="0"/>
           </a:p>
         </p:txBody>
       </p:sp>
@@ -1661,6 +1676,32 @@
           </p:cNvSpPr>
           <p:nvPr>
             <p:ph type="dt" sz="half" idx="10"/>
+            <p:custDataLst>
+              <p:tags r:id="rId3"/>
+            </p:custDataLst>
+          </p:nvPr>
+        </p:nvSpPr>
+        <p:spPr/>
+        <p:txBody>
+          <a:bodyPr/>
+          <a:lstStyle/>
+          <a:p>
+            <a:fld id="{760FBDFE-C587-4B4C-A407-44438C67B59E}" type="datetimeFigureOut">
+              <a:rPr lang="zh-CN" altLang="en-US" smtClean="0"/>
+              <a:t>2026/6/13</a:t>
+            </a:fld>
+            <a:endParaRPr lang="zh-CN" altLang="en-US"/>
+          </a:p>
+        </p:txBody>
+      </p:sp>
+      <p:sp>
+        <p:nvSpPr>
+          <p:cNvPr id="5" name="页脚占位符 4"/>
+          <p:cNvSpPr>
+            <a:spLocks noGrp="1"/>
+          </p:cNvSpPr>
+          <p:nvPr>
+            <p:ph type="ftr" sz="quarter" idx="11"/>
             <p:custDataLst>
               <p:tags r:id="rId4"/>
             </p:custDataLst>
@@ -1671,21 +1712,18 @@
           <a:bodyPr/>
           <a:lstStyle/>
           <a:p>
-            <a:fld id="{760FBDFE-C587-4B4C-A407-44438C67B59E}" type="datetimeFigureOut">
-              <a:rPr lang="zh-CN" altLang="en-US" smtClean="0"/>
-            </a:fld>
             <a:endParaRPr lang="zh-CN" altLang="en-US"/>
           </a:p>
         </p:txBody>
       </p:sp>
       <p:sp>
         <p:nvSpPr>
-          <p:cNvPr id="5" name="页脚占位符 4"/>
-          <p:cNvSpPr>
-            <a:spLocks noGrp="1"/>
-          </p:cNvSpPr>
-          <p:nvPr>
-            <p:ph type="ftr" sz="quarter" idx="11"/>
+          <p:cNvPr id="6" name="灯片编号占位符 5"/>
+          <p:cNvSpPr>
+            <a:spLocks noGrp="1"/>
+          </p:cNvSpPr>
+          <p:nvPr>
+            <p:ph type="sldNum" sz="quarter" idx="12"/>
             <p:custDataLst>
               <p:tags r:id="rId5"/>
             </p:custDataLst>
@@ -1696,30 +1734,9 @@
           <a:bodyPr/>
           <a:lstStyle/>
           <a:p>
-            <a:endParaRPr lang="zh-CN" altLang="en-US"/>
-          </a:p>
-        </p:txBody>
-      </p:sp>
-      <p:sp>
-        <p:nvSpPr>
-          <p:cNvPr id="6" name="灯片编号占位符 5"/>
-          <p:cNvSpPr>
-            <a:spLocks noGrp="1"/>
-          </p:cNvSpPr>
-          <p:nvPr>
-            <p:ph type="sldNum" sz="quarter" idx="12"/>
-            <p:custDataLst>
-              <p:tags r:id="rId6"/>
-            </p:custDataLst>
-          </p:nvPr>
-        </p:nvSpPr>
-        <p:spPr/>
-        <p:txBody>
-          <a:bodyPr/>
-          <a:lstStyle/>
-          <a:p>
             <a:fld id="{49AE70B2-8BF9-45C0-BB95-33D1B9D3A854}" type="slidenum">
               <a:rPr lang="zh-CN" altLang="en-US" smtClean="0"/>
+              <a:t>‹#›</a:t>
             </a:fld>
             <a:endParaRPr lang="zh-CN" altLang="en-US"/>
           </a:p>
@@ -1759,7 +1776,7 @@
           <p:nvPr>
             <p:ph type="title"/>
             <p:custDataLst>
-              <p:tags r:id="rId2"/>
+              <p:tags r:id="rId1"/>
             </p:custDataLst>
           </p:nvPr>
         </p:nvSpPr>
@@ -1777,10 +1794,9 @@
           <a:p>
             <a:pPr lvl="0"/>
             <a:r>
-              <a:rPr lang="zh-CN" altLang="en-US" smtClean="0"/>
+              <a:rPr lang="zh-CN" altLang="en-US"/>
               <a:t>单击此处编辑母版标题样式</a:t>
             </a:r>
-            <a:endParaRPr lang="zh-CN" altLang="en-US"/>
           </a:p>
         </p:txBody>
       </p:sp>
@@ -1793,7 +1809,7 @@
           <p:nvPr>
             <p:ph sz="half" idx="1"/>
             <p:custDataLst>
-              <p:tags r:id="rId3"/>
+              <p:tags r:id="rId2"/>
             </p:custDataLst>
           </p:nvPr>
         </p:nvSpPr>
@@ -1811,42 +1827,37 @@
           <a:p>
             <a:pPr lvl="0"/>
             <a:r>
-              <a:rPr lang="zh-CN" altLang="en-US" smtClean="0"/>
+              <a:rPr lang="zh-CN" altLang="en-US"/>
               <a:t>单击此处编辑母版文本样式</a:t>
             </a:r>
-            <a:endParaRPr lang="zh-CN" altLang="en-US" smtClean="0"/>
           </a:p>
           <a:p>
             <a:pPr lvl="1"/>
             <a:r>
-              <a:rPr lang="zh-CN" altLang="en-US" smtClean="0"/>
+              <a:rPr lang="zh-CN" altLang="en-US"/>
               <a:t>第二级</a:t>
             </a:r>
-            <a:endParaRPr lang="zh-CN" altLang="en-US" smtClean="0"/>
           </a:p>
           <a:p>
             <a:pPr lvl="2"/>
             <a:r>
-              <a:rPr lang="zh-CN" altLang="en-US" smtClean="0"/>
+              <a:rPr lang="zh-CN" altLang="en-US"/>
               <a:t>第三级</a:t>
             </a:r>
-            <a:endParaRPr lang="zh-CN" altLang="en-US" smtClean="0"/>
           </a:p>
           <a:p>
             <a:pPr lvl="3"/>
             <a:r>
-              <a:rPr lang="zh-CN" altLang="en-US" smtClean="0"/>
+              <a:rPr lang="zh-CN" altLang="en-US"/>
               <a:t>第四级</a:t>
             </a:r>
-            <a:endParaRPr lang="zh-CN" altLang="en-US" smtClean="0"/>
           </a:p>
           <a:p>
             <a:pPr lvl="4"/>
             <a:r>
-              <a:rPr lang="zh-CN" altLang="en-US" smtClean="0"/>
+              <a:rPr lang="zh-CN" altLang="en-US"/>
               <a:t>第五级</a:t>
             </a:r>
-            <a:endParaRPr lang="zh-CN" altLang="en-US"/>
           </a:p>
         </p:txBody>
       </p:sp>
@@ -1859,7 +1870,7 @@
           <p:nvPr>
             <p:ph sz="half" idx="2"/>
             <p:custDataLst>
-              <p:tags r:id="rId4"/>
+              <p:tags r:id="rId3"/>
             </p:custDataLst>
           </p:nvPr>
         </p:nvSpPr>
@@ -1880,7 +1891,6 @@
               <a:rPr lang="zh-CN" altLang="en-US" dirty="0"/>
               <a:t>单击此处编辑母版文本样式</a:t>
             </a:r>
-            <a:endParaRPr lang="zh-CN" altLang="en-US" dirty="0"/>
           </a:p>
           <a:p>
             <a:pPr lvl="1"/>
@@ -1888,7 +1898,6 @@
               <a:rPr lang="zh-CN" altLang="en-US" dirty="0"/>
               <a:t>第二级</a:t>
             </a:r>
-            <a:endParaRPr lang="zh-CN" altLang="en-US" dirty="0"/>
           </a:p>
           <a:p>
             <a:pPr lvl="2"/>
@@ -1896,7 +1905,6 @@
               <a:rPr lang="zh-CN" altLang="en-US" dirty="0"/>
               <a:t>第三级</a:t>
             </a:r>
-            <a:endParaRPr lang="zh-CN" altLang="en-US" dirty="0"/>
           </a:p>
           <a:p>
             <a:pPr lvl="3"/>
@@ -1904,7 +1912,6 @@
               <a:rPr lang="zh-CN" altLang="en-US" dirty="0"/>
               <a:t>第四级</a:t>
             </a:r>
-            <a:endParaRPr lang="zh-CN" altLang="en-US" dirty="0"/>
           </a:p>
           <a:p>
             <a:pPr lvl="4"/>
@@ -1912,7 +1919,6 @@
               <a:rPr lang="zh-CN" altLang="en-US" dirty="0"/>
               <a:t>第五级</a:t>
             </a:r>
-            <a:endParaRPr lang="zh-CN" altLang="en-US" dirty="0"/>
           </a:p>
         </p:txBody>
       </p:sp>
@@ -1924,6 +1930,32 @@
           </p:cNvSpPr>
           <p:nvPr>
             <p:ph type="dt" sz="half" idx="10"/>
+            <p:custDataLst>
+              <p:tags r:id="rId4"/>
+            </p:custDataLst>
+          </p:nvPr>
+        </p:nvSpPr>
+        <p:spPr/>
+        <p:txBody>
+          <a:bodyPr/>
+          <a:lstStyle/>
+          <a:p>
+            <a:fld id="{760FBDFE-C587-4B4C-A407-44438C67B59E}" type="datetimeFigureOut">
+              <a:rPr lang="zh-CN" altLang="en-US" smtClean="0"/>
+              <a:t>2026/6/13</a:t>
+            </a:fld>
+            <a:endParaRPr lang="zh-CN" altLang="en-US"/>
+          </a:p>
+        </p:txBody>
+      </p:sp>
+      <p:sp>
+        <p:nvSpPr>
+          <p:cNvPr id="6" name="页脚占位符 5"/>
+          <p:cNvSpPr>
+            <a:spLocks noGrp="1"/>
+          </p:cNvSpPr>
+          <p:nvPr>
+            <p:ph type="ftr" sz="quarter" idx="11"/>
             <p:custDataLst>
               <p:tags r:id="rId5"/>
             </p:custDataLst>
@@ -1934,21 +1966,18 @@
           <a:bodyPr/>
           <a:lstStyle/>
           <a:p>
-            <a:fld id="{760FBDFE-C587-4B4C-A407-44438C67B59E}" type="datetimeFigureOut">
-              <a:rPr lang="zh-CN" altLang="en-US" smtClean="0"/>
-            </a:fld>
             <a:endParaRPr lang="zh-CN" altLang="en-US"/>
           </a:p>
         </p:txBody>
       </p:sp>
       <p:sp>
         <p:nvSpPr>
-          <p:cNvPr id="6" name="页脚占位符 5"/>
-          <p:cNvSpPr>
-            <a:spLocks noGrp="1"/>
-          </p:cNvSpPr>
-          <p:nvPr>
-            <p:ph type="ftr" sz="quarter" idx="11"/>
+          <p:cNvPr id="7" name="灯片编号占位符 6"/>
+          <p:cNvSpPr>
+            <a:spLocks noGrp="1"/>
+          </p:cNvSpPr>
+          <p:nvPr>
+            <p:ph type="sldNum" sz="quarter" idx="12"/>
             <p:custDataLst>
               <p:tags r:id="rId6"/>
             </p:custDataLst>
@@ -1959,30 +1988,9 @@
           <a:bodyPr/>
           <a:lstStyle/>
           <a:p>
-            <a:endParaRPr lang="zh-CN" altLang="en-US"/>
-          </a:p>
-        </p:txBody>
-      </p:sp>
-      <p:sp>
-        <p:nvSpPr>
-          <p:cNvPr id="7" name="灯片编号占位符 6"/>
-          <p:cNvSpPr>
-            <a:spLocks noGrp="1"/>
-          </p:cNvSpPr>
-          <p:nvPr>
-            <p:ph type="sldNum" sz="quarter" idx="12"/>
-            <p:custDataLst>
-              <p:tags r:id="rId7"/>
-            </p:custDataLst>
-          </p:nvPr>
-        </p:nvSpPr>
-        <p:spPr/>
-        <p:txBody>
-          <a:bodyPr/>
-          <a:lstStyle/>
-          <a:p>
             <a:fld id="{49AE70B2-8BF9-45C0-BB95-33D1B9D3A854}" type="slidenum">
               <a:rPr lang="zh-CN" altLang="en-US" smtClean="0"/>
+              <a:t>‹#›</a:t>
             </a:fld>
             <a:endParaRPr lang="zh-CN" altLang="en-US"/>
           </a:p>
@@ -2022,7 +2030,7 @@
           <p:nvPr>
             <p:ph type="title"/>
             <p:custDataLst>
-              <p:tags r:id="rId2"/>
+              <p:tags r:id="rId1"/>
             </p:custDataLst>
           </p:nvPr>
         </p:nvSpPr>
@@ -2040,10 +2048,9 @@
           <a:p>
             <a:pPr lvl="0"/>
             <a:r>
-              <a:rPr lang="zh-CN" altLang="en-US" smtClean="0"/>
+              <a:rPr lang="zh-CN" altLang="en-US"/>
               <a:t>单击此处编辑母版标题样式</a:t>
             </a:r>
-            <a:endParaRPr lang="zh-CN" altLang="en-US"/>
           </a:p>
         </p:txBody>
       </p:sp>
@@ -2056,7 +2063,7 @@
           <p:nvPr>
             <p:ph type="body" idx="1" hasCustomPrompt="1"/>
             <p:custDataLst>
-              <p:tags r:id="rId3"/>
+              <p:tags r:id="rId2"/>
             </p:custDataLst>
           </p:nvPr>
         </p:nvSpPr>
@@ -2124,7 +2131,6 @@
               <a:rPr lang="zh-CN" altLang="en-US" dirty="0"/>
               <a:t>单击此处编辑文本</a:t>
             </a:r>
-            <a:endParaRPr lang="zh-CN" altLang="en-US" dirty="0"/>
           </a:p>
         </p:txBody>
       </p:sp>
@@ -2137,7 +2143,7 @@
           <p:nvPr>
             <p:ph sz="half" idx="2"/>
             <p:custDataLst>
-              <p:tags r:id="rId4"/>
+              <p:tags r:id="rId3"/>
             </p:custDataLst>
           </p:nvPr>
         </p:nvSpPr>
@@ -2155,42 +2161,37 @@
           <a:p>
             <a:pPr lvl="0"/>
             <a:r>
-              <a:rPr lang="zh-CN" altLang="en-US" smtClean="0"/>
+              <a:rPr lang="zh-CN" altLang="en-US"/>
               <a:t>单击此处编辑母版文本样式</a:t>
             </a:r>
-            <a:endParaRPr lang="zh-CN" altLang="en-US" smtClean="0"/>
           </a:p>
           <a:p>
             <a:pPr lvl="1"/>
             <a:r>
-              <a:rPr lang="zh-CN" altLang="en-US" smtClean="0"/>
+              <a:rPr lang="zh-CN" altLang="en-US"/>
               <a:t>第二级</a:t>
             </a:r>
-            <a:endParaRPr lang="zh-CN" altLang="en-US" smtClean="0"/>
           </a:p>
           <a:p>
             <a:pPr lvl="2"/>
             <a:r>
-              <a:rPr lang="zh-CN" altLang="en-US" smtClean="0"/>
+              <a:rPr lang="zh-CN" altLang="en-US"/>
               <a:t>第三级</a:t>
             </a:r>
-            <a:endParaRPr lang="zh-CN" altLang="en-US" smtClean="0"/>
           </a:p>
           <a:p>
             <a:pPr lvl="3"/>
             <a:r>
-              <a:rPr lang="zh-CN" altLang="en-US" smtClean="0"/>
+              <a:rPr lang="zh-CN" altLang="en-US"/>
               <a:t>第四级</a:t>
             </a:r>
-            <a:endParaRPr lang="zh-CN" altLang="en-US" smtClean="0"/>
           </a:p>
           <a:p>
             <a:pPr lvl="4"/>
             <a:r>
-              <a:rPr lang="zh-CN" altLang="en-US" smtClean="0"/>
+              <a:rPr lang="zh-CN" altLang="en-US"/>
               <a:t>第五级</a:t>
             </a:r>
-            <a:endParaRPr lang="zh-CN" altLang="en-US"/>
           </a:p>
         </p:txBody>
       </p:sp>
@@ -2203,7 +2204,7 @@
           <p:nvPr>
             <p:ph type="body" sz="quarter" idx="3" hasCustomPrompt="1"/>
             <p:custDataLst>
-              <p:tags r:id="rId5"/>
+              <p:tags r:id="rId4"/>
             </p:custDataLst>
           </p:nvPr>
         </p:nvSpPr>
@@ -2268,10 +2269,9 @@
           <a:p>
             <a:pPr lvl="0"/>
             <a:r>
-              <a:rPr lang="zh-CN" altLang="en-US" smtClean="0"/>
+              <a:rPr lang="zh-CN" altLang="en-US"/>
               <a:t>单击此处编辑文本</a:t>
             </a:r>
-            <a:endParaRPr lang="zh-CN" altLang="en-US"/>
           </a:p>
         </p:txBody>
       </p:sp>
@@ -2284,7 +2284,7 @@
           <p:nvPr>
             <p:ph sz="quarter" idx="4"/>
             <p:custDataLst>
-              <p:tags r:id="rId6"/>
+              <p:tags r:id="rId5"/>
             </p:custDataLst>
           </p:nvPr>
         </p:nvSpPr>
@@ -2302,53 +2302,74 @@
           <a:p>
             <a:pPr lvl="0"/>
             <a:r>
-              <a:rPr lang="zh-CN" altLang="en-US" smtClean="0"/>
+              <a:rPr lang="zh-CN" altLang="en-US"/>
               <a:t>单击此处编辑母版文本样式</a:t>
             </a:r>
-            <a:endParaRPr lang="zh-CN" altLang="en-US" smtClean="0"/>
           </a:p>
           <a:p>
             <a:pPr lvl="1"/>
             <a:r>
-              <a:rPr lang="zh-CN" altLang="en-US" smtClean="0"/>
+              <a:rPr lang="zh-CN" altLang="en-US"/>
               <a:t>第二级</a:t>
             </a:r>
-            <a:endParaRPr lang="zh-CN" altLang="en-US" smtClean="0"/>
           </a:p>
           <a:p>
             <a:pPr lvl="2"/>
             <a:r>
-              <a:rPr lang="zh-CN" altLang="en-US" smtClean="0"/>
+              <a:rPr lang="zh-CN" altLang="en-US"/>
               <a:t>第三级</a:t>
             </a:r>
-            <a:endParaRPr lang="zh-CN" altLang="en-US" smtClean="0"/>
           </a:p>
           <a:p>
             <a:pPr lvl="3"/>
             <a:r>
-              <a:rPr lang="zh-CN" altLang="en-US" smtClean="0"/>
+              <a:rPr lang="zh-CN" altLang="en-US"/>
               <a:t>第四级</a:t>
             </a:r>
-            <a:endParaRPr lang="zh-CN" altLang="en-US" smtClean="0"/>
           </a:p>
           <a:p>
             <a:pPr lvl="4"/>
             <a:r>
-              <a:rPr lang="zh-CN" altLang="en-US" smtClean="0"/>
+              <a:rPr lang="zh-CN" altLang="en-US"/>
               <a:t>第五级</a:t>
             </a:r>
+          </a:p>
+        </p:txBody>
+      </p:sp>
+      <p:sp>
+        <p:nvSpPr>
+          <p:cNvPr id="7" name="日期占位符 6"/>
+          <p:cNvSpPr>
+            <a:spLocks noGrp="1"/>
+          </p:cNvSpPr>
+          <p:nvPr>
+            <p:ph type="dt" sz="half" idx="10"/>
+            <p:custDataLst>
+              <p:tags r:id="rId6"/>
+            </p:custDataLst>
+          </p:nvPr>
+        </p:nvSpPr>
+        <p:spPr/>
+        <p:txBody>
+          <a:bodyPr/>
+          <a:lstStyle/>
+          <a:p>
+            <a:fld id="{760FBDFE-C587-4B4C-A407-44438C67B59E}" type="datetimeFigureOut">
+              <a:rPr lang="zh-CN" altLang="en-US" smtClean="0"/>
+              <a:t>2026/6/13</a:t>
+            </a:fld>
             <a:endParaRPr lang="zh-CN" altLang="en-US"/>
           </a:p>
         </p:txBody>
       </p:sp>
       <p:sp>
         <p:nvSpPr>
-          <p:cNvPr id="7" name="日期占位符 6"/>
-          <p:cNvSpPr>
-            <a:spLocks noGrp="1"/>
-          </p:cNvSpPr>
-          <p:nvPr>
-            <p:ph type="dt" sz="half" idx="10"/>
+          <p:cNvPr id="8" name="页脚占位符 7"/>
+          <p:cNvSpPr>
+            <a:spLocks noGrp="1"/>
+          </p:cNvSpPr>
+          <p:nvPr>
+            <p:ph type="ftr" sz="quarter" idx="11"/>
             <p:custDataLst>
               <p:tags r:id="rId7"/>
             </p:custDataLst>
@@ -2359,21 +2380,18 @@
           <a:bodyPr/>
           <a:lstStyle/>
           <a:p>
-            <a:fld id="{760FBDFE-C587-4B4C-A407-44438C67B59E}" type="datetimeFigureOut">
-              <a:rPr lang="zh-CN" altLang="en-US" smtClean="0"/>
-            </a:fld>
             <a:endParaRPr lang="zh-CN" altLang="en-US"/>
           </a:p>
         </p:txBody>
       </p:sp>
       <p:sp>
         <p:nvSpPr>
-          <p:cNvPr id="8" name="页脚占位符 7"/>
-          <p:cNvSpPr>
-            <a:spLocks noGrp="1"/>
-          </p:cNvSpPr>
-          <p:nvPr>
-            <p:ph type="ftr" sz="quarter" idx="11"/>
+          <p:cNvPr id="9" name="灯片编号占位符 8"/>
+          <p:cNvSpPr>
+            <a:spLocks noGrp="1"/>
+          </p:cNvSpPr>
+          <p:nvPr>
+            <p:ph type="sldNum" sz="quarter" idx="12"/>
             <p:custDataLst>
               <p:tags r:id="rId8"/>
             </p:custDataLst>
@@ -2384,30 +2402,9 @@
           <a:bodyPr/>
           <a:lstStyle/>
           <a:p>
-            <a:endParaRPr lang="zh-CN" altLang="en-US"/>
-          </a:p>
-        </p:txBody>
-      </p:sp>
-      <p:sp>
-        <p:nvSpPr>
-          <p:cNvPr id="9" name="灯片编号占位符 8"/>
-          <p:cNvSpPr>
-            <a:spLocks noGrp="1"/>
-          </p:cNvSpPr>
-          <p:nvPr>
-            <p:ph type="sldNum" sz="quarter" idx="12"/>
-            <p:custDataLst>
-              <p:tags r:id="rId9"/>
-            </p:custDataLst>
-          </p:nvPr>
-        </p:nvSpPr>
-        <p:spPr/>
-        <p:txBody>
-          <a:bodyPr/>
-          <a:lstStyle/>
-          <a:p>
             <a:fld id="{49AE70B2-8BF9-45C0-BB95-33D1B9D3A854}" type="slidenum">
               <a:rPr lang="zh-CN" altLang="en-US" smtClean="0"/>
+              <a:t>‹#›</a:t>
             </a:fld>
             <a:endParaRPr lang="zh-CN" altLang="en-US"/>
           </a:p>
@@ -2447,7 +2444,7 @@
           <p:nvPr>
             <p:ph type="title"/>
             <p:custDataLst>
-              <p:tags r:id="rId2"/>
+              <p:tags r:id="rId1"/>
             </p:custDataLst>
           </p:nvPr>
         </p:nvSpPr>
@@ -2465,21 +2462,46 @@
           <a:p>
             <a:pPr lvl="0"/>
             <a:r>
-              <a:rPr lang="zh-CN" altLang="en-US" smtClean="0"/>
+              <a:rPr lang="zh-CN" altLang="en-US"/>
               <a:t>单击此处编辑母版标题样式</a:t>
             </a:r>
+          </a:p>
+        </p:txBody>
+      </p:sp>
+      <p:sp>
+        <p:nvSpPr>
+          <p:cNvPr id="3" name="日期占位符 2"/>
+          <p:cNvSpPr>
+            <a:spLocks noGrp="1"/>
+          </p:cNvSpPr>
+          <p:nvPr>
+            <p:ph type="dt" sz="half" idx="10"/>
+            <p:custDataLst>
+              <p:tags r:id="rId2"/>
+            </p:custDataLst>
+          </p:nvPr>
+        </p:nvSpPr>
+        <p:spPr/>
+        <p:txBody>
+          <a:bodyPr/>
+          <a:lstStyle/>
+          <a:p>
+            <a:fld id="{760FBDFE-C587-4B4C-A407-44438C67B59E}" type="datetimeFigureOut">
+              <a:rPr lang="zh-CN" altLang="en-US" smtClean="0"/>
+              <a:t>2026/6/13</a:t>
+            </a:fld>
             <a:endParaRPr lang="zh-CN" altLang="en-US"/>
           </a:p>
         </p:txBody>
       </p:sp>
       <p:sp>
         <p:nvSpPr>
-          <p:cNvPr id="3" name="日期占位符 2"/>
-          <p:cNvSpPr>
-            <a:spLocks noGrp="1"/>
-          </p:cNvSpPr>
-          <p:nvPr>
-            <p:ph type="dt" sz="half" idx="10"/>
+          <p:cNvPr id="4" name="页脚占位符 3"/>
+          <p:cNvSpPr>
+            <a:spLocks noGrp="1"/>
+          </p:cNvSpPr>
+          <p:nvPr>
+            <p:ph type="ftr" sz="quarter" idx="11"/>
             <p:custDataLst>
               <p:tags r:id="rId3"/>
             </p:custDataLst>
@@ -2490,21 +2512,18 @@
           <a:bodyPr/>
           <a:lstStyle/>
           <a:p>
-            <a:fld id="{760FBDFE-C587-4B4C-A407-44438C67B59E}" type="datetimeFigureOut">
-              <a:rPr lang="zh-CN" altLang="en-US" smtClean="0"/>
-            </a:fld>
             <a:endParaRPr lang="zh-CN" altLang="en-US"/>
           </a:p>
         </p:txBody>
       </p:sp>
       <p:sp>
         <p:nvSpPr>
-          <p:cNvPr id="4" name="页脚占位符 3"/>
-          <p:cNvSpPr>
-            <a:spLocks noGrp="1"/>
-          </p:cNvSpPr>
-          <p:nvPr>
-            <p:ph type="ftr" sz="quarter" idx="11"/>
+          <p:cNvPr id="5" name="灯片编号占位符 4"/>
+          <p:cNvSpPr>
+            <a:spLocks noGrp="1"/>
+          </p:cNvSpPr>
+          <p:nvPr>
+            <p:ph type="sldNum" sz="quarter" idx="12"/>
             <p:custDataLst>
               <p:tags r:id="rId4"/>
             </p:custDataLst>
@@ -2515,30 +2534,9 @@
           <a:bodyPr/>
           <a:lstStyle/>
           <a:p>
-            <a:endParaRPr lang="zh-CN" altLang="en-US"/>
-          </a:p>
-        </p:txBody>
-      </p:sp>
-      <p:sp>
-        <p:nvSpPr>
-          <p:cNvPr id="5" name="灯片编号占位符 4"/>
-          <p:cNvSpPr>
-            <a:spLocks noGrp="1"/>
-          </p:cNvSpPr>
-          <p:nvPr>
-            <p:ph type="sldNum" sz="quarter" idx="12"/>
-            <p:custDataLst>
-              <p:tags r:id="rId5"/>
-            </p:custDataLst>
-          </p:nvPr>
-        </p:nvSpPr>
-        <p:spPr/>
-        <p:txBody>
-          <a:bodyPr/>
-          <a:lstStyle/>
-          <a:p>
             <a:fld id="{49AE70B2-8BF9-45C0-BB95-33D1B9D3A854}" type="slidenum">
               <a:rPr lang="zh-CN" altLang="en-US" smtClean="0"/>
+              <a:t>‹#›</a:t>
             </a:fld>
             <a:endParaRPr lang="zh-CN" altLang="en-US"/>
           </a:p>
@@ -2578,6 +2576,32 @@
           <p:nvPr>
             <p:ph type="dt" sz="half" idx="10"/>
             <p:custDataLst>
+              <p:tags r:id="rId1"/>
+            </p:custDataLst>
+          </p:nvPr>
+        </p:nvSpPr>
+        <p:spPr/>
+        <p:txBody>
+          <a:bodyPr/>
+          <a:lstStyle/>
+          <a:p>
+            <a:fld id="{760FBDFE-C587-4B4C-A407-44438C67B59E}" type="datetimeFigureOut">
+              <a:rPr lang="zh-CN" altLang="en-US" smtClean="0"/>
+              <a:t>2026/6/13</a:t>
+            </a:fld>
+            <a:endParaRPr lang="zh-CN" altLang="en-US"/>
+          </a:p>
+        </p:txBody>
+      </p:sp>
+      <p:sp>
+        <p:nvSpPr>
+          <p:cNvPr id="3" name="页脚占位符 2"/>
+          <p:cNvSpPr>
+            <a:spLocks noGrp="1"/>
+          </p:cNvSpPr>
+          <p:nvPr>
+            <p:ph type="ftr" sz="quarter" idx="11"/>
+            <p:custDataLst>
               <p:tags r:id="rId2"/>
             </p:custDataLst>
           </p:nvPr>
@@ -2587,21 +2611,18 @@
           <a:bodyPr/>
           <a:lstStyle/>
           <a:p>
-            <a:fld id="{760FBDFE-C587-4B4C-A407-44438C67B59E}" type="datetimeFigureOut">
-              <a:rPr lang="zh-CN" altLang="en-US" smtClean="0"/>
-            </a:fld>
             <a:endParaRPr lang="zh-CN" altLang="en-US"/>
           </a:p>
         </p:txBody>
       </p:sp>
       <p:sp>
         <p:nvSpPr>
-          <p:cNvPr id="3" name="页脚占位符 2"/>
-          <p:cNvSpPr>
-            <a:spLocks noGrp="1"/>
-          </p:cNvSpPr>
-          <p:nvPr>
-            <p:ph type="ftr" sz="quarter" idx="11"/>
+          <p:cNvPr id="4" name="灯片编号占位符 3"/>
+          <p:cNvSpPr>
+            <a:spLocks noGrp="1"/>
+          </p:cNvSpPr>
+          <p:nvPr>
+            <p:ph type="sldNum" sz="quarter" idx="12"/>
             <p:custDataLst>
               <p:tags r:id="rId3"/>
             </p:custDataLst>
@@ -2612,30 +2633,9 @@
           <a:bodyPr/>
           <a:lstStyle/>
           <a:p>
-            <a:endParaRPr lang="zh-CN" altLang="en-US"/>
-          </a:p>
-        </p:txBody>
-      </p:sp>
-      <p:sp>
-        <p:nvSpPr>
-          <p:cNvPr id="4" name="灯片编号占位符 3"/>
-          <p:cNvSpPr>
-            <a:spLocks noGrp="1"/>
-          </p:cNvSpPr>
-          <p:nvPr>
-            <p:ph type="sldNum" sz="quarter" idx="12"/>
-            <p:custDataLst>
-              <p:tags r:id="rId4"/>
-            </p:custDataLst>
-          </p:nvPr>
-        </p:nvSpPr>
-        <p:spPr/>
-        <p:txBody>
-          <a:bodyPr/>
-          <a:lstStyle/>
-          <a:p>
             <a:fld id="{49AE70B2-8BF9-45C0-BB95-33D1B9D3A854}" type="slidenum">
               <a:rPr lang="zh-CN" altLang="en-US" smtClean="0"/>
+              <a:t>‹#›</a:t>
             </a:fld>
             <a:endParaRPr lang="zh-CN" altLang="en-US"/>
           </a:p>
@@ -2675,7 +2675,7 @@
           <p:nvPr>
             <p:ph type="pic" idx="1"/>
             <p:custDataLst>
-              <p:tags r:id="rId2"/>
+              <p:tags r:id="rId1"/>
             </p:custDataLst>
           </p:nvPr>
         </p:nvSpPr>
@@ -2710,7 +2710,7 @@
           <p:nvPr>
             <p:ph type="body" sz="half" idx="2"/>
             <p:custDataLst>
-              <p:tags r:id="rId3"/>
+              <p:tags r:id="rId2"/>
             </p:custDataLst>
           </p:nvPr>
         </p:nvSpPr>
@@ -2733,10 +2733,9 @@
           <a:p>
             <a:pPr lvl="0"/>
             <a:r>
-              <a:rPr lang="zh-CN" altLang="en-US" smtClean="0"/>
+              <a:rPr lang="zh-CN" altLang="en-US"/>
               <a:t>单击此处编辑母版文本样式</a:t>
             </a:r>
-            <a:endParaRPr lang="zh-CN" altLang="en-US"/>
           </a:p>
         </p:txBody>
       </p:sp>
@@ -2748,6 +2747,32 @@
           </p:cNvSpPr>
           <p:nvPr>
             <p:ph type="dt" sz="half" idx="10"/>
+            <p:custDataLst>
+              <p:tags r:id="rId3"/>
+            </p:custDataLst>
+          </p:nvPr>
+        </p:nvSpPr>
+        <p:spPr/>
+        <p:txBody>
+          <a:bodyPr/>
+          <a:lstStyle/>
+          <a:p>
+            <a:fld id="{9EFD9D74-47D9-4702-A33C-335B63B48DBF}" type="datetimeFigureOut">
+              <a:rPr lang="zh-CN" altLang="en-US" smtClean="0"/>
+              <a:t>2026/6/13</a:t>
+            </a:fld>
+            <a:endParaRPr lang="zh-CN" altLang="en-US" dirty="0"/>
+          </a:p>
+        </p:txBody>
+      </p:sp>
+      <p:sp>
+        <p:nvSpPr>
+          <p:cNvPr id="6" name="页脚占位符 5"/>
+          <p:cNvSpPr>
+            <a:spLocks noGrp="1"/>
+          </p:cNvSpPr>
+          <p:nvPr>
+            <p:ph type="ftr" sz="quarter" idx="11"/>
             <p:custDataLst>
               <p:tags r:id="rId4"/>
             </p:custDataLst>
@@ -2758,21 +2783,18 @@
           <a:bodyPr/>
           <a:lstStyle/>
           <a:p>
-            <a:fld id="{9EFD9D74-47D9-4702-A33C-335B63B48DBF}" type="datetimeFigureOut">
-              <a:rPr lang="zh-CN" altLang="en-US" smtClean="0"/>
-            </a:fld>
             <a:endParaRPr lang="zh-CN" altLang="en-US" dirty="0"/>
           </a:p>
         </p:txBody>
       </p:sp>
       <p:sp>
         <p:nvSpPr>
-          <p:cNvPr id="6" name="页脚占位符 5"/>
-          <p:cNvSpPr>
-            <a:spLocks noGrp="1"/>
-          </p:cNvSpPr>
-          <p:nvPr>
-            <p:ph type="ftr" sz="quarter" idx="11"/>
+          <p:cNvPr id="7" name="灯片编号占位符 6"/>
+          <p:cNvSpPr>
+            <a:spLocks noGrp="1"/>
+          </p:cNvSpPr>
+          <p:nvPr>
+            <p:ph type="sldNum" sz="quarter" idx="12"/>
             <p:custDataLst>
               <p:tags r:id="rId5"/>
             </p:custDataLst>
@@ -2783,18 +2805,22 @@
           <a:bodyPr/>
           <a:lstStyle/>
           <a:p>
-            <a:endParaRPr lang="zh-CN" altLang="en-US" dirty="0"/>
-          </a:p>
-        </p:txBody>
-      </p:sp>
-      <p:sp>
-        <p:nvSpPr>
-          <p:cNvPr id="7" name="灯片编号占位符 6"/>
-          <p:cNvSpPr>
-            <a:spLocks noGrp="1"/>
-          </p:cNvSpPr>
-          <p:nvPr>
-            <p:ph type="sldNum" sz="quarter" idx="12"/>
+            <a:fld id="{FABC47A4-756D-490B-A52F-7D9E2C9FC05F}" type="slidenum">
+              <a:rPr lang="zh-CN" altLang="en-US" smtClean="0"/>
+              <a:t>‹#›</a:t>
+            </a:fld>
+            <a:endParaRPr lang="zh-CN" altLang="en-US"/>
+          </a:p>
+        </p:txBody>
+      </p:sp>
+      <p:sp>
+        <p:nvSpPr>
+          <p:cNvPr id="9" name="标题 8"/>
+          <p:cNvSpPr>
+            <a:spLocks noGrp="1"/>
+          </p:cNvSpPr>
+          <p:nvPr>
+            <p:ph type="title"/>
             <p:custDataLst>
               <p:tags r:id="rId6"/>
             </p:custDataLst>
@@ -2804,36 +2830,11 @@
         <p:txBody>
           <a:bodyPr/>
           <a:lstStyle/>
-          <a:p>
-            <a:fld id="{FABC47A4-756D-490B-A52F-7D9E2C9FC05F}" type="slidenum">
-              <a:rPr lang="zh-CN" altLang="en-US" smtClean="0"/>
-            </a:fld>
-            <a:endParaRPr lang="zh-CN" altLang="en-US"/>
-          </a:p>
-        </p:txBody>
-      </p:sp>
-      <p:sp>
-        <p:nvSpPr>
-          <p:cNvPr id="9" name="标题 8"/>
-          <p:cNvSpPr>
-            <a:spLocks noGrp="1"/>
-          </p:cNvSpPr>
-          <p:nvPr>
-            <p:ph type="title"/>
-            <p:custDataLst>
-              <p:tags r:id="rId7"/>
-            </p:custDataLst>
-          </p:nvPr>
-        </p:nvSpPr>
-        <p:spPr/>
-        <p:txBody>
-          <a:bodyPr/>
           <a:p>
             <a:r>
               <a:rPr lang="zh-CN" altLang="en-US"/>
               <a:t>单击此处编辑母版标题样式</a:t>
             </a:r>
-            <a:endParaRPr lang="zh-CN" altLang="en-US"/>
           </a:p>
         </p:txBody>
       </p:sp>
@@ -2871,7 +2872,7 @@
           <p:nvPr>
             <p:ph type="title" orient="vert" hasCustomPrompt="1"/>
             <p:custDataLst>
-              <p:tags r:id="rId2"/>
+              <p:tags r:id="rId1"/>
             </p:custDataLst>
           </p:nvPr>
         </p:nvSpPr>
@@ -2894,10 +2895,9 @@
           <a:p>
             <a:pPr lvl="0"/>
             <a:r>
-              <a:rPr lang="zh-CN" altLang="en-US" smtClean="0"/>
+              <a:rPr lang="zh-CN" altLang="en-US"/>
               <a:t>单击此处编辑标题</a:t>
             </a:r>
-            <a:endParaRPr lang="zh-CN" altLang="en-US"/>
           </a:p>
         </p:txBody>
       </p:sp>
@@ -2910,7 +2910,7 @@
           <p:nvPr>
             <p:ph type="body" orient="vert" idx="1"/>
             <p:custDataLst>
-              <p:tags r:id="rId3"/>
+              <p:tags r:id="rId2"/>
             </p:custDataLst>
           </p:nvPr>
         </p:nvSpPr>
@@ -2948,7 +2948,6 @@
               <a:rPr lang="zh-CN" altLang="en-US" dirty="0"/>
               <a:t>单击此处编辑母版文本样式</a:t>
             </a:r>
-            <a:endParaRPr lang="zh-CN" altLang="en-US" dirty="0"/>
           </a:p>
           <a:p>
             <a:pPr lvl="1"/>
@@ -2956,7 +2955,6 @@
               <a:rPr lang="zh-CN" altLang="en-US" dirty="0"/>
               <a:t>第二级</a:t>
             </a:r>
-            <a:endParaRPr lang="zh-CN" altLang="en-US" dirty="0"/>
           </a:p>
           <a:p>
             <a:pPr lvl="2"/>
@@ -2964,7 +2962,6 @@
               <a:rPr lang="zh-CN" altLang="en-US" dirty="0"/>
               <a:t>第三级</a:t>
             </a:r>
-            <a:endParaRPr lang="zh-CN" altLang="en-US" dirty="0"/>
           </a:p>
           <a:p>
             <a:pPr lvl="3"/>
@@ -2972,7 +2969,6 @@
               <a:rPr lang="zh-CN" altLang="en-US" dirty="0"/>
               <a:t>第四级</a:t>
             </a:r>
-            <a:endParaRPr lang="zh-CN" altLang="en-US" dirty="0"/>
           </a:p>
           <a:p>
             <a:pPr lvl="4"/>
@@ -2980,7 +2976,6 @@
               <a:rPr lang="zh-CN" altLang="en-US" dirty="0"/>
               <a:t>第五级</a:t>
             </a:r>
-            <a:endParaRPr lang="zh-CN" altLang="en-US" dirty="0"/>
           </a:p>
         </p:txBody>
       </p:sp>
@@ -2992,6 +2987,32 @@
           </p:cNvSpPr>
           <p:nvPr>
             <p:ph type="dt" sz="half" idx="10"/>
+            <p:custDataLst>
+              <p:tags r:id="rId3"/>
+            </p:custDataLst>
+          </p:nvPr>
+        </p:nvSpPr>
+        <p:spPr/>
+        <p:txBody>
+          <a:bodyPr/>
+          <a:lstStyle/>
+          <a:p>
+            <a:fld id="{760FBDFE-C587-4B4C-A407-44438C67B59E}" type="datetimeFigureOut">
+              <a:rPr lang="zh-CN" altLang="en-US" smtClean="0"/>
+              <a:t>2026/6/13</a:t>
+            </a:fld>
+            <a:endParaRPr lang="zh-CN" altLang="en-US"/>
+          </a:p>
+        </p:txBody>
+      </p:sp>
+      <p:sp>
+        <p:nvSpPr>
+          <p:cNvPr id="5" name="页脚占位符 4"/>
+          <p:cNvSpPr>
+            <a:spLocks noGrp="1"/>
+          </p:cNvSpPr>
+          <p:nvPr>
+            <p:ph type="ftr" sz="quarter" idx="11"/>
             <p:custDataLst>
               <p:tags r:id="rId4"/>
             </p:custDataLst>
@@ -3002,21 +3023,18 @@
           <a:bodyPr/>
           <a:lstStyle/>
           <a:p>
-            <a:fld id="{760FBDFE-C587-4B4C-A407-44438C67B59E}" type="datetimeFigureOut">
-              <a:rPr lang="zh-CN" altLang="en-US" smtClean="0"/>
-            </a:fld>
             <a:endParaRPr lang="zh-CN" altLang="en-US"/>
           </a:p>
         </p:txBody>
       </p:sp>
       <p:sp>
         <p:nvSpPr>
-          <p:cNvPr id="5" name="页脚占位符 4"/>
-          <p:cNvSpPr>
-            <a:spLocks noGrp="1"/>
-          </p:cNvSpPr>
-          <p:nvPr>
-            <p:ph type="ftr" sz="quarter" idx="11"/>
+          <p:cNvPr id="6" name="灯片编号占位符 5"/>
+          <p:cNvSpPr>
+            <a:spLocks noGrp="1"/>
+          </p:cNvSpPr>
+          <p:nvPr>
+            <p:ph type="sldNum" sz="quarter" idx="12"/>
             <p:custDataLst>
               <p:tags r:id="rId5"/>
             </p:custDataLst>
@@ -3027,30 +3045,9 @@
           <a:bodyPr/>
           <a:lstStyle/>
           <a:p>
-            <a:endParaRPr lang="zh-CN" altLang="en-US"/>
-          </a:p>
-        </p:txBody>
-      </p:sp>
-      <p:sp>
-        <p:nvSpPr>
-          <p:cNvPr id="6" name="灯片编号占位符 5"/>
-          <p:cNvSpPr>
-            <a:spLocks noGrp="1"/>
-          </p:cNvSpPr>
-          <p:nvPr>
-            <p:ph type="sldNum" sz="quarter" idx="12"/>
-            <p:custDataLst>
-              <p:tags r:id="rId6"/>
-            </p:custDataLst>
-          </p:nvPr>
-        </p:nvSpPr>
-        <p:spPr/>
-        <p:txBody>
-          <a:bodyPr/>
-          <a:lstStyle/>
-          <a:p>
             <a:fld id="{49AE70B2-8BF9-45C0-BB95-33D1B9D3A854}" type="slidenum">
               <a:rPr lang="zh-CN" altLang="en-US" smtClean="0"/>
+              <a:t>‹#›</a:t>
             </a:fld>
             <a:endParaRPr lang="zh-CN" altLang="en-US"/>
           </a:p>
@@ -3095,7 +3092,7 @@
           <p:nvPr>
             <p:ph type="title"/>
             <p:custDataLst>
-              <p:tags r:id="rId12"/>
+              <p:tags r:id="rId14"/>
             </p:custDataLst>
           </p:nvPr>
         </p:nvSpPr>
@@ -3118,7 +3115,6 @@
               <a:rPr lang="zh-CN" altLang="en-US" dirty="0"/>
               <a:t>单击此处编辑母版标题样式</a:t>
             </a:r>
-            <a:endParaRPr lang="zh-CN" altLang="en-US" dirty="0"/>
           </a:p>
         </p:txBody>
       </p:sp>
@@ -3131,7 +3127,7 @@
           <p:nvPr>
             <p:ph type="body" idx="1"/>
             <p:custDataLst>
-              <p:tags r:id="rId13"/>
+              <p:tags r:id="rId15"/>
             </p:custDataLst>
           </p:nvPr>
         </p:nvSpPr>
@@ -3155,7 +3151,6 @@
               <a:rPr lang="zh-CN" altLang="en-US" dirty="0"/>
               <a:t>单击此处编辑母版文本样式</a:t>
             </a:r>
-            <a:endParaRPr lang="zh-CN" altLang="en-US" dirty="0"/>
           </a:p>
           <a:p>
             <a:pPr lvl="1"/>
@@ -3163,7 +3158,6 @@
               <a:rPr lang="zh-CN" altLang="en-US" dirty="0"/>
               <a:t>第二级</a:t>
             </a:r>
-            <a:endParaRPr lang="zh-CN" altLang="en-US" dirty="0"/>
           </a:p>
           <a:p>
             <a:pPr lvl="2"/>
@@ -3171,7 +3165,6 @@
               <a:rPr lang="zh-CN" altLang="en-US" dirty="0"/>
               <a:t>第三级</a:t>
             </a:r>
-            <a:endParaRPr lang="zh-CN" altLang="en-US" dirty="0"/>
           </a:p>
           <a:p>
             <a:pPr lvl="3"/>
@@ -3179,7 +3172,6 @@
               <a:rPr lang="zh-CN" altLang="en-US" dirty="0"/>
               <a:t>第四级</a:t>
             </a:r>
-            <a:endParaRPr lang="zh-CN" altLang="en-US" dirty="0"/>
           </a:p>
           <a:p>
             <a:pPr lvl="4"/>
@@ -3187,7 +3179,6 @@
               <a:rPr lang="zh-CN" altLang="en-US" dirty="0"/>
               <a:t>第五级</a:t>
             </a:r>
-            <a:endParaRPr lang="zh-CN" altLang="en-US" dirty="0"/>
           </a:p>
         </p:txBody>
       </p:sp>
@@ -3200,7 +3191,7 @@
           <p:nvPr>
             <p:ph type="dt" sz="half" idx="2"/>
             <p:custDataLst>
-              <p:tags r:id="rId14"/>
+              <p:tags r:id="rId16"/>
             </p:custDataLst>
           </p:nvPr>
         </p:nvSpPr>
@@ -3231,6 +3222,7 @@
           <a:p>
             <a:fld id="{760FBDFE-C587-4B4C-A407-44438C67B59E}" type="datetimeFigureOut">
               <a:rPr lang="zh-CN" altLang="en-US" smtClean="0"/>
+              <a:t>2026/6/13</a:t>
             </a:fld>
             <a:endParaRPr lang="zh-CN" altLang="en-US"/>
           </a:p>
@@ -3245,7 +3237,7 @@
           <p:nvPr>
             <p:ph type="ftr" sz="quarter" idx="3"/>
             <p:custDataLst>
-              <p:tags r:id="rId15"/>
+              <p:tags r:id="rId17"/>
             </p:custDataLst>
           </p:nvPr>
         </p:nvSpPr>
@@ -3287,7 +3279,7 @@
           <p:nvPr>
             <p:ph type="sldNum" sz="quarter" idx="4"/>
             <p:custDataLst>
-              <p:tags r:id="rId16"/>
+              <p:tags r:id="rId18"/>
             </p:custDataLst>
           </p:nvPr>
         </p:nvSpPr>
@@ -3318,6 +3310,7 @@
           <a:p>
             <a:fld id="{49AE70B2-8BF9-45C0-BB95-33D1B9D3A854}" type="slidenum">
               <a:rPr lang="zh-CN" altLang="en-US" smtClean="0"/>
+              <a:t>‹#›</a:t>
             </a:fld>
             <a:endParaRPr lang="zh-CN" altLang="en-US" dirty="0"/>
           </a:p>
@@ -3325,7 +3318,7 @@
       </p:sp>
     </p:spTree>
     <p:custDataLst>
-      <p:tags r:id="rId17"/>
+      <p:tags r:id="rId13"/>
     </p:custDataLst>
   </p:cSld>
   <p:clrMap bg1="lt1" tx1="dk1" bg2="lt2" tx2="dk2" accent1="accent1" accent2="accent2" accent3="accent3" accent4="accent4" accent5="accent5" accent6="accent6" hlink="hlink" folHlink="folHlink"/>
@@ -3696,7 +3689,7 @@
           <p:nvPr/>
         </p:nvPicPr>
         <p:blipFill>
-          <a:blip r:embed="rId1"/>
+          <a:blip r:embed="rId4"/>
           <a:stretch>
             <a:fillRect/>
           </a:stretch>
@@ -4093,6 +4086,7 @@
         </p:style>
         <p:txBody>
           <a:bodyPr rtlCol="0" anchor="ctr"/>
+          <a:lstStyle/>
           <a:p>
             <a:pPr algn="ctr"/>
             <a:endParaRPr lang="zh-CN" altLang="en-US"/>
@@ -4375,6 +4369,7 @@
         </p:style>
         <p:txBody>
           <a:bodyPr rtlCol="0" anchor="ctr"/>
+          <a:lstStyle/>
           <a:p>
             <a:pPr algn="ctr"/>
             <a:endParaRPr lang="zh-CN" altLang="en-US"/>
@@ -4530,6 +4525,7 @@
         </p:style>
         <p:txBody>
           <a:bodyPr rtlCol="0" anchor="ctr"/>
+          <a:lstStyle/>
           <a:p>
             <a:pPr algn="ctr"/>
             <a:endParaRPr lang="zh-CN" altLang="en-US"/>
@@ -4556,6 +4552,7 @@
           <a:bodyPr wrap="square" rtlCol="0">
             <a:spAutoFit/>
           </a:bodyPr>
+          <a:lstStyle/>
           <a:p>
             <a:r>
               <a:rPr lang="en-US" altLang="zh-CN" sz="2800" b="1">
@@ -4567,13 +4564,6 @@
               </a:rPr>
               <a:t>PERSON_1</a:t>
             </a:r>
-            <a:endParaRPr lang="en-US" altLang="zh-CN" sz="2800" b="1">
-              <a:solidFill>
-                <a:srgbClr val="FF0000"/>
-              </a:solidFill>
-              <a:latin typeface="PingFang SC Semibold" panose="020B0400000000000000" charset="-122"/>
-              <a:ea typeface="PingFang SC Semibold" panose="020B0400000000000000" charset="-122"/>
-            </a:endParaRPr>
           </a:p>
         </p:txBody>
       </p:sp>
@@ -4597,6 +4587,7 @@
           <a:bodyPr wrap="square" rtlCol="0">
             <a:spAutoFit/>
           </a:bodyPr>
+          <a:lstStyle/>
           <a:p>
             <a:r>
               <a:rPr lang="en-US" altLang="zh-CN" sz="2800" b="1">
@@ -4608,13 +4599,6 @@
               </a:rPr>
               <a:t>PERSON_2</a:t>
             </a:r>
-            <a:endParaRPr lang="en-US" altLang="zh-CN" sz="2800" b="1">
-              <a:solidFill>
-                <a:srgbClr val="FF0000"/>
-              </a:solidFill>
-              <a:latin typeface="PingFang SC Semibold" panose="020B0400000000000000" charset="-122"/>
-              <a:ea typeface="PingFang SC Semibold" panose="020B0400000000000000" charset="-122"/>
-            </a:endParaRPr>
           </a:p>
         </p:txBody>
       </p:sp>
@@ -4638,6 +4622,7 @@
           <a:bodyPr wrap="square" rtlCol="0">
             <a:spAutoFit/>
           </a:bodyPr>
+          <a:lstStyle/>
           <a:p>
             <a:r>
               <a:rPr lang="en-US" altLang="zh-CN" sz="2800" b="1">
@@ -4649,19 +4634,12 @@
               </a:rPr>
               <a:t>KNIFE</a:t>
             </a:r>
-            <a:endParaRPr lang="en-US" altLang="zh-CN" sz="2800" b="1">
-              <a:solidFill>
-                <a:srgbClr val="FF0000"/>
-              </a:solidFill>
-              <a:latin typeface="PingFang SC Semibold" panose="020B0400000000000000" charset="-122"/>
-              <a:ea typeface="PingFang SC Semibold" panose="020B0400000000000000" charset="-122"/>
-            </a:endParaRPr>
           </a:p>
         </p:txBody>
       </p:sp>
     </p:spTree>
     <p:custDataLst>
-      <p:tags r:id="rId2"/>
+      <p:tags r:id="rId1"/>
     </p:custDataLst>
   </p:cSld>
   <p:clrMapOvr>
@@ -4673,7 +4651,7 @@
         <p159:morph option="byObject"/>
       </p:transition>
     </mc:Choice>
-    <mc:Fallback>
+    <mc:Fallback xmlns="">
       <p:transition spd="slow" advClick="0" advTm="1000">
         <p:fade/>
       </p:transition>
@@ -4691,7 +4669,14 @@
         <p:cNvGrpSpPr/>
         <p:nvPr/>
       </p:nvGrpSpPr>
-      <p:grpSpPr/>
+      <p:grpSpPr>
+        <a:xfrm>
+          <a:off x="0" y="0"/>
+          <a:ext cx="0" cy="0"/>
+          <a:chOff x="0" y="0"/>
+          <a:chExt cx="0" cy="0"/>
+        </a:xfrm>
+      </p:grpSpPr>
       <p:pic>
         <p:nvPicPr>
           <p:cNvPr id="4" name="图片 3" descr="复杂场景"/>
@@ -4701,7 +4686,7 @@
           <p:nvPr/>
         </p:nvPicPr>
         <p:blipFill>
-          <a:blip r:embed="rId1"/>
+          <a:blip r:embed="rId4"/>
           <a:stretch>
             <a:fillRect/>
           </a:stretch>
@@ -5186,9 +5171,10 @@
         </p:style>
         <p:txBody>
           <a:bodyPr rtlCol="0" anchor="ctr"/>
+          <a:lstStyle/>
           <a:p>
             <a:pPr algn="ctr"/>
-            <a:endParaRPr lang="zh-CN" altLang="en-US"/>
+            <a:endParaRPr lang="zh-CN" altLang="en-US" dirty="0"/>
           </a:p>
         </p:txBody>
       </p:sp>
@@ -5444,6 +5430,7 @@
         </p:style>
         <p:txBody>
           <a:bodyPr rtlCol="0" anchor="ctr"/>
+          <a:lstStyle/>
           <a:p>
             <a:pPr algn="ctr"/>
             <a:endParaRPr lang="zh-CN" altLang="en-US"/>
@@ -5599,6 +5586,7 @@
         </p:style>
         <p:txBody>
           <a:bodyPr rtlCol="0" anchor="ctr"/>
+          <a:lstStyle/>
           <a:p>
             <a:pPr algn="ctr"/>
             <a:endParaRPr lang="zh-CN" altLang="en-US"/>
@@ -5625,9 +5613,10 @@
           <a:bodyPr wrap="square" rtlCol="0">
             <a:spAutoFit/>
           </a:bodyPr>
+          <a:lstStyle/>
           <a:p>
             <a:r>
-              <a:rPr lang="en-US" altLang="zh-CN" sz="2800" b="1">
+              <a:rPr lang="en-US" altLang="zh-CN" sz="2800" b="1" dirty="0">
                 <a:solidFill>
                   <a:srgbClr val="FF0000"/>
                 </a:solidFill>
@@ -5636,13 +5625,6 @@
               </a:rPr>
               <a:t>PERSON_1</a:t>
             </a:r>
-            <a:endParaRPr lang="en-US" altLang="zh-CN" sz="2800" b="1">
-              <a:solidFill>
-                <a:srgbClr val="FF0000"/>
-              </a:solidFill>
-              <a:latin typeface="PingFang SC Semibold" panose="020B0400000000000000" charset="-122"/>
-              <a:ea typeface="PingFang SC Semibold" panose="020B0400000000000000" charset="-122"/>
-            </a:endParaRPr>
           </a:p>
         </p:txBody>
       </p:sp>
@@ -5666,9 +5648,10 @@
           <a:bodyPr wrap="square" rtlCol="0">
             <a:spAutoFit/>
           </a:bodyPr>
+          <a:lstStyle/>
           <a:p>
             <a:r>
-              <a:rPr lang="en-US" altLang="zh-CN" sz="2800" b="1">
+              <a:rPr lang="en-US" altLang="zh-CN" sz="2800" b="1" dirty="0">
                 <a:solidFill>
                   <a:srgbClr val="FF0000"/>
                 </a:solidFill>
@@ -5677,13 +5660,6 @@
               </a:rPr>
               <a:t>PERSON_2</a:t>
             </a:r>
-            <a:endParaRPr lang="en-US" altLang="zh-CN" sz="2800" b="1">
-              <a:solidFill>
-                <a:srgbClr val="FF0000"/>
-              </a:solidFill>
-              <a:latin typeface="PingFang SC Semibold" panose="020B0400000000000000" charset="-122"/>
-              <a:ea typeface="PingFang SC Semibold" panose="020B0400000000000000" charset="-122"/>
-            </a:endParaRPr>
           </a:p>
         </p:txBody>
       </p:sp>
@@ -5707,6 +5683,7 @@
           <a:bodyPr wrap="square" rtlCol="0">
             <a:spAutoFit/>
           </a:bodyPr>
+          <a:lstStyle/>
           <a:p>
             <a:r>
               <a:rPr lang="en-US" altLang="zh-CN" sz="2800" b="1">
@@ -5718,19 +5695,12 @@
               </a:rPr>
               <a:t>KNIFE</a:t>
             </a:r>
-            <a:endParaRPr lang="en-US" altLang="zh-CN" sz="2800" b="1">
-              <a:solidFill>
-                <a:srgbClr val="FF0000"/>
-              </a:solidFill>
-              <a:latin typeface="PingFang SC Semibold" panose="020B0400000000000000" charset="-122"/>
-              <a:ea typeface="PingFang SC Semibold" panose="020B0400000000000000" charset="-122"/>
-            </a:endParaRPr>
           </a:p>
         </p:txBody>
       </p:sp>
     </p:spTree>
     <p:custDataLst>
-      <p:tags r:id="rId2"/>
+      <p:tags r:id="rId1"/>
     </p:custDataLst>
   </p:cSld>
   <p:clrMapOvr>
@@ -5739,8 +5709,132 @@
 </p:sld>
 </file>
 
+<file path=ppt/slides/slide3.xml><?xml version="1.0" encoding="utf-8"?>
+<p:sld xmlns:a="http://schemas.openxmlformats.org/drawingml/2006/main" xmlns:r="http://schemas.openxmlformats.org/officeDocument/2006/relationships" xmlns:p="http://schemas.openxmlformats.org/presentationml/2006/main">
+  <p:cSld>
+    <p:spTree>
+      <p:nvGrpSpPr>
+        <p:cNvPr id="1" name=""/>
+        <p:cNvGrpSpPr/>
+        <p:nvPr/>
+      </p:nvGrpSpPr>
+      <p:grpSpPr>
+        <a:xfrm>
+          <a:off x="0" y="0"/>
+          <a:ext cx="0" cy="0"/>
+          <a:chOff x="0" y="0"/>
+          <a:chExt cx="0" cy="0"/>
+        </a:xfrm>
+      </p:grpSpPr>
+      <p:sp>
+        <p:nvSpPr>
+          <p:cNvPr id="2" name="标题 1">
+            <a:extLst>
+              <a:ext uri="{FF2B5EF4-FFF2-40B4-BE49-F238E27FC236}">
+                <a16:creationId xmlns:a16="http://schemas.microsoft.com/office/drawing/2014/main" id="{120E6881-8BD2-B530-BDEF-2869D01593DE}"/>
+              </a:ext>
+            </a:extLst>
+          </p:cNvPr>
+          <p:cNvSpPr>
+            <a:spLocks noGrp="1"/>
+          </p:cNvSpPr>
+          <p:nvPr>
+            <p:ph type="title"/>
+          </p:nvPr>
+        </p:nvSpPr>
+        <p:spPr/>
+        <p:txBody>
+          <a:bodyPr/>
+          <a:lstStyle/>
+          <a:p>
+            <a:endParaRPr lang="zh-CN" altLang="en-US"/>
+          </a:p>
+        </p:txBody>
+      </p:sp>
+      <p:sp>
+        <p:nvSpPr>
+          <p:cNvPr id="3" name="内容占位符 2">
+            <a:extLst>
+              <a:ext uri="{FF2B5EF4-FFF2-40B4-BE49-F238E27FC236}">
+                <a16:creationId xmlns:a16="http://schemas.microsoft.com/office/drawing/2014/main" id="{C103E93C-5D97-5FE2-B612-3D4DBB384CCE}"/>
+              </a:ext>
+            </a:extLst>
+          </p:cNvPr>
+          <p:cNvSpPr>
+            <a:spLocks noGrp="1"/>
+          </p:cNvSpPr>
+          <p:nvPr>
+            <p:ph idx="1"/>
+          </p:nvPr>
+        </p:nvSpPr>
+        <p:spPr/>
+        <p:txBody>
+          <a:bodyPr/>
+          <a:lstStyle/>
+          <a:p>
+            <a:endParaRPr lang="zh-CN" altLang="en-US"/>
+          </a:p>
+        </p:txBody>
+      </p:sp>
+      <p:pic>
+        <p:nvPicPr>
+          <p:cNvPr id="5" name="图片 4">
+            <a:extLst>
+              <a:ext uri="{FF2B5EF4-FFF2-40B4-BE49-F238E27FC236}">
+                <a16:creationId xmlns:a16="http://schemas.microsoft.com/office/drawing/2014/main" id="{01609815-AA15-763D-C543-97B19E5EA6CD}"/>
+              </a:ext>
+            </a:extLst>
+          </p:cNvPr>
+          <p:cNvPicPr>
+            <a:picLocks noChangeAspect="1"/>
+          </p:cNvPicPr>
+          <p:nvPr/>
+        </p:nvPicPr>
+        <p:blipFill>
+          <a:blip r:embed="rId2"/>
+          <a:stretch>
+            <a:fillRect/>
+          </a:stretch>
+        </p:blipFill>
+        <p:spPr>
+          <a:xfrm>
+            <a:off x="0" y="0"/>
+            <a:ext cx="12192000" cy="6858000"/>
+          </a:xfrm>
+          <a:prstGeom prst="rect">
+            <a:avLst/>
+          </a:prstGeom>
+        </p:spPr>
+      </p:pic>
+    </p:spTree>
+    <p:extLst>
+      <p:ext uri="{BB962C8B-B14F-4D97-AF65-F5344CB8AC3E}">
+        <p14:creationId xmlns:p14="http://schemas.microsoft.com/office/powerpoint/2010/main" val="3926526231"/>
+      </p:ext>
+    </p:extLst>
+  </p:cSld>
+  <p:clrMapOvr>
+    <a:masterClrMapping/>
+  </p:clrMapOvr>
+</p:sld>
+</file>
+
 <file path=ppt/tags/tag1.xml><?xml version="1.0" encoding="utf-8"?>
-<p:tagLst xmlns:p="http://schemas.openxmlformats.org/presentationml/2006/main">
+<p:tagLst xmlns:a="http://schemas.openxmlformats.org/drawingml/2006/main" xmlns:r="http://schemas.openxmlformats.org/officeDocument/2006/relationships" xmlns:p="http://schemas.openxmlformats.org/presentationml/2006/main">
+  <p:tag name="KSO_WM_TEMPLATE_THUMBS_INDEX" val="1、4、7、12、13、14、15、16、17、18、20、24、25、28、33、36、40、43、44"/>
+  <p:tag name="KSO_WM_TEMPLATE_SUBCATEGORY" val="19"/>
+  <p:tag name="KSO_WM_TAG_VERSION" val="1.0"/>
+  <p:tag name="KSO_WM_BEAUTIFY_FLAG" val="#wm#"/>
+  <p:tag name="KSO_WM_TEMPLATE_CATEGORY" val="custom"/>
+  <p:tag name="KSO_WM_TEMPLATE_INDEX" val="20205081"/>
+  <p:tag name="KSO_WM_TEMPLATE_MASTER_TYPE" val="0"/>
+  <p:tag name="KSO_WM_TEMPLATE_COLOR_TYPE" val="1"/>
+  <p:tag name="KSO_WM_UNIT_SHOW_EDIT_AREA_INDICATION" val="1"/>
+</p:tagLst>
+</file>
+
+<file path=ppt/tags/tag10.xml><?xml version="1.0" encoding="utf-8"?>
+<p:tagLst xmlns:a="http://schemas.openxmlformats.org/drawingml/2006/main" xmlns:r="http://schemas.openxmlformats.org/officeDocument/2006/relationships" xmlns:p="http://schemas.openxmlformats.org/presentationml/2006/main">
   <p:tag name="KSO_WM_UNIT_HIGHLIGHT" val="0"/>
   <p:tag name="KSO_WM_UNIT_COMPATIBLE" val="0"/>
   <p:tag name="KSO_WM_UNIT_DIAGRAM_ISNUMVISUAL" val="0"/>
@@ -5752,8 +5846,21 @@
 </p:tagLst>
 </file>
 
-<file path=ppt/tags/tag10.xml><?xml version="1.0" encoding="utf-8"?>
-<p:tagLst xmlns:p="http://schemas.openxmlformats.org/presentationml/2006/main">
+<file path=ppt/tags/tag11.xml><?xml version="1.0" encoding="utf-8"?>
+<p:tagLst xmlns:a="http://schemas.openxmlformats.org/drawingml/2006/main" xmlns:r="http://schemas.openxmlformats.org/officeDocument/2006/relationships" xmlns:p="http://schemas.openxmlformats.org/presentationml/2006/main">
+  <p:tag name="KSO_WM_UNIT_HIGHLIGHT" val="0"/>
+  <p:tag name="KSO_WM_UNIT_COMPATIBLE" val="0"/>
+  <p:tag name="KSO_WM_UNIT_DIAGRAM_ISNUMVISUAL" val="0"/>
+  <p:tag name="KSO_WM_UNIT_DIAGRAM_ISREFERUNIT" val="0"/>
+  <p:tag name="KSO_WM_UNIT_ID" val="_1**"/>
+  <p:tag name="KSO_WM_UNIT_LAYERLEVEL" val="1"/>
+  <p:tag name="KSO_WM_TAG_VERSION" val="1.0"/>
+  <p:tag name="KSO_WM_BEAUTIFY_FLAG" val="#wm#"/>
+</p:tagLst>
+</file>
+
+<file path=ppt/tags/tag12.xml><?xml version="1.0" encoding="utf-8"?>
+<p:tagLst xmlns:a="http://schemas.openxmlformats.org/drawingml/2006/main" xmlns:r="http://schemas.openxmlformats.org/officeDocument/2006/relationships" xmlns:p="http://schemas.openxmlformats.org/presentationml/2006/main">
   <p:tag name="KSO_WM_UNIT_HIGHLIGHT" val="0"/>
   <p:tag name="KSO_WM_UNIT_COMPATIBLE" val="0"/>
   <p:tag name="KSO_WM_UNIT_DIAGRAM_ISNUMVISUAL" val="0"/>
@@ -5765,8 +5872,60 @@
 </p:tagLst>
 </file>
 
-<file path=ppt/tags/tag11.xml><?xml version="1.0" encoding="utf-8"?>
-<p:tagLst xmlns:p="http://schemas.openxmlformats.org/presentationml/2006/main">
+<file path=ppt/tags/tag13.xml><?xml version="1.0" encoding="utf-8"?>
+<p:tagLst xmlns:a="http://schemas.openxmlformats.org/drawingml/2006/main" xmlns:r="http://schemas.openxmlformats.org/officeDocument/2006/relationships" xmlns:p="http://schemas.openxmlformats.org/presentationml/2006/main">
+  <p:tag name="KSO_WM_UNIT_HIGHLIGHT" val="0"/>
+  <p:tag name="KSO_WM_UNIT_COMPATIBLE" val="0"/>
+  <p:tag name="KSO_WM_UNIT_DIAGRAM_ISNUMVISUAL" val="0"/>
+  <p:tag name="KSO_WM_UNIT_DIAGRAM_ISREFERUNIT" val="0"/>
+  <p:tag name="KSO_WM_UNIT_ID" val="_2**"/>
+  <p:tag name="KSO_WM_UNIT_LAYERLEVEL" val="1"/>
+  <p:tag name="KSO_WM_TAG_VERSION" val="1.0"/>
+  <p:tag name="KSO_WM_BEAUTIFY_FLAG" val="#wm#"/>
+</p:tagLst>
+</file>
+
+<file path=ppt/tags/tag14.xml><?xml version="1.0" encoding="utf-8"?>
+<p:tagLst xmlns:a="http://schemas.openxmlformats.org/drawingml/2006/main" xmlns:r="http://schemas.openxmlformats.org/officeDocument/2006/relationships" xmlns:p="http://schemas.openxmlformats.org/presentationml/2006/main">
+  <p:tag name="KSO_WM_UNIT_HIGHLIGHT" val="0"/>
+  <p:tag name="KSO_WM_UNIT_COMPATIBLE" val="0"/>
+  <p:tag name="KSO_WM_UNIT_DIAGRAM_ISNUMVISUAL" val="0"/>
+  <p:tag name="KSO_WM_UNIT_DIAGRAM_ISREFERUNIT" val="0"/>
+  <p:tag name="KSO_WM_UNIT_ID" val="_2**"/>
+  <p:tag name="KSO_WM_UNIT_LAYERLEVEL" val="1"/>
+  <p:tag name="KSO_WM_TAG_VERSION" val="1.0"/>
+  <p:tag name="KSO_WM_BEAUTIFY_FLAG" val="#wm#"/>
+</p:tagLst>
+</file>
+
+<file path=ppt/tags/tag15.xml><?xml version="1.0" encoding="utf-8"?>
+<p:tagLst xmlns:a="http://schemas.openxmlformats.org/drawingml/2006/main" xmlns:r="http://schemas.openxmlformats.org/officeDocument/2006/relationships" xmlns:p="http://schemas.openxmlformats.org/presentationml/2006/main">
+  <p:tag name="KSO_WM_UNIT_HIGHLIGHT" val="0"/>
+  <p:tag name="KSO_WM_UNIT_COMPATIBLE" val="0"/>
+  <p:tag name="KSO_WM_UNIT_DIAGRAM_ISNUMVISUAL" val="0"/>
+  <p:tag name="KSO_WM_UNIT_DIAGRAM_ISREFERUNIT" val="0"/>
+  <p:tag name="KSO_WM_UNIT_ID" val="_2**"/>
+  <p:tag name="KSO_WM_UNIT_LAYERLEVEL" val="1"/>
+  <p:tag name="KSO_WM_TAG_VERSION" val="1.0"/>
+  <p:tag name="KSO_WM_BEAUTIFY_FLAG" val="#wm#"/>
+</p:tagLst>
+</file>
+
+<file path=ppt/tags/tag16.xml><?xml version="1.0" encoding="utf-8"?>
+<p:tagLst xmlns:a="http://schemas.openxmlformats.org/drawingml/2006/main" xmlns:r="http://schemas.openxmlformats.org/officeDocument/2006/relationships" xmlns:p="http://schemas.openxmlformats.org/presentationml/2006/main">
+  <p:tag name="KSO_WM_UNIT_HIGHLIGHT" val="0"/>
+  <p:tag name="KSO_WM_UNIT_COMPATIBLE" val="0"/>
+  <p:tag name="KSO_WM_UNIT_DIAGRAM_ISNUMVISUAL" val="0"/>
+  <p:tag name="KSO_WM_UNIT_DIAGRAM_ISREFERUNIT" val="0"/>
+  <p:tag name="KSO_WM_UNIT_ID" val="_2**"/>
+  <p:tag name="KSO_WM_UNIT_LAYERLEVEL" val="1"/>
+  <p:tag name="KSO_WM_TAG_VERSION" val="1.0"/>
+  <p:tag name="KSO_WM_BEAUTIFY_FLAG" val="#wm#"/>
+</p:tagLst>
+</file>
+
+<file path=ppt/tags/tag17.xml><?xml version="1.0" encoding="utf-8"?>
+<p:tagLst xmlns:a="http://schemas.openxmlformats.org/drawingml/2006/main" xmlns:r="http://schemas.openxmlformats.org/officeDocument/2006/relationships" xmlns:p="http://schemas.openxmlformats.org/presentationml/2006/main">
   <p:tag name="KSO_WM_UNIT_HIGHLIGHT" val="0"/>
   <p:tag name="KSO_WM_UNIT_COMPATIBLE" val="0"/>
   <p:tag name="KSO_WM_UNIT_DIAGRAM_ISNUMVISUAL" val="0"/>
@@ -5778,8 +5937,8 @@
 </p:tagLst>
 </file>
 
-<file path=ppt/tags/tag12.xml><?xml version="1.0" encoding="utf-8"?>
-<p:tagLst xmlns:p="http://schemas.openxmlformats.org/presentationml/2006/main">
+<file path=ppt/tags/tag18.xml><?xml version="1.0" encoding="utf-8"?>
+<p:tagLst xmlns:a="http://schemas.openxmlformats.org/drawingml/2006/main" xmlns:r="http://schemas.openxmlformats.org/officeDocument/2006/relationships" xmlns:p="http://schemas.openxmlformats.org/presentationml/2006/main">
   <p:tag name="KSO_WM_UNIT_HIGHLIGHT" val="0"/>
   <p:tag name="KSO_WM_UNIT_COMPATIBLE" val="0"/>
   <p:tag name="KSO_WM_UNIT_DIAGRAM_ISNUMVISUAL" val="0"/>
@@ -5791,8 +5950,8 @@
 </p:tagLst>
 </file>
 
-<file path=ppt/tags/tag13.xml><?xml version="1.0" encoding="utf-8"?>
-<p:tagLst xmlns:p="http://schemas.openxmlformats.org/presentationml/2006/main">
+<file path=ppt/tags/tag19.xml><?xml version="1.0" encoding="utf-8"?>
+<p:tagLst xmlns:a="http://schemas.openxmlformats.org/drawingml/2006/main" xmlns:r="http://schemas.openxmlformats.org/officeDocument/2006/relationships" xmlns:p="http://schemas.openxmlformats.org/presentationml/2006/main">
   <p:tag name="KSO_WM_UNIT_HIGHLIGHT" val="0"/>
   <p:tag name="KSO_WM_UNIT_COMPATIBLE" val="0"/>
   <p:tag name="KSO_WM_UNIT_DIAGRAM_ISNUMVISUAL" val="0"/>
@@ -5804,619 +5963,8 @@
 </p:tagLst>
 </file>
 
-<file path=ppt/tags/tag14.xml><?xml version="1.0" encoding="utf-8"?>
-<p:tagLst xmlns:p="http://schemas.openxmlformats.org/presentationml/2006/main">
-  <p:tag name="KSO_WM_UNIT_HIGHLIGHT" val="0"/>
-  <p:tag name="KSO_WM_UNIT_COMPATIBLE" val="0"/>
-  <p:tag name="KSO_WM_UNIT_DIAGRAM_ISNUMVISUAL" val="0"/>
-  <p:tag name="KSO_WM_UNIT_DIAGRAM_ISREFERUNIT" val="0"/>
-  <p:tag name="KSO_WM_UNIT_ID" val="_3**"/>
-  <p:tag name="KSO_WM_UNIT_LAYERLEVEL" val="1"/>
-  <p:tag name="KSO_WM_TAG_VERSION" val="1.0"/>
-  <p:tag name="KSO_WM_BEAUTIFY_FLAG" val="#wm#"/>
-</p:tagLst>
-</file>
-
-<file path=ppt/tags/tag15.xml><?xml version="1.0" encoding="utf-8"?>
-<p:tagLst xmlns:p="http://schemas.openxmlformats.org/presentationml/2006/main">
-  <p:tag name="KSO_WM_UNIT_HIGHLIGHT" val="0"/>
-  <p:tag name="KSO_WM_UNIT_COMPATIBLE" val="0"/>
-  <p:tag name="KSO_WM_UNIT_DIAGRAM_ISNUMVISUAL" val="0"/>
-  <p:tag name="KSO_WM_UNIT_DIAGRAM_ISREFERUNIT" val="0"/>
-  <p:tag name="KSO_WM_UNIT_ID" val="_3**"/>
-  <p:tag name="KSO_WM_UNIT_LAYERLEVEL" val="1"/>
-  <p:tag name="KSO_WM_TAG_VERSION" val="1.0"/>
-  <p:tag name="KSO_WM_BEAUTIFY_FLAG" val="#wm#"/>
-</p:tagLst>
-</file>
-
-<file path=ppt/tags/tag16.xml><?xml version="1.0" encoding="utf-8"?>
-<p:tagLst xmlns:p="http://schemas.openxmlformats.org/presentationml/2006/main">
-  <p:tag name="KSO_WM_UNIT_HIGHLIGHT" val="0"/>
-  <p:tag name="KSO_WM_UNIT_COMPATIBLE" val="0"/>
-  <p:tag name="KSO_WM_UNIT_DIAGRAM_ISNUMVISUAL" val="0"/>
-  <p:tag name="KSO_WM_UNIT_DIAGRAM_ISREFERUNIT" val="0"/>
-  <p:tag name="KSO_WM_UNIT_ID" val="_4**"/>
-  <p:tag name="KSO_WM_UNIT_LAYERLEVEL" val="1"/>
-  <p:tag name="KSO_WM_TAG_VERSION" val="1.0"/>
-  <p:tag name="KSO_WM_BEAUTIFY_FLAG" val="#wm#"/>
-</p:tagLst>
-</file>
-
-<file path=ppt/tags/tag17.xml><?xml version="1.0" encoding="utf-8"?>
-<p:tagLst xmlns:p="http://schemas.openxmlformats.org/presentationml/2006/main">
-  <p:tag name="KSO_WM_UNIT_HIGHLIGHT" val="0"/>
-  <p:tag name="KSO_WM_UNIT_COMPATIBLE" val="0"/>
-  <p:tag name="KSO_WM_UNIT_DIAGRAM_ISNUMVISUAL" val="0"/>
-  <p:tag name="KSO_WM_UNIT_DIAGRAM_ISREFERUNIT" val="0"/>
-  <p:tag name="KSO_WM_UNIT_ID" val="_4**"/>
-  <p:tag name="KSO_WM_UNIT_LAYERLEVEL" val="1"/>
-  <p:tag name="KSO_WM_TAG_VERSION" val="1.0"/>
-  <p:tag name="KSO_WM_BEAUTIFY_FLAG" val="#wm#"/>
-</p:tagLst>
-</file>
-
-<file path=ppt/tags/tag18.xml><?xml version="1.0" encoding="utf-8"?>
-<p:tagLst xmlns:p="http://schemas.openxmlformats.org/presentationml/2006/main">
-  <p:tag name="KSO_WM_UNIT_HIGHLIGHT" val="0"/>
-  <p:tag name="KSO_WM_UNIT_COMPATIBLE" val="0"/>
-  <p:tag name="KSO_WM_UNIT_DIAGRAM_ISNUMVISUAL" val="0"/>
-  <p:tag name="KSO_WM_UNIT_DIAGRAM_ISREFERUNIT" val="0"/>
-  <p:tag name="KSO_WM_UNIT_ID" val="_4**"/>
-  <p:tag name="KSO_WM_UNIT_LAYERLEVEL" val="1"/>
-  <p:tag name="KSO_WM_TAG_VERSION" val="1.0"/>
-  <p:tag name="KSO_WM_BEAUTIFY_FLAG" val="#wm#"/>
-</p:tagLst>
-</file>
-
-<file path=ppt/tags/tag19.xml><?xml version="1.0" encoding="utf-8"?>
-<p:tagLst xmlns:p="http://schemas.openxmlformats.org/presentationml/2006/main">
-  <p:tag name="KSO_WM_UNIT_HIGHLIGHT" val="0"/>
-  <p:tag name="KSO_WM_UNIT_COMPATIBLE" val="0"/>
-  <p:tag name="KSO_WM_UNIT_DIAGRAM_ISNUMVISUAL" val="0"/>
-  <p:tag name="KSO_WM_UNIT_DIAGRAM_ISREFERUNIT" val="0"/>
-  <p:tag name="KSO_WM_UNIT_ID" val="_4**"/>
-  <p:tag name="KSO_WM_UNIT_LAYERLEVEL" val="1"/>
-  <p:tag name="KSO_WM_TAG_VERSION" val="1.0"/>
-  <p:tag name="KSO_WM_BEAUTIFY_FLAG" val="#wm#"/>
-</p:tagLst>
-</file>
-
 <file path=ppt/tags/tag2.xml><?xml version="1.0" encoding="utf-8"?>
-<p:tagLst xmlns:p="http://schemas.openxmlformats.org/presentationml/2006/main">
-  <p:tag name="KSO_WM_UNIT_HIGHLIGHT" val="0"/>
-  <p:tag name="KSO_WM_UNIT_COMPATIBLE" val="0"/>
-  <p:tag name="KSO_WM_UNIT_DIAGRAM_ISNUMVISUAL" val="0"/>
-  <p:tag name="KSO_WM_UNIT_DIAGRAM_ISREFERUNIT" val="0"/>
-  <p:tag name="KSO_WM_UNIT_ID" val="_1**"/>
-  <p:tag name="KSO_WM_UNIT_LAYERLEVEL" val="1"/>
-  <p:tag name="KSO_WM_TAG_VERSION" val="1.0"/>
-  <p:tag name="KSO_WM_BEAUTIFY_FLAG" val="#wm#"/>
-</p:tagLst>
-</file>
-
-<file path=ppt/tags/tag20.xml><?xml version="1.0" encoding="utf-8"?>
-<p:tagLst xmlns:p="http://schemas.openxmlformats.org/presentationml/2006/main">
-  <p:tag name="KSO_WM_UNIT_HIGHLIGHT" val="0"/>
-  <p:tag name="KSO_WM_UNIT_COMPATIBLE" val="0"/>
-  <p:tag name="KSO_WM_UNIT_DIAGRAM_ISNUMVISUAL" val="0"/>
-  <p:tag name="KSO_WM_UNIT_DIAGRAM_ISREFERUNIT" val="0"/>
-  <p:tag name="KSO_WM_UNIT_ID" val="_4**"/>
-  <p:tag name="KSO_WM_UNIT_LAYERLEVEL" val="1"/>
-  <p:tag name="KSO_WM_TAG_VERSION" val="1.0"/>
-  <p:tag name="KSO_WM_BEAUTIFY_FLAG" val="#wm#"/>
-</p:tagLst>
-</file>
-
-<file path=ppt/tags/tag21.xml><?xml version="1.0" encoding="utf-8"?>
-<p:tagLst xmlns:p="http://schemas.openxmlformats.org/presentationml/2006/main">
-  <p:tag name="KSO_WM_UNIT_HIGHLIGHT" val="0"/>
-  <p:tag name="KSO_WM_UNIT_COMPATIBLE" val="0"/>
-  <p:tag name="KSO_WM_UNIT_DIAGRAM_ISNUMVISUAL" val="0"/>
-  <p:tag name="KSO_WM_UNIT_DIAGRAM_ISREFERUNIT" val="0"/>
-  <p:tag name="KSO_WM_UNIT_ID" val="_4**"/>
-  <p:tag name="KSO_WM_UNIT_LAYERLEVEL" val="1"/>
-  <p:tag name="KSO_WM_TAG_VERSION" val="1.0"/>
-  <p:tag name="KSO_WM_BEAUTIFY_FLAG" val="#wm#"/>
-</p:tagLst>
-</file>
-
-<file path=ppt/tags/tag22.xml><?xml version="1.0" encoding="utf-8"?>
-<p:tagLst xmlns:p="http://schemas.openxmlformats.org/presentationml/2006/main">
-  <p:tag name="KSO_WM_UNIT_HIGHLIGHT" val="0"/>
-  <p:tag name="KSO_WM_UNIT_COMPATIBLE" val="0"/>
-  <p:tag name="KSO_WM_UNIT_DIAGRAM_ISNUMVISUAL" val="0"/>
-  <p:tag name="KSO_WM_UNIT_DIAGRAM_ISREFERUNIT" val="0"/>
-  <p:tag name="KSO_WM_UNIT_ID" val="_5**"/>
-  <p:tag name="KSO_WM_UNIT_LAYERLEVEL" val="1"/>
-  <p:tag name="KSO_WM_TAG_VERSION" val="1.0"/>
-  <p:tag name="KSO_WM_BEAUTIFY_FLAG" val="#wm#"/>
-</p:tagLst>
-</file>
-
-<file path=ppt/tags/tag23.xml><?xml version="1.0" encoding="utf-8"?>
-<p:tagLst xmlns:p="http://schemas.openxmlformats.org/presentationml/2006/main">
-  <p:tag name="KSO_WM_UNIT_HIGHLIGHT" val="0"/>
-  <p:tag name="KSO_WM_UNIT_COMPATIBLE" val="0"/>
-  <p:tag name="KSO_WM_UNIT_DIAGRAM_ISNUMVISUAL" val="0"/>
-  <p:tag name="KSO_WM_UNIT_DIAGRAM_ISREFERUNIT" val="0"/>
-  <p:tag name="KSO_WM_UNIT_ID" val="_5**"/>
-  <p:tag name="KSO_WM_UNIT_LAYERLEVEL" val="1"/>
-  <p:tag name="KSO_WM_TAG_VERSION" val="1.0"/>
-  <p:tag name="KSO_WM_BEAUTIFY_FLAG" val="#wm#"/>
-</p:tagLst>
-</file>
-
-<file path=ppt/tags/tag24.xml><?xml version="1.0" encoding="utf-8"?>
-<p:tagLst xmlns:p="http://schemas.openxmlformats.org/presentationml/2006/main">
-  <p:tag name="KSO_WM_UNIT_HIGHLIGHT" val="0"/>
-  <p:tag name="KSO_WM_UNIT_COMPATIBLE" val="0"/>
-  <p:tag name="KSO_WM_UNIT_DIAGRAM_ISNUMVISUAL" val="0"/>
-  <p:tag name="KSO_WM_UNIT_DIAGRAM_ISREFERUNIT" val="0"/>
-  <p:tag name="KSO_WM_UNIT_ID" val="_5**"/>
-  <p:tag name="KSO_WM_UNIT_LAYERLEVEL" val="1"/>
-  <p:tag name="KSO_WM_TAG_VERSION" val="1.0"/>
-  <p:tag name="KSO_WM_BEAUTIFY_FLAG" val="#wm#"/>
-</p:tagLst>
-</file>
-
-<file path=ppt/tags/tag25.xml><?xml version="1.0" encoding="utf-8"?>
-<p:tagLst xmlns:p="http://schemas.openxmlformats.org/presentationml/2006/main">
-  <p:tag name="KSO_WM_UNIT_HIGHLIGHT" val="0"/>
-  <p:tag name="KSO_WM_UNIT_COMPATIBLE" val="0"/>
-  <p:tag name="KSO_WM_UNIT_DIAGRAM_ISNUMVISUAL" val="0"/>
-  <p:tag name="KSO_WM_UNIT_DIAGRAM_ISREFERUNIT" val="0"/>
-  <p:tag name="KSO_WM_UNIT_ID" val="_5**"/>
-  <p:tag name="KSO_WM_UNIT_LAYERLEVEL" val="1"/>
-  <p:tag name="KSO_WM_TAG_VERSION" val="1.0"/>
-  <p:tag name="KSO_WM_BEAUTIFY_FLAG" val="#wm#"/>
-</p:tagLst>
-</file>
-
-<file path=ppt/tags/tag26.xml><?xml version="1.0" encoding="utf-8"?>
-<p:tagLst xmlns:p="http://schemas.openxmlformats.org/presentationml/2006/main">
-  <p:tag name="KSO_WM_UNIT_HIGHLIGHT" val="0"/>
-  <p:tag name="KSO_WM_UNIT_COMPATIBLE" val="0"/>
-  <p:tag name="KSO_WM_UNIT_DIAGRAM_ISNUMVISUAL" val="0"/>
-  <p:tag name="KSO_WM_UNIT_DIAGRAM_ISREFERUNIT" val="0"/>
-  <p:tag name="KSO_WM_UNIT_ID" val="_5**"/>
-  <p:tag name="KSO_WM_UNIT_LAYERLEVEL" val="1"/>
-  <p:tag name="KSO_WM_TAG_VERSION" val="1.0"/>
-  <p:tag name="KSO_WM_BEAUTIFY_FLAG" val="#wm#"/>
-</p:tagLst>
-</file>
-
-<file path=ppt/tags/tag27.xml><?xml version="1.0" encoding="utf-8"?>
-<p:tagLst xmlns:p="http://schemas.openxmlformats.org/presentationml/2006/main">
-  <p:tag name="KSO_WM_UNIT_HIGHLIGHT" val="0"/>
-  <p:tag name="KSO_WM_UNIT_COMPATIBLE" val="0"/>
-  <p:tag name="KSO_WM_UNIT_DIAGRAM_ISNUMVISUAL" val="0"/>
-  <p:tag name="KSO_WM_UNIT_DIAGRAM_ISREFERUNIT" val="0"/>
-  <p:tag name="KSO_WM_UNIT_ID" val="_5**"/>
-  <p:tag name="KSO_WM_UNIT_LAYERLEVEL" val="1"/>
-  <p:tag name="KSO_WM_TAG_VERSION" val="1.0"/>
-  <p:tag name="KSO_WM_BEAUTIFY_FLAG" val="#wm#"/>
-</p:tagLst>
-</file>
-
-<file path=ppt/tags/tag28.xml><?xml version="1.0" encoding="utf-8"?>
-<p:tagLst xmlns:p="http://schemas.openxmlformats.org/presentationml/2006/main">
-  <p:tag name="KSO_WM_UNIT_HIGHLIGHT" val="0"/>
-  <p:tag name="KSO_WM_UNIT_COMPATIBLE" val="0"/>
-  <p:tag name="KSO_WM_UNIT_DIAGRAM_ISNUMVISUAL" val="0"/>
-  <p:tag name="KSO_WM_UNIT_DIAGRAM_ISREFERUNIT" val="0"/>
-  <p:tag name="KSO_WM_UNIT_ID" val="_5**"/>
-  <p:tag name="KSO_WM_UNIT_LAYERLEVEL" val="1"/>
-  <p:tag name="KSO_WM_TAG_VERSION" val="1.0"/>
-  <p:tag name="KSO_WM_BEAUTIFY_FLAG" val="#wm#"/>
-</p:tagLst>
-</file>
-
-<file path=ppt/tags/tag29.xml><?xml version="1.0" encoding="utf-8"?>
-<p:tagLst xmlns:p="http://schemas.openxmlformats.org/presentationml/2006/main">
-  <p:tag name="KSO_WM_UNIT_HIGHLIGHT" val="0"/>
-  <p:tag name="KSO_WM_UNIT_COMPATIBLE" val="0"/>
-  <p:tag name="KSO_WM_UNIT_DIAGRAM_ISNUMVISUAL" val="0"/>
-  <p:tag name="KSO_WM_UNIT_DIAGRAM_ISREFERUNIT" val="0"/>
-  <p:tag name="KSO_WM_UNIT_ID" val="_5**"/>
-  <p:tag name="KSO_WM_UNIT_LAYERLEVEL" val="1"/>
-  <p:tag name="KSO_WM_TAG_VERSION" val="1.0"/>
-  <p:tag name="KSO_WM_BEAUTIFY_FLAG" val="#wm#"/>
-</p:tagLst>
-</file>
-
-<file path=ppt/tags/tag3.xml><?xml version="1.0" encoding="utf-8"?>
-<p:tagLst xmlns:p="http://schemas.openxmlformats.org/presentationml/2006/main">
-  <p:tag name="KSO_WM_UNIT_HIGHLIGHT" val="0"/>
-  <p:tag name="KSO_WM_UNIT_COMPATIBLE" val="0"/>
-  <p:tag name="KSO_WM_UNIT_DIAGRAM_ISNUMVISUAL" val="0"/>
-  <p:tag name="KSO_WM_UNIT_DIAGRAM_ISREFERUNIT" val="0"/>
-  <p:tag name="KSO_WM_UNIT_ID" val="_1**"/>
-  <p:tag name="KSO_WM_UNIT_LAYERLEVEL" val="1"/>
-  <p:tag name="KSO_WM_TAG_VERSION" val="1.0"/>
-  <p:tag name="KSO_WM_BEAUTIFY_FLAG" val="#wm#"/>
-</p:tagLst>
-</file>
-
-<file path=ppt/tags/tag30.xml><?xml version="1.0" encoding="utf-8"?>
-<p:tagLst xmlns:p="http://schemas.openxmlformats.org/presentationml/2006/main">
-  <p:tag name="KSO_WM_UNIT_HIGHLIGHT" val="0"/>
-  <p:tag name="KSO_WM_UNIT_COMPATIBLE" val="0"/>
-  <p:tag name="KSO_WM_UNIT_DIAGRAM_ISNUMVISUAL" val="0"/>
-  <p:tag name="KSO_WM_UNIT_DIAGRAM_ISREFERUNIT" val="0"/>
-  <p:tag name="KSO_WM_UNIT_ID" val="_6**"/>
-  <p:tag name="KSO_WM_UNIT_LAYERLEVEL" val="1"/>
-  <p:tag name="KSO_WM_TAG_VERSION" val="1.0"/>
-  <p:tag name="KSO_WM_BEAUTIFY_FLAG" val="#wm#"/>
-</p:tagLst>
-</file>
-
-<file path=ppt/tags/tag31.xml><?xml version="1.0" encoding="utf-8"?>
-<p:tagLst xmlns:p="http://schemas.openxmlformats.org/presentationml/2006/main">
-  <p:tag name="KSO_WM_UNIT_HIGHLIGHT" val="0"/>
-  <p:tag name="KSO_WM_UNIT_COMPATIBLE" val="0"/>
-  <p:tag name="KSO_WM_UNIT_DIAGRAM_ISNUMVISUAL" val="0"/>
-  <p:tag name="KSO_WM_UNIT_DIAGRAM_ISREFERUNIT" val="0"/>
-  <p:tag name="KSO_WM_UNIT_ID" val="_6**"/>
-  <p:tag name="KSO_WM_UNIT_LAYERLEVEL" val="1"/>
-  <p:tag name="KSO_WM_TAG_VERSION" val="1.0"/>
-  <p:tag name="KSO_WM_BEAUTIFY_FLAG" val="#wm#"/>
-</p:tagLst>
-</file>
-
-<file path=ppt/tags/tag32.xml><?xml version="1.0" encoding="utf-8"?>
-<p:tagLst xmlns:p="http://schemas.openxmlformats.org/presentationml/2006/main">
-  <p:tag name="KSO_WM_UNIT_HIGHLIGHT" val="0"/>
-  <p:tag name="KSO_WM_UNIT_COMPATIBLE" val="0"/>
-  <p:tag name="KSO_WM_UNIT_DIAGRAM_ISNUMVISUAL" val="0"/>
-  <p:tag name="KSO_WM_UNIT_DIAGRAM_ISREFERUNIT" val="0"/>
-  <p:tag name="KSO_WM_UNIT_ID" val="_6**"/>
-  <p:tag name="KSO_WM_UNIT_LAYERLEVEL" val="1"/>
-  <p:tag name="KSO_WM_TAG_VERSION" val="1.0"/>
-  <p:tag name="KSO_WM_BEAUTIFY_FLAG" val="#wm#"/>
-</p:tagLst>
-</file>
-
-<file path=ppt/tags/tag33.xml><?xml version="1.0" encoding="utf-8"?>
-<p:tagLst xmlns:p="http://schemas.openxmlformats.org/presentationml/2006/main">
-  <p:tag name="KSO_WM_UNIT_HIGHLIGHT" val="0"/>
-  <p:tag name="KSO_WM_UNIT_COMPATIBLE" val="0"/>
-  <p:tag name="KSO_WM_UNIT_DIAGRAM_ISNUMVISUAL" val="0"/>
-  <p:tag name="KSO_WM_UNIT_DIAGRAM_ISREFERUNIT" val="0"/>
-  <p:tag name="KSO_WM_UNIT_ID" val="_6**"/>
-  <p:tag name="KSO_WM_UNIT_LAYERLEVEL" val="1"/>
-  <p:tag name="KSO_WM_TAG_VERSION" val="1.0"/>
-  <p:tag name="KSO_WM_BEAUTIFY_FLAG" val="#wm#"/>
-</p:tagLst>
-</file>
-
-<file path=ppt/tags/tag34.xml><?xml version="1.0" encoding="utf-8"?>
-<p:tagLst xmlns:p="http://schemas.openxmlformats.org/presentationml/2006/main">
-  <p:tag name="KSO_WM_UNIT_HIGHLIGHT" val="0"/>
-  <p:tag name="KSO_WM_UNIT_COMPATIBLE" val="0"/>
-  <p:tag name="KSO_WM_UNIT_DIAGRAM_ISNUMVISUAL" val="0"/>
-  <p:tag name="KSO_WM_UNIT_DIAGRAM_ISREFERUNIT" val="0"/>
-  <p:tag name="KSO_WM_UNIT_ID" val="_7**"/>
-  <p:tag name="KSO_WM_UNIT_LAYERLEVEL" val="1"/>
-  <p:tag name="KSO_WM_TAG_VERSION" val="1.0"/>
-  <p:tag name="KSO_WM_BEAUTIFY_FLAG" val="#wm#"/>
-</p:tagLst>
-</file>
-
-<file path=ppt/tags/tag35.xml><?xml version="1.0" encoding="utf-8"?>
-<p:tagLst xmlns:p="http://schemas.openxmlformats.org/presentationml/2006/main">
-  <p:tag name="KSO_WM_UNIT_HIGHLIGHT" val="0"/>
-  <p:tag name="KSO_WM_UNIT_COMPATIBLE" val="0"/>
-  <p:tag name="KSO_WM_UNIT_DIAGRAM_ISNUMVISUAL" val="0"/>
-  <p:tag name="KSO_WM_UNIT_DIAGRAM_ISREFERUNIT" val="0"/>
-  <p:tag name="KSO_WM_UNIT_ID" val="_7**"/>
-  <p:tag name="KSO_WM_UNIT_LAYERLEVEL" val="1"/>
-  <p:tag name="KSO_WM_TAG_VERSION" val="1.0"/>
-  <p:tag name="KSO_WM_BEAUTIFY_FLAG" val="#wm#"/>
-</p:tagLst>
-</file>
-
-<file path=ppt/tags/tag36.xml><?xml version="1.0" encoding="utf-8"?>
-<p:tagLst xmlns:p="http://schemas.openxmlformats.org/presentationml/2006/main">
-  <p:tag name="KSO_WM_UNIT_HIGHLIGHT" val="0"/>
-  <p:tag name="KSO_WM_UNIT_COMPATIBLE" val="0"/>
-  <p:tag name="KSO_WM_UNIT_DIAGRAM_ISNUMVISUAL" val="0"/>
-  <p:tag name="KSO_WM_UNIT_DIAGRAM_ISREFERUNIT" val="0"/>
-  <p:tag name="KSO_WM_UNIT_ID" val="_7**"/>
-  <p:tag name="KSO_WM_UNIT_LAYERLEVEL" val="1"/>
-  <p:tag name="KSO_WM_TAG_VERSION" val="1.0"/>
-  <p:tag name="KSO_WM_BEAUTIFY_FLAG" val="#wm#"/>
-</p:tagLst>
-</file>
-
-<file path=ppt/tags/tag37.xml><?xml version="1.0" encoding="utf-8"?>
-<p:tagLst xmlns:p="http://schemas.openxmlformats.org/presentationml/2006/main">
-  <p:tag name="KSO_WM_UNIT_HIGHLIGHT" val="0"/>
-  <p:tag name="KSO_WM_UNIT_COMPATIBLE" val="0"/>
-  <p:tag name="KSO_WM_UNIT_DIAGRAM_ISNUMVISUAL" val="0"/>
-  <p:tag name="KSO_WM_UNIT_DIAGRAM_ISREFERUNIT" val="0"/>
-  <p:tag name="KSO_WM_UNIT_ID" val="_8**"/>
-  <p:tag name="KSO_WM_UNIT_LAYERLEVEL" val="1"/>
-  <p:tag name="KSO_WM_TAG_VERSION" val="1.0"/>
-  <p:tag name="KSO_WM_BEAUTIFY_FLAG" val="#wm#"/>
-</p:tagLst>
-</file>
-
-<file path=ppt/tags/tag38.xml><?xml version="1.0" encoding="utf-8"?>
-<p:tagLst xmlns:p="http://schemas.openxmlformats.org/presentationml/2006/main">
-  <p:tag name="KSO_WM_UNIT_HIGHLIGHT" val="0"/>
-  <p:tag name="KSO_WM_UNIT_COMPATIBLE" val="0"/>
-  <p:tag name="KSO_WM_UNIT_DIAGRAM_ISNUMVISUAL" val="0"/>
-  <p:tag name="KSO_WM_UNIT_DIAGRAM_ISREFERUNIT" val="0"/>
-  <p:tag name="KSO_WM_UNIT_ID" val="_8**"/>
-  <p:tag name="KSO_WM_UNIT_LAYERLEVEL" val="1"/>
-  <p:tag name="KSO_WM_TAG_VERSION" val="1.0"/>
-  <p:tag name="KSO_WM_BEAUTIFY_FLAG" val="#wm#"/>
-</p:tagLst>
-</file>
-
-<file path=ppt/tags/tag39.xml><?xml version="1.0" encoding="utf-8"?>
-<p:tagLst xmlns:p="http://schemas.openxmlformats.org/presentationml/2006/main">
-  <p:tag name="KSO_WM_UNIT_HIGHLIGHT" val="0"/>
-  <p:tag name="KSO_WM_UNIT_COMPATIBLE" val="0"/>
-  <p:tag name="KSO_WM_UNIT_DIAGRAM_ISNUMVISUAL" val="0"/>
-  <p:tag name="KSO_WM_UNIT_DIAGRAM_ISREFERUNIT" val="0"/>
-  <p:tag name="KSO_WM_UNIT_ID" val="_8**"/>
-  <p:tag name="KSO_WM_UNIT_LAYERLEVEL" val="1"/>
-  <p:tag name="KSO_WM_TAG_VERSION" val="1.0"/>
-  <p:tag name="KSO_WM_BEAUTIFY_FLAG" val="#wm#"/>
-</p:tagLst>
-</file>
-
-<file path=ppt/tags/tag4.xml><?xml version="1.0" encoding="utf-8"?>
-<p:tagLst xmlns:p="http://schemas.openxmlformats.org/presentationml/2006/main">
-  <p:tag name="KSO_WM_UNIT_HIGHLIGHT" val="0"/>
-  <p:tag name="KSO_WM_UNIT_COMPATIBLE" val="0"/>
-  <p:tag name="KSO_WM_UNIT_DIAGRAM_ISNUMVISUAL" val="0"/>
-  <p:tag name="KSO_WM_UNIT_DIAGRAM_ISREFERUNIT" val="0"/>
-  <p:tag name="KSO_WM_UNIT_ID" val="_1**"/>
-  <p:tag name="KSO_WM_UNIT_LAYERLEVEL" val="1"/>
-  <p:tag name="KSO_WM_TAG_VERSION" val="1.0"/>
-  <p:tag name="KSO_WM_BEAUTIFY_FLAG" val="#wm#"/>
-</p:tagLst>
-</file>
-
-<file path=ppt/tags/tag40.xml><?xml version="1.0" encoding="utf-8"?>
-<p:tagLst xmlns:p="http://schemas.openxmlformats.org/presentationml/2006/main">
-  <p:tag name="KSO_WM_UNIT_HIGHLIGHT" val="0"/>
-  <p:tag name="KSO_WM_UNIT_COMPATIBLE" val="0"/>
-  <p:tag name="KSO_WM_UNIT_DIAGRAM_ISNUMVISUAL" val="0"/>
-  <p:tag name="KSO_WM_UNIT_DIAGRAM_ISREFERUNIT" val="0"/>
-  <p:tag name="KSO_WM_UNIT_ID" val="_8**"/>
-  <p:tag name="KSO_WM_UNIT_LAYERLEVEL" val="1"/>
-  <p:tag name="KSO_WM_TAG_VERSION" val="1.0"/>
-  <p:tag name="KSO_WM_BEAUTIFY_FLAG" val="#wm#"/>
-</p:tagLst>
-</file>
-
-<file path=ppt/tags/tag41.xml><?xml version="1.0" encoding="utf-8"?>
-<p:tagLst xmlns:p="http://schemas.openxmlformats.org/presentationml/2006/main">
-  <p:tag name="KSO_WM_UNIT_HIGHLIGHT" val="0"/>
-  <p:tag name="KSO_WM_UNIT_COMPATIBLE" val="0"/>
-  <p:tag name="KSO_WM_UNIT_DIAGRAM_ISNUMVISUAL" val="0"/>
-  <p:tag name="KSO_WM_UNIT_DIAGRAM_ISREFERUNIT" val="0"/>
-  <p:tag name="KSO_WM_UNIT_ID" val="_8**"/>
-  <p:tag name="KSO_WM_UNIT_LAYERLEVEL" val="1"/>
-  <p:tag name="KSO_WM_TAG_VERSION" val="1.0"/>
-  <p:tag name="KSO_WM_BEAUTIFY_FLAG" val="#wm#"/>
-</p:tagLst>
-</file>
-
-<file path=ppt/tags/tag42.xml><?xml version="1.0" encoding="utf-8"?>
-<p:tagLst xmlns:p="http://schemas.openxmlformats.org/presentationml/2006/main">
-  <p:tag name="KSO_WM_UNIT_HIGHLIGHT" val="0"/>
-  <p:tag name="KSO_WM_UNIT_COMPATIBLE" val="0"/>
-  <p:tag name="KSO_WM_UNIT_DIAGRAM_ISNUMVISUAL" val="0"/>
-  <p:tag name="KSO_WM_UNIT_DIAGRAM_ISREFERUNIT" val="0"/>
-  <p:tag name="KSO_WM_UNIT_ID" val="_8**"/>
-  <p:tag name="KSO_WM_UNIT_LAYERLEVEL" val="1"/>
-  <p:tag name="KSO_WM_TAG_VERSION" val="1.0"/>
-  <p:tag name="KSO_WM_BEAUTIFY_FLAG" val="#wm#"/>
-</p:tagLst>
-</file>
-
-<file path=ppt/tags/tag43.xml><?xml version="1.0" encoding="utf-8"?>
-<p:tagLst xmlns:p="http://schemas.openxmlformats.org/presentationml/2006/main">
-  <p:tag name="KSO_WM_UNIT_HIGHLIGHT" val="0"/>
-  <p:tag name="KSO_WM_UNIT_COMPATIBLE" val="0"/>
-  <p:tag name="KSO_WM_UNIT_DIAGRAM_ISNUMVISUAL" val="0"/>
-  <p:tag name="KSO_WM_UNIT_DIAGRAM_ISREFERUNIT" val="0"/>
-  <p:tag name="KSO_WM_UNIT_ID" val="_9**"/>
-  <p:tag name="KSO_WM_UNIT_LAYERLEVEL" val="1"/>
-  <p:tag name="KSO_WM_TAG_VERSION" val="1.0"/>
-  <p:tag name="KSO_WM_BEAUTIFY_FLAG" val="#wm#"/>
-</p:tagLst>
-</file>
-
-<file path=ppt/tags/tag44.xml><?xml version="1.0" encoding="utf-8"?>
-<p:tagLst xmlns:p="http://schemas.openxmlformats.org/presentationml/2006/main">
-  <p:tag name="KSO_WM_UNIT_HIGHLIGHT" val="0"/>
-  <p:tag name="KSO_WM_UNIT_COMPATIBLE" val="0"/>
-  <p:tag name="KSO_WM_UNIT_DIAGRAM_ISNUMVISUAL" val="0"/>
-  <p:tag name="KSO_WM_UNIT_DIAGRAM_ISREFERUNIT" val="0"/>
-  <p:tag name="KSO_WM_UNIT_ID" val="_9**"/>
-  <p:tag name="KSO_WM_UNIT_LAYERLEVEL" val="1"/>
-  <p:tag name="KSO_WM_TAG_VERSION" val="1.0"/>
-  <p:tag name="KSO_WM_BEAUTIFY_FLAG" val="#wm#"/>
-</p:tagLst>
-</file>
-
-<file path=ppt/tags/tag45.xml><?xml version="1.0" encoding="utf-8"?>
-<p:tagLst xmlns:p="http://schemas.openxmlformats.org/presentationml/2006/main">
-  <p:tag name="KSO_WM_UNIT_HIGHLIGHT" val="0"/>
-  <p:tag name="KSO_WM_UNIT_COMPATIBLE" val="0"/>
-  <p:tag name="KSO_WM_UNIT_DIAGRAM_ISNUMVISUAL" val="0"/>
-  <p:tag name="KSO_WM_UNIT_DIAGRAM_ISREFERUNIT" val="0"/>
-  <p:tag name="KSO_WM_UNIT_ID" val="_9**"/>
-  <p:tag name="KSO_WM_UNIT_LAYERLEVEL" val="1"/>
-  <p:tag name="KSO_WM_TAG_VERSION" val="1.0"/>
-  <p:tag name="KSO_WM_BEAUTIFY_FLAG" val="#wm#"/>
-</p:tagLst>
-</file>
-
-<file path=ppt/tags/tag46.xml><?xml version="1.0" encoding="utf-8"?>
-<p:tagLst xmlns:p="http://schemas.openxmlformats.org/presentationml/2006/main">
-  <p:tag name="KSO_WM_UNIT_HIGHLIGHT" val="0"/>
-  <p:tag name="KSO_WM_UNIT_COMPATIBLE" val="0"/>
-  <p:tag name="KSO_WM_UNIT_DIAGRAM_ISNUMVISUAL" val="0"/>
-  <p:tag name="KSO_WM_UNIT_DIAGRAM_ISREFERUNIT" val="0"/>
-  <p:tag name="KSO_WM_UNIT_ID" val="_9**"/>
-  <p:tag name="KSO_WM_UNIT_LAYERLEVEL" val="1"/>
-  <p:tag name="KSO_WM_TAG_VERSION" val="1.0"/>
-  <p:tag name="KSO_WM_BEAUTIFY_FLAG" val="#wm#"/>
-</p:tagLst>
-</file>
-
-<file path=ppt/tags/tag47.xml><?xml version="1.0" encoding="utf-8"?>
-<p:tagLst xmlns:p="http://schemas.openxmlformats.org/presentationml/2006/main">
-  <p:tag name="KSO_WM_UNIT_HIGHLIGHT" val="0"/>
-  <p:tag name="KSO_WM_UNIT_COMPATIBLE" val="0"/>
-  <p:tag name="KSO_WM_UNIT_DIAGRAM_ISNUMVISUAL" val="0"/>
-  <p:tag name="KSO_WM_UNIT_DIAGRAM_ISREFERUNIT" val="0"/>
-  <p:tag name="KSO_WM_UNIT_ID" val="_9**"/>
-  <p:tag name="KSO_WM_UNIT_LAYERLEVEL" val="1"/>
-  <p:tag name="KSO_WM_TAG_VERSION" val="1.0"/>
-  <p:tag name="KSO_WM_BEAUTIFY_FLAG" val="#wm#"/>
-</p:tagLst>
-</file>
-
-<file path=ppt/tags/tag48.xml><?xml version="1.0" encoding="utf-8"?>
-<p:tagLst xmlns:p="http://schemas.openxmlformats.org/presentationml/2006/main">
-  <p:tag name="KSO_WM_UNIT_HIGHLIGHT" val="0"/>
-  <p:tag name="KSO_WM_UNIT_COMPATIBLE" val="0"/>
-  <p:tag name="KSO_WM_UNIT_DIAGRAM_ISNUMVISUAL" val="0"/>
-  <p:tag name="KSO_WM_UNIT_DIAGRAM_ISREFERUNIT" val="0"/>
-  <p:tag name="KSO_WM_UNIT_ID" val="_10**"/>
-  <p:tag name="KSO_WM_UNIT_LAYERLEVEL" val="1"/>
-  <p:tag name="KSO_WM_TAG_VERSION" val="1.0"/>
-  <p:tag name="KSO_WM_BEAUTIFY_FLAG" val="#wm#"/>
-</p:tagLst>
-</file>
-
-<file path=ppt/tags/tag49.xml><?xml version="1.0" encoding="utf-8"?>
-<p:tagLst xmlns:p="http://schemas.openxmlformats.org/presentationml/2006/main">
-  <p:tag name="KSO_WM_UNIT_HIGHLIGHT" val="0"/>
-  <p:tag name="KSO_WM_UNIT_COMPATIBLE" val="0"/>
-  <p:tag name="KSO_WM_UNIT_DIAGRAM_ISNUMVISUAL" val="0"/>
-  <p:tag name="KSO_WM_UNIT_DIAGRAM_ISREFERUNIT" val="0"/>
-  <p:tag name="KSO_WM_UNIT_ID" val="_10**"/>
-  <p:tag name="KSO_WM_UNIT_LAYERLEVEL" val="1"/>
-  <p:tag name="KSO_WM_TAG_VERSION" val="1.0"/>
-  <p:tag name="KSO_WM_BEAUTIFY_FLAG" val="#wm#"/>
-</p:tagLst>
-</file>
-
-<file path=ppt/tags/tag5.xml><?xml version="1.0" encoding="utf-8"?>
-<p:tagLst xmlns:p="http://schemas.openxmlformats.org/presentationml/2006/main">
-  <p:tag name="KSO_WM_UNIT_HIGHLIGHT" val="0"/>
-  <p:tag name="KSO_WM_UNIT_COMPATIBLE" val="0"/>
-  <p:tag name="KSO_WM_UNIT_DIAGRAM_ISNUMVISUAL" val="0"/>
-  <p:tag name="KSO_WM_UNIT_DIAGRAM_ISREFERUNIT" val="0"/>
-  <p:tag name="KSO_WM_UNIT_ID" val="_1**"/>
-  <p:tag name="KSO_WM_UNIT_LAYERLEVEL" val="1"/>
-  <p:tag name="KSO_WM_TAG_VERSION" val="1.0"/>
-  <p:tag name="KSO_WM_BEAUTIFY_FLAG" val="#wm#"/>
-</p:tagLst>
-</file>
-
-<file path=ppt/tags/tag50.xml><?xml version="1.0" encoding="utf-8"?>
-<p:tagLst xmlns:p="http://schemas.openxmlformats.org/presentationml/2006/main">
-  <p:tag name="KSO_WM_UNIT_HIGHLIGHT" val="0"/>
-  <p:tag name="KSO_WM_UNIT_COMPATIBLE" val="0"/>
-  <p:tag name="KSO_WM_UNIT_DIAGRAM_ISNUMVISUAL" val="0"/>
-  <p:tag name="KSO_WM_UNIT_DIAGRAM_ISREFERUNIT" val="0"/>
-  <p:tag name="KSO_WM_UNIT_ID" val="_10**"/>
-  <p:tag name="KSO_WM_UNIT_LAYERLEVEL" val="1"/>
-  <p:tag name="KSO_WM_TAG_VERSION" val="1.0"/>
-  <p:tag name="KSO_WM_BEAUTIFY_FLAG" val="#wm#"/>
-</p:tagLst>
-</file>
-
-<file path=ppt/tags/tag51.xml><?xml version="1.0" encoding="utf-8"?>
-<p:tagLst xmlns:p="http://schemas.openxmlformats.org/presentationml/2006/main">
-  <p:tag name="KSO_WM_UNIT_HIGHLIGHT" val="0"/>
-  <p:tag name="KSO_WM_UNIT_COMPATIBLE" val="0"/>
-  <p:tag name="KSO_WM_UNIT_DIAGRAM_ISNUMVISUAL" val="0"/>
-  <p:tag name="KSO_WM_UNIT_DIAGRAM_ISREFERUNIT" val="0"/>
-  <p:tag name="KSO_WM_UNIT_ID" val="_10**"/>
-  <p:tag name="KSO_WM_UNIT_LAYERLEVEL" val="1"/>
-  <p:tag name="KSO_WM_TAG_VERSION" val="1.0"/>
-  <p:tag name="KSO_WM_BEAUTIFY_FLAG" val="#wm#"/>
-</p:tagLst>
-</file>
-
-<file path=ppt/tags/tag52.xml><?xml version="1.0" encoding="utf-8"?>
-<p:tagLst xmlns:p="http://schemas.openxmlformats.org/presentationml/2006/main">
-  <p:tag name="KSO_WM_UNIT_HIGHLIGHT" val="0"/>
-  <p:tag name="KSO_WM_UNIT_COMPATIBLE" val="0"/>
-  <p:tag name="KSO_WM_UNIT_DIAGRAM_ISNUMVISUAL" val="0"/>
-  <p:tag name="KSO_WM_UNIT_DIAGRAM_ISREFERUNIT" val="0"/>
-  <p:tag name="KSO_WM_UNIT_ID" val="_11**"/>
-  <p:tag name="KSO_WM_UNIT_LAYERLEVEL" val="1"/>
-  <p:tag name="KSO_WM_TAG_VERSION" val="1.0"/>
-  <p:tag name="KSO_WM_BEAUTIFY_FLAG" val="#wm#"/>
-</p:tagLst>
-</file>
-
-<file path=ppt/tags/tag53.xml><?xml version="1.0" encoding="utf-8"?>
-<p:tagLst xmlns:p="http://schemas.openxmlformats.org/presentationml/2006/main">
-  <p:tag name="KSO_WM_UNIT_HIGHLIGHT" val="0"/>
-  <p:tag name="KSO_WM_UNIT_COMPATIBLE" val="0"/>
-  <p:tag name="KSO_WM_UNIT_DIAGRAM_ISNUMVISUAL" val="0"/>
-  <p:tag name="KSO_WM_UNIT_DIAGRAM_ISREFERUNIT" val="0"/>
-  <p:tag name="KSO_WM_UNIT_ID" val="_11**"/>
-  <p:tag name="KSO_WM_UNIT_LAYERLEVEL" val="1"/>
-  <p:tag name="KSO_WM_TAG_VERSION" val="1.0"/>
-  <p:tag name="KSO_WM_BEAUTIFY_FLAG" val="#wm#"/>
-</p:tagLst>
-</file>
-
-<file path=ppt/tags/tag54.xml><?xml version="1.0" encoding="utf-8"?>
-<p:tagLst xmlns:p="http://schemas.openxmlformats.org/presentationml/2006/main">
-  <p:tag name="KSO_WM_UNIT_HIGHLIGHT" val="0"/>
-  <p:tag name="KSO_WM_UNIT_COMPATIBLE" val="0"/>
-  <p:tag name="KSO_WM_UNIT_DIAGRAM_ISNUMVISUAL" val="0"/>
-  <p:tag name="KSO_WM_UNIT_DIAGRAM_ISREFERUNIT" val="0"/>
-  <p:tag name="KSO_WM_UNIT_ID" val="_11**"/>
-  <p:tag name="KSO_WM_UNIT_LAYERLEVEL" val="1"/>
-  <p:tag name="KSO_WM_TAG_VERSION" val="1.0"/>
-  <p:tag name="KSO_WM_BEAUTIFY_FLAG" val="#wm#"/>
-</p:tagLst>
-</file>
-
-<file path=ppt/tags/tag55.xml><?xml version="1.0" encoding="utf-8"?>
-<p:tagLst xmlns:p="http://schemas.openxmlformats.org/presentationml/2006/main">
-  <p:tag name="KSO_WM_UNIT_HIGHLIGHT" val="0"/>
-  <p:tag name="KSO_WM_UNIT_COMPATIBLE" val="0"/>
-  <p:tag name="KSO_WM_UNIT_DIAGRAM_ISNUMVISUAL" val="0"/>
-  <p:tag name="KSO_WM_UNIT_DIAGRAM_ISREFERUNIT" val="0"/>
-  <p:tag name="KSO_WM_UNIT_ID" val="_11**"/>
-  <p:tag name="KSO_WM_UNIT_LAYERLEVEL" val="1"/>
-  <p:tag name="KSO_WM_TAG_VERSION" val="1.0"/>
-  <p:tag name="KSO_WM_BEAUTIFY_FLAG" val="#wm#"/>
-</p:tagLst>
-</file>
-
-<file path=ppt/tags/tag56.xml><?xml version="1.0" encoding="utf-8"?>
-<p:tagLst xmlns:p="http://schemas.openxmlformats.org/presentationml/2006/main">
-  <p:tag name="KSO_WM_UNIT_HIGHLIGHT" val="0"/>
-  <p:tag name="KSO_WM_UNIT_COMPATIBLE" val="0"/>
-  <p:tag name="KSO_WM_UNIT_DIAGRAM_ISNUMVISUAL" val="0"/>
-  <p:tag name="KSO_WM_UNIT_DIAGRAM_ISREFERUNIT" val="0"/>
-  <p:tag name="KSO_WM_UNIT_ID" val="_11**"/>
-  <p:tag name="KSO_WM_UNIT_LAYERLEVEL" val="1"/>
-  <p:tag name="KSO_WM_TAG_VERSION" val="1.0"/>
-  <p:tag name="KSO_WM_BEAUTIFY_FLAG" val="#wm#"/>
-</p:tagLst>
-</file>
-
-<file path=ppt/tags/tag57.xml><?xml version="1.0" encoding="utf-8"?>
-<p:tagLst xmlns:p="http://schemas.openxmlformats.org/presentationml/2006/main">
+<p:tagLst xmlns:a="http://schemas.openxmlformats.org/drawingml/2006/main" xmlns:r="http://schemas.openxmlformats.org/officeDocument/2006/relationships" xmlns:p="http://schemas.openxmlformats.org/presentationml/2006/main">
   <p:tag name="KSO_WM_UNIT_HIGHLIGHT" val="0"/>
   <p:tag name="KSO_WM_UNIT_COMPATIBLE" val="0"/>
   <p:tag name="KSO_WM_UNIT_DIAGRAM_ISNUMVISUAL" val="0"/>
@@ -6430,8 +5978,138 @@
 </p:tagLst>
 </file>
 
-<file path=ppt/tags/tag58.xml><?xml version="1.0" encoding="utf-8"?>
-<p:tagLst xmlns:p="http://schemas.openxmlformats.org/presentationml/2006/main">
+<file path=ppt/tags/tag20.xml><?xml version="1.0" encoding="utf-8"?>
+<p:tagLst xmlns:a="http://schemas.openxmlformats.org/drawingml/2006/main" xmlns:r="http://schemas.openxmlformats.org/officeDocument/2006/relationships" xmlns:p="http://schemas.openxmlformats.org/presentationml/2006/main">
+  <p:tag name="KSO_WM_UNIT_HIGHLIGHT" val="0"/>
+  <p:tag name="KSO_WM_UNIT_COMPATIBLE" val="0"/>
+  <p:tag name="KSO_WM_UNIT_DIAGRAM_ISNUMVISUAL" val="0"/>
+  <p:tag name="KSO_WM_UNIT_DIAGRAM_ISREFERUNIT" val="0"/>
+  <p:tag name="KSO_WM_UNIT_ID" val="_3**"/>
+  <p:tag name="KSO_WM_UNIT_LAYERLEVEL" val="1"/>
+  <p:tag name="KSO_WM_TAG_VERSION" val="1.0"/>
+  <p:tag name="KSO_WM_BEAUTIFY_FLAG" val="#wm#"/>
+</p:tagLst>
+</file>
+
+<file path=ppt/tags/tag21.xml><?xml version="1.0" encoding="utf-8"?>
+<p:tagLst xmlns:a="http://schemas.openxmlformats.org/drawingml/2006/main" xmlns:r="http://schemas.openxmlformats.org/officeDocument/2006/relationships" xmlns:p="http://schemas.openxmlformats.org/presentationml/2006/main">
+  <p:tag name="KSO_WM_UNIT_HIGHLIGHT" val="0"/>
+  <p:tag name="KSO_WM_UNIT_COMPATIBLE" val="0"/>
+  <p:tag name="KSO_WM_UNIT_DIAGRAM_ISNUMVISUAL" val="0"/>
+  <p:tag name="KSO_WM_UNIT_DIAGRAM_ISREFERUNIT" val="0"/>
+  <p:tag name="KSO_WM_UNIT_ID" val="_3**"/>
+  <p:tag name="KSO_WM_UNIT_LAYERLEVEL" val="1"/>
+  <p:tag name="KSO_WM_TAG_VERSION" val="1.0"/>
+  <p:tag name="KSO_WM_BEAUTIFY_FLAG" val="#wm#"/>
+</p:tagLst>
+</file>
+
+<file path=ppt/tags/tag22.xml><?xml version="1.0" encoding="utf-8"?>
+<p:tagLst xmlns:a="http://schemas.openxmlformats.org/drawingml/2006/main" xmlns:r="http://schemas.openxmlformats.org/officeDocument/2006/relationships" xmlns:p="http://schemas.openxmlformats.org/presentationml/2006/main">
+  <p:tag name="KSO_WM_UNIT_HIGHLIGHT" val="0"/>
+  <p:tag name="KSO_WM_UNIT_COMPATIBLE" val="0"/>
+  <p:tag name="KSO_WM_UNIT_DIAGRAM_ISNUMVISUAL" val="0"/>
+  <p:tag name="KSO_WM_UNIT_DIAGRAM_ISREFERUNIT" val="0"/>
+  <p:tag name="KSO_WM_UNIT_ID" val="_4**"/>
+  <p:tag name="KSO_WM_UNIT_LAYERLEVEL" val="1"/>
+  <p:tag name="KSO_WM_TAG_VERSION" val="1.0"/>
+  <p:tag name="KSO_WM_BEAUTIFY_FLAG" val="#wm#"/>
+</p:tagLst>
+</file>
+
+<file path=ppt/tags/tag23.xml><?xml version="1.0" encoding="utf-8"?>
+<p:tagLst xmlns:a="http://schemas.openxmlformats.org/drawingml/2006/main" xmlns:r="http://schemas.openxmlformats.org/officeDocument/2006/relationships" xmlns:p="http://schemas.openxmlformats.org/presentationml/2006/main">
+  <p:tag name="KSO_WM_UNIT_HIGHLIGHT" val="0"/>
+  <p:tag name="KSO_WM_UNIT_COMPATIBLE" val="0"/>
+  <p:tag name="KSO_WM_UNIT_DIAGRAM_ISNUMVISUAL" val="0"/>
+  <p:tag name="KSO_WM_UNIT_DIAGRAM_ISREFERUNIT" val="0"/>
+  <p:tag name="KSO_WM_UNIT_ID" val="_4**"/>
+  <p:tag name="KSO_WM_UNIT_LAYERLEVEL" val="1"/>
+  <p:tag name="KSO_WM_TAG_VERSION" val="1.0"/>
+  <p:tag name="KSO_WM_BEAUTIFY_FLAG" val="#wm#"/>
+</p:tagLst>
+</file>
+
+<file path=ppt/tags/tag24.xml><?xml version="1.0" encoding="utf-8"?>
+<p:tagLst xmlns:a="http://schemas.openxmlformats.org/drawingml/2006/main" xmlns:r="http://schemas.openxmlformats.org/officeDocument/2006/relationships" xmlns:p="http://schemas.openxmlformats.org/presentationml/2006/main">
+  <p:tag name="KSO_WM_UNIT_HIGHLIGHT" val="0"/>
+  <p:tag name="KSO_WM_UNIT_COMPATIBLE" val="0"/>
+  <p:tag name="KSO_WM_UNIT_DIAGRAM_ISNUMVISUAL" val="0"/>
+  <p:tag name="KSO_WM_UNIT_DIAGRAM_ISREFERUNIT" val="0"/>
+  <p:tag name="KSO_WM_UNIT_ID" val="_4**"/>
+  <p:tag name="KSO_WM_UNIT_LAYERLEVEL" val="1"/>
+  <p:tag name="KSO_WM_TAG_VERSION" val="1.0"/>
+  <p:tag name="KSO_WM_BEAUTIFY_FLAG" val="#wm#"/>
+</p:tagLst>
+</file>
+
+<file path=ppt/tags/tag25.xml><?xml version="1.0" encoding="utf-8"?>
+<p:tagLst xmlns:a="http://schemas.openxmlformats.org/drawingml/2006/main" xmlns:r="http://schemas.openxmlformats.org/officeDocument/2006/relationships" xmlns:p="http://schemas.openxmlformats.org/presentationml/2006/main">
+  <p:tag name="KSO_WM_UNIT_HIGHLIGHT" val="0"/>
+  <p:tag name="KSO_WM_UNIT_COMPATIBLE" val="0"/>
+  <p:tag name="KSO_WM_UNIT_DIAGRAM_ISNUMVISUAL" val="0"/>
+  <p:tag name="KSO_WM_UNIT_DIAGRAM_ISREFERUNIT" val="0"/>
+  <p:tag name="KSO_WM_UNIT_ID" val="_4**"/>
+  <p:tag name="KSO_WM_UNIT_LAYERLEVEL" val="1"/>
+  <p:tag name="KSO_WM_TAG_VERSION" val="1.0"/>
+  <p:tag name="KSO_WM_BEAUTIFY_FLAG" val="#wm#"/>
+</p:tagLst>
+</file>
+
+<file path=ppt/tags/tag26.xml><?xml version="1.0" encoding="utf-8"?>
+<p:tagLst xmlns:a="http://schemas.openxmlformats.org/drawingml/2006/main" xmlns:r="http://schemas.openxmlformats.org/officeDocument/2006/relationships" xmlns:p="http://schemas.openxmlformats.org/presentationml/2006/main">
+  <p:tag name="KSO_WM_UNIT_HIGHLIGHT" val="0"/>
+  <p:tag name="KSO_WM_UNIT_COMPATIBLE" val="0"/>
+  <p:tag name="KSO_WM_UNIT_DIAGRAM_ISNUMVISUAL" val="0"/>
+  <p:tag name="KSO_WM_UNIT_DIAGRAM_ISREFERUNIT" val="0"/>
+  <p:tag name="KSO_WM_UNIT_ID" val="_4**"/>
+  <p:tag name="KSO_WM_UNIT_LAYERLEVEL" val="1"/>
+  <p:tag name="KSO_WM_TAG_VERSION" val="1.0"/>
+  <p:tag name="KSO_WM_BEAUTIFY_FLAG" val="#wm#"/>
+</p:tagLst>
+</file>
+
+<file path=ppt/tags/tag27.xml><?xml version="1.0" encoding="utf-8"?>
+<p:tagLst xmlns:a="http://schemas.openxmlformats.org/drawingml/2006/main" xmlns:r="http://schemas.openxmlformats.org/officeDocument/2006/relationships" xmlns:p="http://schemas.openxmlformats.org/presentationml/2006/main">
+  <p:tag name="KSO_WM_UNIT_HIGHLIGHT" val="0"/>
+  <p:tag name="KSO_WM_UNIT_COMPATIBLE" val="0"/>
+  <p:tag name="KSO_WM_UNIT_DIAGRAM_ISNUMVISUAL" val="0"/>
+  <p:tag name="KSO_WM_UNIT_DIAGRAM_ISREFERUNIT" val="0"/>
+  <p:tag name="KSO_WM_UNIT_ID" val="_4**"/>
+  <p:tag name="KSO_WM_UNIT_LAYERLEVEL" val="1"/>
+  <p:tag name="KSO_WM_TAG_VERSION" val="1.0"/>
+  <p:tag name="KSO_WM_BEAUTIFY_FLAG" val="#wm#"/>
+</p:tagLst>
+</file>
+
+<file path=ppt/tags/tag28.xml><?xml version="1.0" encoding="utf-8"?>
+<p:tagLst xmlns:a="http://schemas.openxmlformats.org/drawingml/2006/main" xmlns:r="http://schemas.openxmlformats.org/officeDocument/2006/relationships" xmlns:p="http://schemas.openxmlformats.org/presentationml/2006/main">
+  <p:tag name="KSO_WM_UNIT_HIGHLIGHT" val="0"/>
+  <p:tag name="KSO_WM_UNIT_COMPATIBLE" val="0"/>
+  <p:tag name="KSO_WM_UNIT_DIAGRAM_ISNUMVISUAL" val="0"/>
+  <p:tag name="KSO_WM_UNIT_DIAGRAM_ISREFERUNIT" val="0"/>
+  <p:tag name="KSO_WM_UNIT_ID" val="_5**"/>
+  <p:tag name="KSO_WM_UNIT_LAYERLEVEL" val="1"/>
+  <p:tag name="KSO_WM_TAG_VERSION" val="1.0"/>
+  <p:tag name="KSO_WM_BEAUTIFY_FLAG" val="#wm#"/>
+</p:tagLst>
+</file>
+
+<file path=ppt/tags/tag29.xml><?xml version="1.0" encoding="utf-8"?>
+<p:tagLst xmlns:a="http://schemas.openxmlformats.org/drawingml/2006/main" xmlns:r="http://schemas.openxmlformats.org/officeDocument/2006/relationships" xmlns:p="http://schemas.openxmlformats.org/presentationml/2006/main">
+  <p:tag name="KSO_WM_UNIT_HIGHLIGHT" val="0"/>
+  <p:tag name="KSO_WM_UNIT_COMPATIBLE" val="0"/>
+  <p:tag name="KSO_WM_UNIT_DIAGRAM_ISNUMVISUAL" val="0"/>
+  <p:tag name="KSO_WM_UNIT_DIAGRAM_ISREFERUNIT" val="0"/>
+  <p:tag name="KSO_WM_UNIT_ID" val="_5**"/>
+  <p:tag name="KSO_WM_UNIT_LAYERLEVEL" val="1"/>
+  <p:tag name="KSO_WM_TAG_VERSION" val="1.0"/>
+  <p:tag name="KSO_WM_BEAUTIFY_FLAG" val="#wm#"/>
+</p:tagLst>
+</file>
+
+<file path=ppt/tags/tag3.xml><?xml version="1.0" encoding="utf-8"?>
+<p:tagLst xmlns:a="http://schemas.openxmlformats.org/drawingml/2006/main" xmlns:r="http://schemas.openxmlformats.org/officeDocument/2006/relationships" xmlns:p="http://schemas.openxmlformats.org/presentationml/2006/main">
   <p:tag name="KSO_WM_UNIT_HIGHLIGHT" val="0"/>
   <p:tag name="KSO_WM_UNIT_COMPATIBLE" val="0"/>
   <p:tag name="KSO_WM_UNIT_DIAGRAM_ISNUMVISUAL" val="0"/>
@@ -6445,8 +6123,138 @@
 </p:tagLst>
 </file>
 
-<file path=ppt/tags/tag59.xml><?xml version="1.0" encoding="utf-8"?>
-<p:tagLst xmlns:p="http://schemas.openxmlformats.org/presentationml/2006/main">
+<file path=ppt/tags/tag30.xml><?xml version="1.0" encoding="utf-8"?>
+<p:tagLst xmlns:a="http://schemas.openxmlformats.org/drawingml/2006/main" xmlns:r="http://schemas.openxmlformats.org/officeDocument/2006/relationships" xmlns:p="http://schemas.openxmlformats.org/presentationml/2006/main">
+  <p:tag name="KSO_WM_UNIT_HIGHLIGHT" val="0"/>
+  <p:tag name="KSO_WM_UNIT_COMPATIBLE" val="0"/>
+  <p:tag name="KSO_WM_UNIT_DIAGRAM_ISNUMVISUAL" val="0"/>
+  <p:tag name="KSO_WM_UNIT_DIAGRAM_ISREFERUNIT" val="0"/>
+  <p:tag name="KSO_WM_UNIT_ID" val="_5**"/>
+  <p:tag name="KSO_WM_UNIT_LAYERLEVEL" val="1"/>
+  <p:tag name="KSO_WM_TAG_VERSION" val="1.0"/>
+  <p:tag name="KSO_WM_BEAUTIFY_FLAG" val="#wm#"/>
+</p:tagLst>
+</file>
+
+<file path=ppt/tags/tag31.xml><?xml version="1.0" encoding="utf-8"?>
+<p:tagLst xmlns:a="http://schemas.openxmlformats.org/drawingml/2006/main" xmlns:r="http://schemas.openxmlformats.org/officeDocument/2006/relationships" xmlns:p="http://schemas.openxmlformats.org/presentationml/2006/main">
+  <p:tag name="KSO_WM_UNIT_HIGHLIGHT" val="0"/>
+  <p:tag name="KSO_WM_UNIT_COMPATIBLE" val="0"/>
+  <p:tag name="KSO_WM_UNIT_DIAGRAM_ISNUMVISUAL" val="0"/>
+  <p:tag name="KSO_WM_UNIT_DIAGRAM_ISREFERUNIT" val="0"/>
+  <p:tag name="KSO_WM_UNIT_ID" val="_5**"/>
+  <p:tag name="KSO_WM_UNIT_LAYERLEVEL" val="1"/>
+  <p:tag name="KSO_WM_TAG_VERSION" val="1.0"/>
+  <p:tag name="KSO_WM_BEAUTIFY_FLAG" val="#wm#"/>
+</p:tagLst>
+</file>
+
+<file path=ppt/tags/tag32.xml><?xml version="1.0" encoding="utf-8"?>
+<p:tagLst xmlns:a="http://schemas.openxmlformats.org/drawingml/2006/main" xmlns:r="http://schemas.openxmlformats.org/officeDocument/2006/relationships" xmlns:p="http://schemas.openxmlformats.org/presentationml/2006/main">
+  <p:tag name="KSO_WM_UNIT_HIGHLIGHT" val="0"/>
+  <p:tag name="KSO_WM_UNIT_COMPATIBLE" val="0"/>
+  <p:tag name="KSO_WM_UNIT_DIAGRAM_ISNUMVISUAL" val="0"/>
+  <p:tag name="KSO_WM_UNIT_DIAGRAM_ISREFERUNIT" val="0"/>
+  <p:tag name="KSO_WM_UNIT_ID" val="_5**"/>
+  <p:tag name="KSO_WM_UNIT_LAYERLEVEL" val="1"/>
+  <p:tag name="KSO_WM_TAG_VERSION" val="1.0"/>
+  <p:tag name="KSO_WM_BEAUTIFY_FLAG" val="#wm#"/>
+</p:tagLst>
+</file>
+
+<file path=ppt/tags/tag33.xml><?xml version="1.0" encoding="utf-8"?>
+<p:tagLst xmlns:a="http://schemas.openxmlformats.org/drawingml/2006/main" xmlns:r="http://schemas.openxmlformats.org/officeDocument/2006/relationships" xmlns:p="http://schemas.openxmlformats.org/presentationml/2006/main">
+  <p:tag name="KSO_WM_UNIT_HIGHLIGHT" val="0"/>
+  <p:tag name="KSO_WM_UNIT_COMPATIBLE" val="0"/>
+  <p:tag name="KSO_WM_UNIT_DIAGRAM_ISNUMVISUAL" val="0"/>
+  <p:tag name="KSO_WM_UNIT_DIAGRAM_ISREFERUNIT" val="0"/>
+  <p:tag name="KSO_WM_UNIT_ID" val="_5**"/>
+  <p:tag name="KSO_WM_UNIT_LAYERLEVEL" val="1"/>
+  <p:tag name="KSO_WM_TAG_VERSION" val="1.0"/>
+  <p:tag name="KSO_WM_BEAUTIFY_FLAG" val="#wm#"/>
+</p:tagLst>
+</file>
+
+<file path=ppt/tags/tag34.xml><?xml version="1.0" encoding="utf-8"?>
+<p:tagLst xmlns:a="http://schemas.openxmlformats.org/drawingml/2006/main" xmlns:r="http://schemas.openxmlformats.org/officeDocument/2006/relationships" xmlns:p="http://schemas.openxmlformats.org/presentationml/2006/main">
+  <p:tag name="KSO_WM_UNIT_HIGHLIGHT" val="0"/>
+  <p:tag name="KSO_WM_UNIT_COMPATIBLE" val="0"/>
+  <p:tag name="KSO_WM_UNIT_DIAGRAM_ISNUMVISUAL" val="0"/>
+  <p:tag name="KSO_WM_UNIT_DIAGRAM_ISREFERUNIT" val="0"/>
+  <p:tag name="KSO_WM_UNIT_ID" val="_5**"/>
+  <p:tag name="KSO_WM_UNIT_LAYERLEVEL" val="1"/>
+  <p:tag name="KSO_WM_TAG_VERSION" val="1.0"/>
+  <p:tag name="KSO_WM_BEAUTIFY_FLAG" val="#wm#"/>
+</p:tagLst>
+</file>
+
+<file path=ppt/tags/tag35.xml><?xml version="1.0" encoding="utf-8"?>
+<p:tagLst xmlns:a="http://schemas.openxmlformats.org/drawingml/2006/main" xmlns:r="http://schemas.openxmlformats.org/officeDocument/2006/relationships" xmlns:p="http://schemas.openxmlformats.org/presentationml/2006/main">
+  <p:tag name="KSO_WM_UNIT_HIGHLIGHT" val="0"/>
+  <p:tag name="KSO_WM_UNIT_COMPATIBLE" val="0"/>
+  <p:tag name="KSO_WM_UNIT_DIAGRAM_ISNUMVISUAL" val="0"/>
+  <p:tag name="KSO_WM_UNIT_DIAGRAM_ISREFERUNIT" val="0"/>
+  <p:tag name="KSO_WM_UNIT_ID" val="_5**"/>
+  <p:tag name="KSO_WM_UNIT_LAYERLEVEL" val="1"/>
+  <p:tag name="KSO_WM_TAG_VERSION" val="1.0"/>
+  <p:tag name="KSO_WM_BEAUTIFY_FLAG" val="#wm#"/>
+</p:tagLst>
+</file>
+
+<file path=ppt/tags/tag36.xml><?xml version="1.0" encoding="utf-8"?>
+<p:tagLst xmlns:a="http://schemas.openxmlformats.org/drawingml/2006/main" xmlns:r="http://schemas.openxmlformats.org/officeDocument/2006/relationships" xmlns:p="http://schemas.openxmlformats.org/presentationml/2006/main">
+  <p:tag name="KSO_WM_UNIT_HIGHLIGHT" val="0"/>
+  <p:tag name="KSO_WM_UNIT_COMPATIBLE" val="0"/>
+  <p:tag name="KSO_WM_UNIT_DIAGRAM_ISNUMVISUAL" val="0"/>
+  <p:tag name="KSO_WM_UNIT_DIAGRAM_ISREFERUNIT" val="0"/>
+  <p:tag name="KSO_WM_UNIT_ID" val="_6**"/>
+  <p:tag name="KSO_WM_UNIT_LAYERLEVEL" val="1"/>
+  <p:tag name="KSO_WM_TAG_VERSION" val="1.0"/>
+  <p:tag name="KSO_WM_BEAUTIFY_FLAG" val="#wm#"/>
+</p:tagLst>
+</file>
+
+<file path=ppt/tags/tag37.xml><?xml version="1.0" encoding="utf-8"?>
+<p:tagLst xmlns:a="http://schemas.openxmlformats.org/drawingml/2006/main" xmlns:r="http://schemas.openxmlformats.org/officeDocument/2006/relationships" xmlns:p="http://schemas.openxmlformats.org/presentationml/2006/main">
+  <p:tag name="KSO_WM_UNIT_HIGHLIGHT" val="0"/>
+  <p:tag name="KSO_WM_UNIT_COMPATIBLE" val="0"/>
+  <p:tag name="KSO_WM_UNIT_DIAGRAM_ISNUMVISUAL" val="0"/>
+  <p:tag name="KSO_WM_UNIT_DIAGRAM_ISREFERUNIT" val="0"/>
+  <p:tag name="KSO_WM_UNIT_ID" val="_6**"/>
+  <p:tag name="KSO_WM_UNIT_LAYERLEVEL" val="1"/>
+  <p:tag name="KSO_WM_TAG_VERSION" val="1.0"/>
+  <p:tag name="KSO_WM_BEAUTIFY_FLAG" val="#wm#"/>
+</p:tagLst>
+</file>
+
+<file path=ppt/tags/tag38.xml><?xml version="1.0" encoding="utf-8"?>
+<p:tagLst xmlns:a="http://schemas.openxmlformats.org/drawingml/2006/main" xmlns:r="http://schemas.openxmlformats.org/officeDocument/2006/relationships" xmlns:p="http://schemas.openxmlformats.org/presentationml/2006/main">
+  <p:tag name="KSO_WM_UNIT_HIGHLIGHT" val="0"/>
+  <p:tag name="KSO_WM_UNIT_COMPATIBLE" val="0"/>
+  <p:tag name="KSO_WM_UNIT_DIAGRAM_ISNUMVISUAL" val="0"/>
+  <p:tag name="KSO_WM_UNIT_DIAGRAM_ISREFERUNIT" val="0"/>
+  <p:tag name="KSO_WM_UNIT_ID" val="_6**"/>
+  <p:tag name="KSO_WM_UNIT_LAYERLEVEL" val="1"/>
+  <p:tag name="KSO_WM_TAG_VERSION" val="1.0"/>
+  <p:tag name="KSO_WM_BEAUTIFY_FLAG" val="#wm#"/>
+</p:tagLst>
+</file>
+
+<file path=ppt/tags/tag39.xml><?xml version="1.0" encoding="utf-8"?>
+<p:tagLst xmlns:a="http://schemas.openxmlformats.org/drawingml/2006/main" xmlns:r="http://schemas.openxmlformats.org/officeDocument/2006/relationships" xmlns:p="http://schemas.openxmlformats.org/presentationml/2006/main">
+  <p:tag name="KSO_WM_UNIT_HIGHLIGHT" val="0"/>
+  <p:tag name="KSO_WM_UNIT_COMPATIBLE" val="0"/>
+  <p:tag name="KSO_WM_UNIT_DIAGRAM_ISNUMVISUAL" val="0"/>
+  <p:tag name="KSO_WM_UNIT_DIAGRAM_ISREFERUNIT" val="0"/>
+  <p:tag name="KSO_WM_UNIT_ID" val="_6**"/>
+  <p:tag name="KSO_WM_UNIT_LAYERLEVEL" val="1"/>
+  <p:tag name="KSO_WM_TAG_VERSION" val="1.0"/>
+  <p:tag name="KSO_WM_BEAUTIFY_FLAG" val="#wm#"/>
+</p:tagLst>
+</file>
+
+<file path=ppt/tags/tag4.xml><?xml version="1.0" encoding="utf-8"?>
+<p:tagLst xmlns:a="http://schemas.openxmlformats.org/drawingml/2006/main" xmlns:r="http://schemas.openxmlformats.org/officeDocument/2006/relationships" xmlns:p="http://schemas.openxmlformats.org/presentationml/2006/main">
   <p:tag name="KSO_WM_UNIT_HIGHLIGHT" val="0"/>
   <p:tag name="KSO_WM_UNIT_COMPATIBLE" val="0"/>
   <p:tag name="KSO_WM_UNIT_DIAGRAM_ISNUMVISUAL" val="0"/>
@@ -6458,21 +6266,138 @@
 </p:tagLst>
 </file>
 
-<file path=ppt/tags/tag6.xml><?xml version="1.0" encoding="utf-8"?>
-<p:tagLst xmlns:p="http://schemas.openxmlformats.org/presentationml/2006/main">
+<file path=ppt/tags/tag40.xml><?xml version="1.0" encoding="utf-8"?>
+<p:tagLst xmlns:a="http://schemas.openxmlformats.org/drawingml/2006/main" xmlns:r="http://schemas.openxmlformats.org/officeDocument/2006/relationships" xmlns:p="http://schemas.openxmlformats.org/presentationml/2006/main">
   <p:tag name="KSO_WM_UNIT_HIGHLIGHT" val="0"/>
   <p:tag name="KSO_WM_UNIT_COMPATIBLE" val="0"/>
   <p:tag name="KSO_WM_UNIT_DIAGRAM_ISNUMVISUAL" val="0"/>
   <p:tag name="KSO_WM_UNIT_DIAGRAM_ISREFERUNIT" val="0"/>
-  <p:tag name="KSO_WM_UNIT_ID" val="_2**"/>
+  <p:tag name="KSO_WM_UNIT_ID" val="_7**"/>
   <p:tag name="KSO_WM_UNIT_LAYERLEVEL" val="1"/>
   <p:tag name="KSO_WM_TAG_VERSION" val="1.0"/>
   <p:tag name="KSO_WM_BEAUTIFY_FLAG" val="#wm#"/>
 </p:tagLst>
 </file>
 
-<file path=ppt/tags/tag60.xml><?xml version="1.0" encoding="utf-8"?>
-<p:tagLst xmlns:p="http://schemas.openxmlformats.org/presentationml/2006/main">
+<file path=ppt/tags/tag41.xml><?xml version="1.0" encoding="utf-8"?>
+<p:tagLst xmlns:a="http://schemas.openxmlformats.org/drawingml/2006/main" xmlns:r="http://schemas.openxmlformats.org/officeDocument/2006/relationships" xmlns:p="http://schemas.openxmlformats.org/presentationml/2006/main">
+  <p:tag name="KSO_WM_UNIT_HIGHLIGHT" val="0"/>
+  <p:tag name="KSO_WM_UNIT_COMPATIBLE" val="0"/>
+  <p:tag name="KSO_WM_UNIT_DIAGRAM_ISNUMVISUAL" val="0"/>
+  <p:tag name="KSO_WM_UNIT_DIAGRAM_ISREFERUNIT" val="0"/>
+  <p:tag name="KSO_WM_UNIT_ID" val="_7**"/>
+  <p:tag name="KSO_WM_UNIT_LAYERLEVEL" val="1"/>
+  <p:tag name="KSO_WM_TAG_VERSION" val="1.0"/>
+  <p:tag name="KSO_WM_BEAUTIFY_FLAG" val="#wm#"/>
+</p:tagLst>
+</file>
+
+<file path=ppt/tags/tag42.xml><?xml version="1.0" encoding="utf-8"?>
+<p:tagLst xmlns:a="http://schemas.openxmlformats.org/drawingml/2006/main" xmlns:r="http://schemas.openxmlformats.org/officeDocument/2006/relationships" xmlns:p="http://schemas.openxmlformats.org/presentationml/2006/main">
+  <p:tag name="KSO_WM_UNIT_HIGHLIGHT" val="0"/>
+  <p:tag name="KSO_WM_UNIT_COMPATIBLE" val="0"/>
+  <p:tag name="KSO_WM_UNIT_DIAGRAM_ISNUMVISUAL" val="0"/>
+  <p:tag name="KSO_WM_UNIT_DIAGRAM_ISREFERUNIT" val="0"/>
+  <p:tag name="KSO_WM_UNIT_ID" val="_7**"/>
+  <p:tag name="KSO_WM_UNIT_LAYERLEVEL" val="1"/>
+  <p:tag name="KSO_WM_TAG_VERSION" val="1.0"/>
+  <p:tag name="KSO_WM_BEAUTIFY_FLAG" val="#wm#"/>
+</p:tagLst>
+</file>
+
+<file path=ppt/tags/tag43.xml><?xml version="1.0" encoding="utf-8"?>
+<p:tagLst xmlns:a="http://schemas.openxmlformats.org/drawingml/2006/main" xmlns:r="http://schemas.openxmlformats.org/officeDocument/2006/relationships" xmlns:p="http://schemas.openxmlformats.org/presentationml/2006/main">
+  <p:tag name="KSO_WM_UNIT_HIGHLIGHT" val="0"/>
+  <p:tag name="KSO_WM_UNIT_COMPATIBLE" val="0"/>
+  <p:tag name="KSO_WM_UNIT_DIAGRAM_ISNUMVISUAL" val="0"/>
+  <p:tag name="KSO_WM_UNIT_DIAGRAM_ISREFERUNIT" val="0"/>
+  <p:tag name="KSO_WM_UNIT_ID" val="_8**"/>
+  <p:tag name="KSO_WM_UNIT_LAYERLEVEL" val="1"/>
+  <p:tag name="KSO_WM_TAG_VERSION" val="1.0"/>
+  <p:tag name="KSO_WM_BEAUTIFY_FLAG" val="#wm#"/>
+</p:tagLst>
+</file>
+
+<file path=ppt/tags/tag44.xml><?xml version="1.0" encoding="utf-8"?>
+<p:tagLst xmlns:a="http://schemas.openxmlformats.org/drawingml/2006/main" xmlns:r="http://schemas.openxmlformats.org/officeDocument/2006/relationships" xmlns:p="http://schemas.openxmlformats.org/presentationml/2006/main">
+  <p:tag name="KSO_WM_UNIT_HIGHLIGHT" val="0"/>
+  <p:tag name="KSO_WM_UNIT_COMPATIBLE" val="0"/>
+  <p:tag name="KSO_WM_UNIT_DIAGRAM_ISNUMVISUAL" val="0"/>
+  <p:tag name="KSO_WM_UNIT_DIAGRAM_ISREFERUNIT" val="0"/>
+  <p:tag name="KSO_WM_UNIT_ID" val="_8**"/>
+  <p:tag name="KSO_WM_UNIT_LAYERLEVEL" val="1"/>
+  <p:tag name="KSO_WM_TAG_VERSION" val="1.0"/>
+  <p:tag name="KSO_WM_BEAUTIFY_FLAG" val="#wm#"/>
+</p:tagLst>
+</file>
+
+<file path=ppt/tags/tag45.xml><?xml version="1.0" encoding="utf-8"?>
+<p:tagLst xmlns:a="http://schemas.openxmlformats.org/drawingml/2006/main" xmlns:r="http://schemas.openxmlformats.org/officeDocument/2006/relationships" xmlns:p="http://schemas.openxmlformats.org/presentationml/2006/main">
+  <p:tag name="KSO_WM_UNIT_HIGHLIGHT" val="0"/>
+  <p:tag name="KSO_WM_UNIT_COMPATIBLE" val="0"/>
+  <p:tag name="KSO_WM_UNIT_DIAGRAM_ISNUMVISUAL" val="0"/>
+  <p:tag name="KSO_WM_UNIT_DIAGRAM_ISREFERUNIT" val="0"/>
+  <p:tag name="KSO_WM_UNIT_ID" val="_8**"/>
+  <p:tag name="KSO_WM_UNIT_LAYERLEVEL" val="1"/>
+  <p:tag name="KSO_WM_TAG_VERSION" val="1.0"/>
+  <p:tag name="KSO_WM_BEAUTIFY_FLAG" val="#wm#"/>
+</p:tagLst>
+</file>
+
+<file path=ppt/tags/tag46.xml><?xml version="1.0" encoding="utf-8"?>
+<p:tagLst xmlns:a="http://schemas.openxmlformats.org/drawingml/2006/main" xmlns:r="http://schemas.openxmlformats.org/officeDocument/2006/relationships" xmlns:p="http://schemas.openxmlformats.org/presentationml/2006/main">
+  <p:tag name="KSO_WM_UNIT_HIGHLIGHT" val="0"/>
+  <p:tag name="KSO_WM_UNIT_COMPATIBLE" val="0"/>
+  <p:tag name="KSO_WM_UNIT_DIAGRAM_ISNUMVISUAL" val="0"/>
+  <p:tag name="KSO_WM_UNIT_DIAGRAM_ISREFERUNIT" val="0"/>
+  <p:tag name="KSO_WM_UNIT_ID" val="_8**"/>
+  <p:tag name="KSO_WM_UNIT_LAYERLEVEL" val="1"/>
+  <p:tag name="KSO_WM_TAG_VERSION" val="1.0"/>
+  <p:tag name="KSO_WM_BEAUTIFY_FLAG" val="#wm#"/>
+</p:tagLst>
+</file>
+
+<file path=ppt/tags/tag47.xml><?xml version="1.0" encoding="utf-8"?>
+<p:tagLst xmlns:a="http://schemas.openxmlformats.org/drawingml/2006/main" xmlns:r="http://schemas.openxmlformats.org/officeDocument/2006/relationships" xmlns:p="http://schemas.openxmlformats.org/presentationml/2006/main">
+  <p:tag name="KSO_WM_UNIT_HIGHLIGHT" val="0"/>
+  <p:tag name="KSO_WM_UNIT_COMPATIBLE" val="0"/>
+  <p:tag name="KSO_WM_UNIT_DIAGRAM_ISNUMVISUAL" val="0"/>
+  <p:tag name="KSO_WM_UNIT_DIAGRAM_ISREFERUNIT" val="0"/>
+  <p:tag name="KSO_WM_UNIT_ID" val="_8**"/>
+  <p:tag name="KSO_WM_UNIT_LAYERLEVEL" val="1"/>
+  <p:tag name="KSO_WM_TAG_VERSION" val="1.0"/>
+  <p:tag name="KSO_WM_BEAUTIFY_FLAG" val="#wm#"/>
+</p:tagLst>
+</file>
+
+<file path=ppt/tags/tag48.xml><?xml version="1.0" encoding="utf-8"?>
+<p:tagLst xmlns:a="http://schemas.openxmlformats.org/drawingml/2006/main" xmlns:r="http://schemas.openxmlformats.org/officeDocument/2006/relationships" xmlns:p="http://schemas.openxmlformats.org/presentationml/2006/main">
+  <p:tag name="KSO_WM_UNIT_HIGHLIGHT" val="0"/>
+  <p:tag name="KSO_WM_UNIT_COMPATIBLE" val="0"/>
+  <p:tag name="KSO_WM_UNIT_DIAGRAM_ISNUMVISUAL" val="0"/>
+  <p:tag name="KSO_WM_UNIT_DIAGRAM_ISREFERUNIT" val="0"/>
+  <p:tag name="KSO_WM_UNIT_ID" val="_8**"/>
+  <p:tag name="KSO_WM_UNIT_LAYERLEVEL" val="1"/>
+  <p:tag name="KSO_WM_TAG_VERSION" val="1.0"/>
+  <p:tag name="KSO_WM_BEAUTIFY_FLAG" val="#wm#"/>
+</p:tagLst>
+</file>
+
+<file path=ppt/tags/tag49.xml><?xml version="1.0" encoding="utf-8"?>
+<p:tagLst xmlns:a="http://schemas.openxmlformats.org/drawingml/2006/main" xmlns:r="http://schemas.openxmlformats.org/officeDocument/2006/relationships" xmlns:p="http://schemas.openxmlformats.org/presentationml/2006/main">
+  <p:tag name="KSO_WM_UNIT_HIGHLIGHT" val="0"/>
+  <p:tag name="KSO_WM_UNIT_COMPATIBLE" val="0"/>
+  <p:tag name="KSO_WM_UNIT_DIAGRAM_ISNUMVISUAL" val="0"/>
+  <p:tag name="KSO_WM_UNIT_DIAGRAM_ISREFERUNIT" val="0"/>
+  <p:tag name="KSO_WM_UNIT_ID" val="_9**"/>
+  <p:tag name="KSO_WM_UNIT_LAYERLEVEL" val="1"/>
+  <p:tag name="KSO_WM_TAG_VERSION" val="1.0"/>
+  <p:tag name="KSO_WM_BEAUTIFY_FLAG" val="#wm#"/>
+</p:tagLst>
+</file>
+
+<file path=ppt/tags/tag5.xml><?xml version="1.0" encoding="utf-8"?>
+<p:tagLst xmlns:a="http://schemas.openxmlformats.org/drawingml/2006/main" xmlns:r="http://schemas.openxmlformats.org/officeDocument/2006/relationships" xmlns:p="http://schemas.openxmlformats.org/presentationml/2006/main">
   <p:tag name="KSO_WM_UNIT_HIGHLIGHT" val="0"/>
   <p:tag name="KSO_WM_UNIT_COMPATIBLE" val="0"/>
   <p:tag name="KSO_WM_UNIT_DIAGRAM_ISNUMVISUAL" val="0"/>
@@ -6484,8 +6409,138 @@
 </p:tagLst>
 </file>
 
-<file path=ppt/tags/tag61.xml><?xml version="1.0" encoding="utf-8"?>
-<p:tagLst xmlns:p="http://schemas.openxmlformats.org/presentationml/2006/main">
+<file path=ppt/tags/tag50.xml><?xml version="1.0" encoding="utf-8"?>
+<p:tagLst xmlns:a="http://schemas.openxmlformats.org/drawingml/2006/main" xmlns:r="http://schemas.openxmlformats.org/officeDocument/2006/relationships" xmlns:p="http://schemas.openxmlformats.org/presentationml/2006/main">
+  <p:tag name="KSO_WM_UNIT_HIGHLIGHT" val="0"/>
+  <p:tag name="KSO_WM_UNIT_COMPATIBLE" val="0"/>
+  <p:tag name="KSO_WM_UNIT_DIAGRAM_ISNUMVISUAL" val="0"/>
+  <p:tag name="KSO_WM_UNIT_DIAGRAM_ISREFERUNIT" val="0"/>
+  <p:tag name="KSO_WM_UNIT_ID" val="_9**"/>
+  <p:tag name="KSO_WM_UNIT_LAYERLEVEL" val="1"/>
+  <p:tag name="KSO_WM_TAG_VERSION" val="1.0"/>
+  <p:tag name="KSO_WM_BEAUTIFY_FLAG" val="#wm#"/>
+</p:tagLst>
+</file>
+
+<file path=ppt/tags/tag51.xml><?xml version="1.0" encoding="utf-8"?>
+<p:tagLst xmlns:a="http://schemas.openxmlformats.org/drawingml/2006/main" xmlns:r="http://schemas.openxmlformats.org/officeDocument/2006/relationships" xmlns:p="http://schemas.openxmlformats.org/presentationml/2006/main">
+  <p:tag name="KSO_WM_UNIT_HIGHLIGHT" val="0"/>
+  <p:tag name="KSO_WM_UNIT_COMPATIBLE" val="0"/>
+  <p:tag name="KSO_WM_UNIT_DIAGRAM_ISNUMVISUAL" val="0"/>
+  <p:tag name="KSO_WM_UNIT_DIAGRAM_ISREFERUNIT" val="0"/>
+  <p:tag name="KSO_WM_UNIT_ID" val="_9**"/>
+  <p:tag name="KSO_WM_UNIT_LAYERLEVEL" val="1"/>
+  <p:tag name="KSO_WM_TAG_VERSION" val="1.0"/>
+  <p:tag name="KSO_WM_BEAUTIFY_FLAG" val="#wm#"/>
+</p:tagLst>
+</file>
+
+<file path=ppt/tags/tag52.xml><?xml version="1.0" encoding="utf-8"?>
+<p:tagLst xmlns:a="http://schemas.openxmlformats.org/drawingml/2006/main" xmlns:r="http://schemas.openxmlformats.org/officeDocument/2006/relationships" xmlns:p="http://schemas.openxmlformats.org/presentationml/2006/main">
+  <p:tag name="KSO_WM_UNIT_HIGHLIGHT" val="0"/>
+  <p:tag name="KSO_WM_UNIT_COMPATIBLE" val="0"/>
+  <p:tag name="KSO_WM_UNIT_DIAGRAM_ISNUMVISUAL" val="0"/>
+  <p:tag name="KSO_WM_UNIT_DIAGRAM_ISREFERUNIT" val="0"/>
+  <p:tag name="KSO_WM_UNIT_ID" val="_9**"/>
+  <p:tag name="KSO_WM_UNIT_LAYERLEVEL" val="1"/>
+  <p:tag name="KSO_WM_TAG_VERSION" val="1.0"/>
+  <p:tag name="KSO_WM_BEAUTIFY_FLAG" val="#wm#"/>
+</p:tagLst>
+</file>
+
+<file path=ppt/tags/tag53.xml><?xml version="1.0" encoding="utf-8"?>
+<p:tagLst xmlns:a="http://schemas.openxmlformats.org/drawingml/2006/main" xmlns:r="http://schemas.openxmlformats.org/officeDocument/2006/relationships" xmlns:p="http://schemas.openxmlformats.org/presentationml/2006/main">
+  <p:tag name="KSO_WM_UNIT_HIGHLIGHT" val="0"/>
+  <p:tag name="KSO_WM_UNIT_COMPATIBLE" val="0"/>
+  <p:tag name="KSO_WM_UNIT_DIAGRAM_ISNUMVISUAL" val="0"/>
+  <p:tag name="KSO_WM_UNIT_DIAGRAM_ISREFERUNIT" val="0"/>
+  <p:tag name="KSO_WM_UNIT_ID" val="_9**"/>
+  <p:tag name="KSO_WM_UNIT_LAYERLEVEL" val="1"/>
+  <p:tag name="KSO_WM_TAG_VERSION" val="1.0"/>
+  <p:tag name="KSO_WM_BEAUTIFY_FLAG" val="#wm#"/>
+</p:tagLst>
+</file>
+
+<file path=ppt/tags/tag54.xml><?xml version="1.0" encoding="utf-8"?>
+<p:tagLst xmlns:a="http://schemas.openxmlformats.org/drawingml/2006/main" xmlns:r="http://schemas.openxmlformats.org/officeDocument/2006/relationships" xmlns:p="http://schemas.openxmlformats.org/presentationml/2006/main">
+  <p:tag name="KSO_WM_UNIT_HIGHLIGHT" val="0"/>
+  <p:tag name="KSO_WM_UNIT_COMPATIBLE" val="0"/>
+  <p:tag name="KSO_WM_UNIT_DIAGRAM_ISNUMVISUAL" val="0"/>
+  <p:tag name="KSO_WM_UNIT_DIAGRAM_ISREFERUNIT" val="0"/>
+  <p:tag name="KSO_WM_UNIT_ID" val="_10**"/>
+  <p:tag name="KSO_WM_UNIT_LAYERLEVEL" val="1"/>
+  <p:tag name="KSO_WM_TAG_VERSION" val="1.0"/>
+  <p:tag name="KSO_WM_BEAUTIFY_FLAG" val="#wm#"/>
+</p:tagLst>
+</file>
+
+<file path=ppt/tags/tag55.xml><?xml version="1.0" encoding="utf-8"?>
+<p:tagLst xmlns:a="http://schemas.openxmlformats.org/drawingml/2006/main" xmlns:r="http://schemas.openxmlformats.org/officeDocument/2006/relationships" xmlns:p="http://schemas.openxmlformats.org/presentationml/2006/main">
+  <p:tag name="KSO_WM_UNIT_HIGHLIGHT" val="0"/>
+  <p:tag name="KSO_WM_UNIT_COMPATIBLE" val="0"/>
+  <p:tag name="KSO_WM_UNIT_DIAGRAM_ISNUMVISUAL" val="0"/>
+  <p:tag name="KSO_WM_UNIT_DIAGRAM_ISREFERUNIT" val="0"/>
+  <p:tag name="KSO_WM_UNIT_ID" val="_10**"/>
+  <p:tag name="KSO_WM_UNIT_LAYERLEVEL" val="1"/>
+  <p:tag name="KSO_WM_TAG_VERSION" val="1.0"/>
+  <p:tag name="KSO_WM_BEAUTIFY_FLAG" val="#wm#"/>
+</p:tagLst>
+</file>
+
+<file path=ppt/tags/tag56.xml><?xml version="1.0" encoding="utf-8"?>
+<p:tagLst xmlns:a="http://schemas.openxmlformats.org/drawingml/2006/main" xmlns:r="http://schemas.openxmlformats.org/officeDocument/2006/relationships" xmlns:p="http://schemas.openxmlformats.org/presentationml/2006/main">
+  <p:tag name="KSO_WM_UNIT_HIGHLIGHT" val="0"/>
+  <p:tag name="KSO_WM_UNIT_COMPATIBLE" val="0"/>
+  <p:tag name="KSO_WM_UNIT_DIAGRAM_ISNUMVISUAL" val="0"/>
+  <p:tag name="KSO_WM_UNIT_DIAGRAM_ISREFERUNIT" val="0"/>
+  <p:tag name="KSO_WM_UNIT_ID" val="_10**"/>
+  <p:tag name="KSO_WM_UNIT_LAYERLEVEL" val="1"/>
+  <p:tag name="KSO_WM_TAG_VERSION" val="1.0"/>
+  <p:tag name="KSO_WM_BEAUTIFY_FLAG" val="#wm#"/>
+</p:tagLst>
+</file>
+
+<file path=ppt/tags/tag57.xml><?xml version="1.0" encoding="utf-8"?>
+<p:tagLst xmlns:a="http://schemas.openxmlformats.org/drawingml/2006/main" xmlns:r="http://schemas.openxmlformats.org/officeDocument/2006/relationships" xmlns:p="http://schemas.openxmlformats.org/presentationml/2006/main">
+  <p:tag name="KSO_WM_UNIT_HIGHLIGHT" val="0"/>
+  <p:tag name="KSO_WM_UNIT_COMPATIBLE" val="0"/>
+  <p:tag name="KSO_WM_UNIT_DIAGRAM_ISNUMVISUAL" val="0"/>
+  <p:tag name="KSO_WM_UNIT_DIAGRAM_ISREFERUNIT" val="0"/>
+  <p:tag name="KSO_WM_UNIT_ID" val="_10**"/>
+  <p:tag name="KSO_WM_UNIT_LAYERLEVEL" val="1"/>
+  <p:tag name="KSO_WM_TAG_VERSION" val="1.0"/>
+  <p:tag name="KSO_WM_BEAUTIFY_FLAG" val="#wm#"/>
+</p:tagLst>
+</file>
+
+<file path=ppt/tags/tag58.xml><?xml version="1.0" encoding="utf-8"?>
+<p:tagLst xmlns:a="http://schemas.openxmlformats.org/drawingml/2006/main" xmlns:r="http://schemas.openxmlformats.org/officeDocument/2006/relationships" xmlns:p="http://schemas.openxmlformats.org/presentationml/2006/main">
+  <p:tag name="KSO_WM_UNIT_HIGHLIGHT" val="0"/>
+  <p:tag name="KSO_WM_UNIT_COMPATIBLE" val="0"/>
+  <p:tag name="KSO_WM_UNIT_DIAGRAM_ISNUMVISUAL" val="0"/>
+  <p:tag name="KSO_WM_UNIT_DIAGRAM_ISREFERUNIT" val="0"/>
+  <p:tag name="KSO_WM_UNIT_ID" val="_11**"/>
+  <p:tag name="KSO_WM_UNIT_LAYERLEVEL" val="1"/>
+  <p:tag name="KSO_WM_TAG_VERSION" val="1.0"/>
+  <p:tag name="KSO_WM_BEAUTIFY_FLAG" val="#wm#"/>
+</p:tagLst>
+</file>
+
+<file path=ppt/tags/tag59.xml><?xml version="1.0" encoding="utf-8"?>
+<p:tagLst xmlns:a="http://schemas.openxmlformats.org/drawingml/2006/main" xmlns:r="http://schemas.openxmlformats.org/officeDocument/2006/relationships" xmlns:p="http://schemas.openxmlformats.org/presentationml/2006/main">
+  <p:tag name="KSO_WM_UNIT_HIGHLIGHT" val="0"/>
+  <p:tag name="KSO_WM_UNIT_COMPATIBLE" val="0"/>
+  <p:tag name="KSO_WM_UNIT_DIAGRAM_ISNUMVISUAL" val="0"/>
+  <p:tag name="KSO_WM_UNIT_DIAGRAM_ISREFERUNIT" val="0"/>
+  <p:tag name="KSO_WM_UNIT_ID" val="_11**"/>
+  <p:tag name="KSO_WM_UNIT_LAYERLEVEL" val="1"/>
+  <p:tag name="KSO_WM_TAG_VERSION" val="1.0"/>
+  <p:tag name="KSO_WM_BEAUTIFY_FLAG" val="#wm#"/>
+</p:tagLst>
+</file>
+
+<file path=ppt/tags/tag6.xml><?xml version="1.0" encoding="utf-8"?>
+<p:tagLst xmlns:a="http://schemas.openxmlformats.org/drawingml/2006/main" xmlns:r="http://schemas.openxmlformats.org/officeDocument/2006/relationships" xmlns:p="http://schemas.openxmlformats.org/presentationml/2006/main">
   <p:tag name="KSO_WM_UNIT_HIGHLIGHT" val="0"/>
   <p:tag name="KSO_WM_UNIT_COMPATIBLE" val="0"/>
   <p:tag name="KSO_WM_UNIT_DIAGRAM_ISNUMVISUAL" val="0"/>
@@ -6497,22 +6552,47 @@
 </p:tagLst>
 </file>
 
-<file path=ppt/tags/tag62.xml><?xml version="1.0" encoding="utf-8"?>
-<p:tagLst xmlns:p="http://schemas.openxmlformats.org/presentationml/2006/main">
-  <p:tag name="KSO_WM_TEMPLATE_THUMBS_INDEX" val="1、4、7、12、13、14、15、16、17、18、20、24、25、28、33、36、40、43、44"/>
-  <p:tag name="KSO_WM_TEMPLATE_SUBCATEGORY" val="19"/>
+<file path=ppt/tags/tag60.xml><?xml version="1.0" encoding="utf-8"?>
+<p:tagLst xmlns:a="http://schemas.openxmlformats.org/drawingml/2006/main" xmlns:r="http://schemas.openxmlformats.org/officeDocument/2006/relationships" xmlns:p="http://schemas.openxmlformats.org/presentationml/2006/main">
+  <p:tag name="KSO_WM_UNIT_HIGHLIGHT" val="0"/>
+  <p:tag name="KSO_WM_UNIT_COMPATIBLE" val="0"/>
+  <p:tag name="KSO_WM_UNIT_DIAGRAM_ISNUMVISUAL" val="0"/>
+  <p:tag name="KSO_WM_UNIT_DIAGRAM_ISREFERUNIT" val="0"/>
+  <p:tag name="KSO_WM_UNIT_ID" val="_11**"/>
+  <p:tag name="KSO_WM_UNIT_LAYERLEVEL" val="1"/>
   <p:tag name="KSO_WM_TAG_VERSION" val="1.0"/>
   <p:tag name="KSO_WM_BEAUTIFY_FLAG" val="#wm#"/>
-  <p:tag name="KSO_WM_TEMPLATE_CATEGORY" val="custom"/>
-  <p:tag name="KSO_WM_TEMPLATE_INDEX" val="20205081"/>
-  <p:tag name="KSO_WM_TEMPLATE_MASTER_TYPE" val="0"/>
-  <p:tag name="KSO_WM_TEMPLATE_COLOR_TYPE" val="1"/>
-  <p:tag name="KSO_WM_UNIT_SHOW_EDIT_AREA_INDICATION" val="1"/>
 </p:tagLst>
 </file>
 
+<file path=ppt/tags/tag61.xml><?xml version="1.0" encoding="utf-8"?>
+<p:tagLst xmlns:a="http://schemas.openxmlformats.org/drawingml/2006/main" xmlns:r="http://schemas.openxmlformats.org/officeDocument/2006/relationships" xmlns:p="http://schemas.openxmlformats.org/presentationml/2006/main">
+  <p:tag name="KSO_WM_UNIT_HIGHLIGHT" val="0"/>
+  <p:tag name="KSO_WM_UNIT_COMPATIBLE" val="0"/>
+  <p:tag name="KSO_WM_UNIT_DIAGRAM_ISNUMVISUAL" val="0"/>
+  <p:tag name="KSO_WM_UNIT_DIAGRAM_ISREFERUNIT" val="0"/>
+  <p:tag name="KSO_WM_UNIT_ID" val="_11**"/>
+  <p:tag name="KSO_WM_UNIT_LAYERLEVEL" val="1"/>
+  <p:tag name="KSO_WM_TAG_VERSION" val="1.0"/>
+  <p:tag name="KSO_WM_BEAUTIFY_FLAG" val="#wm#"/>
+</p:tagLst>
+</file>
+
+<file path=ppt/tags/tag62.xml><?xml version="1.0" encoding="utf-8"?>
+<p:tagLst xmlns:a="http://schemas.openxmlformats.org/drawingml/2006/main" xmlns:r="http://schemas.openxmlformats.org/officeDocument/2006/relationships" xmlns:p="http://schemas.openxmlformats.org/presentationml/2006/main">
+  <p:tag name="KSO_WM_UNIT_HIGHLIGHT" val="0"/>
+  <p:tag name="KSO_WM_UNIT_COMPATIBLE" val="0"/>
+  <p:tag name="KSO_WM_UNIT_DIAGRAM_ISNUMVISUAL" val="0"/>
+  <p:tag name="KSO_WM_UNIT_DIAGRAM_ISREFERUNIT" val="0"/>
+  <p:tag name="KSO_WM_UNIT_ID" val="_11**"/>
+  <p:tag name="KSO_WM_UNIT_LAYERLEVEL" val="1"/>
+  <p:tag name="KSO_WM_TAG_VERSION" val="1.0"/>
+  <p:tag name="KSO_WM_BEAUTIFY_FLAG" val="#wm#"/>
+</p:tagLst>
+</file>
+
 <file path=ppt/tags/tag63.xml><?xml version="1.0" encoding="utf-8"?>
-<p:tagLst xmlns:p="http://schemas.openxmlformats.org/presentationml/2006/main">
+<p:tagLst xmlns:a="http://schemas.openxmlformats.org/drawingml/2006/main" xmlns:r="http://schemas.openxmlformats.org/officeDocument/2006/relationships" xmlns:p="http://schemas.openxmlformats.org/presentationml/2006/main">
   <p:tag name="KSO_WM_SLIDE_ID" val="custom20205081_1"/>
   <p:tag name="KSO_WM_TEMPLATE_SUBCATEGORY" val="19"/>
   <p:tag name="KSO_WM_TEMPLATE_MASTER_TYPE" val="0"/>
@@ -6533,7 +6613,7 @@
 </file>
 
 <file path=ppt/tags/tag64.xml><?xml version="1.0" encoding="utf-8"?>
-<p:tagLst xmlns:p="http://schemas.openxmlformats.org/presentationml/2006/main">
+<p:tagLst xmlns:a="http://schemas.openxmlformats.org/drawingml/2006/main" xmlns:r="http://schemas.openxmlformats.org/officeDocument/2006/relationships" xmlns:p="http://schemas.openxmlformats.org/presentationml/2006/main">
   <p:tag name="KSO_WM_BEAUTIFY_FLAG" val="#wm#"/>
   <p:tag name="KSO_WM_TEMPLATE_CATEGORY" val="custom"/>
   <p:tag name="KSO_WM_TEMPLATE_INDEX" val="20205081"/>
@@ -6541,12 +6621,12 @@
 </file>
 
 <file path=ppt/tags/tag7.xml><?xml version="1.0" encoding="utf-8"?>
-<p:tagLst xmlns:p="http://schemas.openxmlformats.org/presentationml/2006/main">
+<p:tagLst xmlns:a="http://schemas.openxmlformats.org/drawingml/2006/main" xmlns:r="http://schemas.openxmlformats.org/officeDocument/2006/relationships" xmlns:p="http://schemas.openxmlformats.org/presentationml/2006/main">
   <p:tag name="KSO_WM_UNIT_HIGHLIGHT" val="0"/>
   <p:tag name="KSO_WM_UNIT_COMPATIBLE" val="0"/>
   <p:tag name="KSO_WM_UNIT_DIAGRAM_ISNUMVISUAL" val="0"/>
   <p:tag name="KSO_WM_UNIT_DIAGRAM_ISREFERUNIT" val="0"/>
-  <p:tag name="KSO_WM_UNIT_ID" val="_2**"/>
+  <p:tag name="KSO_WM_UNIT_ID" val="_1**"/>
   <p:tag name="KSO_WM_UNIT_LAYERLEVEL" val="1"/>
   <p:tag name="KSO_WM_TAG_VERSION" val="1.0"/>
   <p:tag name="KSO_WM_BEAUTIFY_FLAG" val="#wm#"/>
@@ -6554,12 +6634,12 @@
 </file>
 
 <file path=ppt/tags/tag8.xml><?xml version="1.0" encoding="utf-8"?>
-<p:tagLst xmlns:p="http://schemas.openxmlformats.org/presentationml/2006/main">
+<p:tagLst xmlns:a="http://schemas.openxmlformats.org/drawingml/2006/main" xmlns:r="http://schemas.openxmlformats.org/officeDocument/2006/relationships" xmlns:p="http://schemas.openxmlformats.org/presentationml/2006/main">
   <p:tag name="KSO_WM_UNIT_HIGHLIGHT" val="0"/>
   <p:tag name="KSO_WM_UNIT_COMPATIBLE" val="0"/>
   <p:tag name="KSO_WM_UNIT_DIAGRAM_ISNUMVISUAL" val="0"/>
   <p:tag name="KSO_WM_UNIT_DIAGRAM_ISREFERUNIT" val="0"/>
-  <p:tag name="KSO_WM_UNIT_ID" val="_2**"/>
+  <p:tag name="KSO_WM_UNIT_ID" val="_1**"/>
   <p:tag name="KSO_WM_UNIT_LAYERLEVEL" val="1"/>
   <p:tag name="KSO_WM_TAG_VERSION" val="1.0"/>
   <p:tag name="KSO_WM_BEAUTIFY_FLAG" val="#wm#"/>
@@ -6567,12 +6647,12 @@
 </file>
 
 <file path=ppt/tags/tag9.xml><?xml version="1.0" encoding="utf-8"?>
-<p:tagLst xmlns:p="http://schemas.openxmlformats.org/presentationml/2006/main">
+<p:tagLst xmlns:a="http://schemas.openxmlformats.org/drawingml/2006/main" xmlns:r="http://schemas.openxmlformats.org/officeDocument/2006/relationships" xmlns:p="http://schemas.openxmlformats.org/presentationml/2006/main">
   <p:tag name="KSO_WM_UNIT_HIGHLIGHT" val="0"/>
   <p:tag name="KSO_WM_UNIT_COMPATIBLE" val="0"/>
   <p:tag name="KSO_WM_UNIT_DIAGRAM_ISNUMVISUAL" val="0"/>
   <p:tag name="KSO_WM_UNIT_DIAGRAM_ISREFERUNIT" val="0"/>
-  <p:tag name="KSO_WM_UNIT_ID" val="_2**"/>
+  <p:tag name="KSO_WM_UNIT_ID" val="_1**"/>
   <p:tag name="KSO_WM_UNIT_LAYERLEVEL" val="1"/>
   <p:tag name="KSO_WM_TAG_VERSION" val="1.0"/>
   <p:tag name="KSO_WM_BEAUTIFY_FLAG" val="#wm#"/>
@@ -6762,6 +6842,8 @@
       </a:bgFillStyleLst>
     </a:fmtScheme>
   </a:themeElements>
+  <a:objectDefaults/>
+  <a:extraClrSchemeLst/>
   <a:extLst>
     <a:ext uri="{05A4C25C-085E-4340-85A3-A5531E510DB2}">
       <thm15:themeFamily xmlns:thm15="http://schemas.microsoft.com/office/thememl/2012/main" name="Office Theme" id="{62F939B6-93AF-4DB8-9C6B-D6C7DFDC589F}" vid="{4A3C46E8-61CC-4603-A589-7422A47A8E4A}"/>
@@ -6961,6 +7043,8 @@
       </a:bgFillStyleLst>
     </a:fmtScheme>
   </a:themeElements>
+  <a:objectDefaults/>
+  <a:extraClrSchemeLst/>
   <a:extLst>
     <a:ext uri="{05A4C25C-085E-4340-85A3-A5531E510DB2}">
       <thm15:themeFamily xmlns:thm15="http://schemas.microsoft.com/office/thememl/2012/main" name="Office Theme" id="{62F939B6-93AF-4DB8-9C6B-D6C7DFDC589F}" vid="{4A3C46E8-61CC-4603-A589-7422A47A8E4A}"/>
@@ -7160,6 +7244,8 @@
       </a:bgFillStyleLst>
     </a:fmtScheme>
   </a:themeElements>
+  <a:objectDefaults/>
+  <a:extraClrSchemeLst/>
   <a:extLst>
     <a:ext uri="{05A4C25C-085E-4340-85A3-A5531E510DB2}">
       <thm15:themeFamily xmlns:thm15="http://schemas.microsoft.com/office/thememl/2012/main" name="Office Theme" id="{62F939B6-93AF-4DB8-9C6B-D6C7DFDC589F}" vid="{4A3C46E8-61CC-4603-A589-7422A47A8E4A}"/>

</xml_diff>